<commit_message>
docs: embed input and output images in Beamer slides, remove date/title footer clutter, and update Overleaf package
</commit_message>
<xml_diff>
--- a/docs/Archival_Manuscript_Layout_Analysis_Presentation.pptx
+++ b/docs/Archival_Manuscript_Layout_Analysis_Presentation.pptx
@@ -3811,7 +3811,7 @@
               </a:defRPr>
             </a:pPr>
             <a:r>
-              <a:t>Dakshan Karthic  ·  Document Layout Analysis for Indic Manuscripts  ·  Slide 10 / 16</a:t>
+              <a:t>Slide 10 / 16</a:t>
             </a:r>
           </a:p>
         </p:txBody>
@@ -4339,7 +4339,7 @@
               </a:defRPr>
             </a:pPr>
             <a:r>
-              <a:t>Dakshan Karthic  ·  Document Layout Analysis for Indic Manuscripts  ·  Slide 11 / 16</a:t>
+              <a:t>Slide 11 / 16</a:t>
             </a:r>
           </a:p>
         </p:txBody>
@@ -4392,7 +4392,7 @@
               </a:defRPr>
             </a:pPr>
             <a:r>
-              <a:t>SECTION 2: METHODOLOGY</a:t>
+              <a:t>SECTION 3: VISUAL RESULTS</a:t>
             </a:r>
           </a:p>
         </p:txBody>
@@ -4427,7 +4427,7 @@
               </a:defRPr>
             </a:pPr>
             <a:r>
-              <a:t>Orthographic Scoring and Polygon Simplification</a:t>
+              <a:t>Visual Document Layout Parsing: Degraded Lithographic Folio</a:t>
             </a:r>
           </a:p>
         </p:txBody>
@@ -4462,395 +4462,62 @@
               </a:defRPr>
             </a:pPr>
             <a:r>
-              <a:t>Automated Quality Arbitration and Douglas-Peucker Reduction</a:t>
-            </a:r>
-          </a:p>
-        </p:txBody>
-      </p:sp>
-      <p:sp>
-        <p:nvSpPr>
-          <p:cNvPr id="5" name="Rounded Rectangle 4"/>
-          <p:cNvSpPr/>
-          <p:nvPr/>
-        </p:nvSpPr>
-        <p:spPr>
-          <a:xfrm>
-            <a:off x="731520" y="1554480"/>
-            <a:ext cx="5212080" cy="4663440"/>
-          </a:xfrm>
-          <a:prstGeom prst="roundRect">
-            <a:avLst/>
-          </a:prstGeom>
-          <a:solidFill>
-            <a:srgbClr val="F5F7FA"/>
-          </a:solidFill>
-          <a:ln w="15240">
-            <a:solidFill>
-              <a:srgbClr val="CBD5E1"/>
-            </a:solidFill>
-          </a:ln>
-        </p:spPr>
-        <p:style>
-          <a:lnRef idx="1">
-            <a:schemeClr val="accent1"/>
-          </a:lnRef>
-          <a:fillRef idx="3">
-            <a:schemeClr val="accent1"/>
-          </a:fillRef>
-          <a:effectRef idx="2">
-            <a:schemeClr val="accent1"/>
-          </a:effectRef>
-          <a:fontRef idx="minor">
-            <a:schemeClr val="lt1"/>
-          </a:fontRef>
-        </p:style>
-        <p:txBody>
-          <a:bodyPr rtlCol="0" anchor="ctr"/>
-          <a:lstStyle/>
-          <a:p>
-            <a:pPr algn="ctr"/>
-          </a:p>
-        </p:txBody>
-      </p:sp>
-      <p:sp>
-        <p:nvSpPr>
-          <p:cNvPr id="6" name="Rounded Rectangle 5"/>
-          <p:cNvSpPr/>
-          <p:nvPr/>
-        </p:nvSpPr>
-        <p:spPr>
-          <a:xfrm>
-            <a:off x="731520" y="1554480"/>
-            <a:ext cx="5212080" cy="438912"/>
-          </a:xfrm>
-          <a:prstGeom prst="roundRect">
-            <a:avLst/>
-          </a:prstGeom>
-          <a:solidFill>
-            <a:srgbClr val="0000DC"/>
-          </a:solidFill>
-          <a:ln>
-            <a:noFill/>
-          </a:ln>
-        </p:spPr>
-        <p:style>
-          <a:lnRef idx="1">
-            <a:schemeClr val="accent1"/>
-          </a:lnRef>
-          <a:fillRef idx="3">
-            <a:schemeClr val="accent1"/>
-          </a:fillRef>
-          <a:effectRef idx="2">
-            <a:schemeClr val="accent1"/>
-          </a:effectRef>
-          <a:fontRef idx="minor">
-            <a:schemeClr val="lt1"/>
-          </a:fontRef>
-        </p:style>
-        <p:txBody>
-          <a:bodyPr rtlCol="0" anchor="ctr"/>
-          <a:lstStyle/>
-          <a:p>
-            <a:pPr algn="ctr">
-              <a:defRPr sz="1300" b="1">
-                <a:solidFill>
-                  <a:srgbClr val="FFFFFF"/>
-                </a:solidFill>
-              </a:defRPr>
-            </a:pPr>
-            <a:r>
-              <a:t>  1. Devanagari Orthographic Scoring Metric</a:t>
-            </a:r>
-          </a:p>
-        </p:txBody>
-      </p:sp>
+              <a:t>Side-by-Side Verification of Segmented Bounding Polygons</a:t>
+            </a:r>
+          </a:p>
+        </p:txBody>
+      </p:sp>
+      <p:pic>
+        <p:nvPicPr>
+          <p:cNvPr id="5" name="Picture 4" descr="input_folio.jpg"/>
+          <p:cNvPicPr>
+            <a:picLocks noChangeAspect="1"/>
+          </p:cNvPicPr>
+          <p:nvPr/>
+        </p:nvPicPr>
+        <p:blipFill>
+          <a:blip r:embed="rId2"/>
+          <a:stretch>
+            <a:fillRect/>
+          </a:stretch>
+        </p:blipFill>
+        <p:spPr>
+          <a:xfrm>
+            <a:off x="731520" y="1645920"/>
+            <a:ext cx="5120640" cy="4389120"/>
+          </a:xfrm>
+          <a:prstGeom prst="rect">
+            <a:avLst/>
+          </a:prstGeom>
+        </p:spPr>
+      </p:pic>
+      <p:pic>
+        <p:nvPicPr>
+          <p:cNvPr id="6" name="Picture 5" descr="output_annotation.jpg"/>
+          <p:cNvPicPr>
+            <a:picLocks noChangeAspect="1"/>
+          </p:cNvPicPr>
+          <p:nvPr/>
+        </p:nvPicPr>
+        <p:blipFill>
+          <a:blip r:embed="rId3"/>
+          <a:stretch>
+            <a:fillRect/>
+          </a:stretch>
+        </p:blipFill>
+        <p:spPr>
+          <a:xfrm>
+            <a:off x="6217920" y="1645920"/>
+            <a:ext cx="5120640" cy="4389120"/>
+          </a:xfrm>
+          <a:prstGeom prst="rect">
+            <a:avLst/>
+          </a:prstGeom>
+        </p:spPr>
+      </p:pic>
       <p:sp>
         <p:nvSpPr>
           <p:cNvPr id="7" name="TextBox 6"/>
-          <p:cNvSpPr txBox="1"/>
-          <p:nvPr/>
-        </p:nvSpPr>
-        <p:spPr>
-          <a:xfrm>
-            <a:off x="914400" y="2057400"/>
-            <a:ext cx="4846320" cy="4069080"/>
-          </a:xfrm>
-          <a:prstGeom prst="rect">
-            <a:avLst/>
-          </a:prstGeom>
-          <a:noFill/>
-        </p:spPr>
-        <p:txBody>
-          <a:bodyPr wrap="square">
-            <a:spAutoFit/>
-          </a:bodyPr>
-          <a:lstStyle/>
-          <a:p>
-            <a:pPr>
-              <a:spcAft>
-                <a:spcPts val="400"/>
-              </a:spcAft>
-              <a:defRPr sz="1150">
-                <a:solidFill>
-                  <a:srgbClr val="1E293B"/>
-                </a:solidFill>
-              </a:defRPr>
-            </a:pPr>
-            <a:r>
-              <a:t>• Evaluates quality of line OCR candidates autonomously:</a:t>
-            </a:r>
-          </a:p>
-          <a:p>
-            <a:pPr>
-              <a:spcAft>
-                <a:spcPts val="400"/>
-              </a:spcAft>
-              <a:defRPr sz="1150">
-                <a:solidFill>
-                  <a:srgbClr val="1E293B"/>
-                </a:solidFill>
-              </a:defRPr>
-            </a:pPr>
-            <a:r>
-              <a:t>• +5 for Devanagari Unicode block [0x0900, 0x097F].</a:t>
-            </a:r>
-          </a:p>
-          <a:p>
-            <a:pPr>
-              <a:spcAft>
-                <a:spcPts val="400"/>
-              </a:spcAft>
-              <a:defRPr sz="1150">
-                <a:solidFill>
-                  <a:srgbClr val="1E293B"/>
-                </a:solidFill>
-              </a:defRPr>
-            </a:pPr>
-            <a:r>
-              <a:t>• +1 for Indic punctuation (Danda, Double Danda).</a:t>
-            </a:r>
-          </a:p>
-          <a:p>
-            <a:pPr>
-              <a:spcAft>
-                <a:spcPts val="400"/>
-              </a:spcAft>
-              <a:defRPr sz="1150">
-                <a:solidFill>
-                  <a:srgbClr val="1E293B"/>
-                </a:solidFill>
-              </a:defRPr>
-            </a:pPr>
-            <a:r>
-              <a:t>• -12 penalty for Latin/ASCII noise symbols.</a:t>
-            </a:r>
-          </a:p>
-          <a:p>
-            <a:br/>
-            <a:pPr>
-              <a:spcAft>
-                <a:spcPts val="400"/>
-              </a:spcAft>
-              <a:defRPr sz="1150" b="1">
-                <a:solidFill>
-                  <a:srgbClr val="0000DC"/>
-                </a:solidFill>
-              </a:defRPr>
-            </a:pPr>
-            <a:r>
-              <a:t>S_Dev(T) = Sum_{c in T} omega(c) - 8 Sum_{n in N} count(n, T) + 2 min(|words(T)|, 12)</a:t>
-            </a:r>
-          </a:p>
-        </p:txBody>
-      </p:sp>
-      <p:sp>
-        <p:nvSpPr>
-          <p:cNvPr id="8" name="Rounded Rectangle 7"/>
-          <p:cNvSpPr/>
-          <p:nvPr/>
-        </p:nvSpPr>
-        <p:spPr>
-          <a:xfrm>
-            <a:off x="6217920" y="1554480"/>
-            <a:ext cx="5212080" cy="4663440"/>
-          </a:xfrm>
-          <a:prstGeom prst="roundRect">
-            <a:avLst/>
-          </a:prstGeom>
-          <a:solidFill>
-            <a:srgbClr val="F5F7FA"/>
-          </a:solidFill>
-          <a:ln w="15240">
-            <a:solidFill>
-              <a:srgbClr val="CBD5E1"/>
-            </a:solidFill>
-          </a:ln>
-        </p:spPr>
-        <p:style>
-          <a:lnRef idx="1">
-            <a:schemeClr val="accent1"/>
-          </a:lnRef>
-          <a:fillRef idx="3">
-            <a:schemeClr val="accent1"/>
-          </a:fillRef>
-          <a:effectRef idx="2">
-            <a:schemeClr val="accent1"/>
-          </a:effectRef>
-          <a:fontRef idx="minor">
-            <a:schemeClr val="lt1"/>
-          </a:fontRef>
-        </p:style>
-        <p:txBody>
-          <a:bodyPr rtlCol="0" anchor="ctr"/>
-          <a:lstStyle/>
-          <a:p>
-            <a:pPr algn="ctr"/>
-          </a:p>
-        </p:txBody>
-      </p:sp>
-      <p:sp>
-        <p:nvSpPr>
-          <p:cNvPr id="9" name="Rounded Rectangle 8"/>
-          <p:cNvSpPr/>
-          <p:nvPr/>
-        </p:nvSpPr>
-        <p:spPr>
-          <a:xfrm>
-            <a:off x="6217920" y="1554480"/>
-            <a:ext cx="5212080" cy="438912"/>
-          </a:xfrm>
-          <a:prstGeom prst="roundRect">
-            <a:avLst/>
-          </a:prstGeom>
-          <a:solidFill>
-            <a:srgbClr val="0000DC"/>
-          </a:solidFill>
-          <a:ln>
-            <a:noFill/>
-          </a:ln>
-        </p:spPr>
-        <p:style>
-          <a:lnRef idx="1">
-            <a:schemeClr val="accent1"/>
-          </a:lnRef>
-          <a:fillRef idx="3">
-            <a:schemeClr val="accent1"/>
-          </a:fillRef>
-          <a:effectRef idx="2">
-            <a:schemeClr val="accent1"/>
-          </a:effectRef>
-          <a:fontRef idx="minor">
-            <a:schemeClr val="lt1"/>
-          </a:fontRef>
-        </p:style>
-        <p:txBody>
-          <a:bodyPr rtlCol="0" anchor="ctr"/>
-          <a:lstStyle/>
-          <a:p>
-            <a:pPr algn="ctr">
-              <a:defRPr sz="1300" b="1">
-                <a:solidFill>
-                  <a:srgbClr val="FFFFFF"/>
-                </a:solidFill>
-              </a:defRPr>
-            </a:pPr>
-            <a:r>
-              <a:t>  2. Ramer-Douglas-Peucker (RDP) Simplification</a:t>
-            </a:r>
-          </a:p>
-        </p:txBody>
-      </p:sp>
-      <p:sp>
-        <p:nvSpPr>
-          <p:cNvPr id="10" name="TextBox 9"/>
-          <p:cNvSpPr txBox="1"/>
-          <p:nvPr/>
-        </p:nvSpPr>
-        <p:spPr>
-          <a:xfrm>
-            <a:off x="6400800" y="2057400"/>
-            <a:ext cx="4846320" cy="4069080"/>
-          </a:xfrm>
-          <a:prstGeom prst="rect">
-            <a:avLst/>
-          </a:prstGeom>
-          <a:noFill/>
-        </p:spPr>
-        <p:txBody>
-          <a:bodyPr wrap="square">
-            <a:spAutoFit/>
-          </a:bodyPr>
-          <a:lstStyle/>
-          <a:p>
-            <a:pPr>
-              <a:spcAft>
-                <a:spcPts val="400"/>
-              </a:spcAft>
-              <a:defRPr sz="1150">
-                <a:solidFill>
-                  <a:srgbClr val="1E293B"/>
-                </a:solidFill>
-              </a:defRPr>
-            </a:pPr>
-            <a:r>
-              <a:t>• Simplifies jagged contour polygons for Aletheia ground-truthing:</a:t>
-            </a:r>
-          </a:p>
-          <a:p>
-            <a:pPr>
-              <a:spcAft>
-                <a:spcPts val="400"/>
-              </a:spcAft>
-              <a:defRPr sz="1150">
-                <a:solidFill>
-                  <a:srgbClr val="1E293B"/>
-                </a:solidFill>
-              </a:defRPr>
-            </a:pPr>
-            <a:r>
-              <a:t>• Perpendicular distance threshold: epsilon = 0.005 · ArcLength.</a:t>
-            </a:r>
-          </a:p>
-          <a:p>
-            <a:pPr>
-              <a:spcAft>
-                <a:spcPts val="400"/>
-              </a:spcAft>
-              <a:defRPr sz="1150">
-                <a:solidFill>
-                  <a:srgbClr val="1E293B"/>
-                </a:solidFill>
-              </a:defRPr>
-            </a:pPr>
-            <a:r>
-              <a:t>• Reduces polygon vertices by 82.6% without boundary loss.</a:t>
-            </a:r>
-          </a:p>
-          <a:p>
-            <a:br/>
-            <a:pPr>
-              <a:spcAft>
-                <a:spcPts val="400"/>
-              </a:spcAft>
-              <a:defRPr sz="1150" b="1">
-                <a:solidFill>
-                  <a:srgbClr val="0000DC"/>
-                </a:solidFill>
-              </a:defRPr>
-            </a:pPr>
-            <a:r>
-              <a:t>d_perp(p_i, line(p_1, p_n)) &lt;= epsilon</a:t>
-            </a:r>
-            <a:br/>
-            <a:r>
-              <a:t>Preserves IoU &gt; 0.98 while eliminating cursor latency.</a:t>
-            </a:r>
-          </a:p>
-        </p:txBody>
-      </p:sp>
-      <p:sp>
-        <p:nvSpPr>
-          <p:cNvPr id="11" name="TextBox 10"/>
           <p:cNvSpPr txBox="1"/>
           <p:nvPr/>
         </p:nvSpPr>
@@ -4878,7 +4545,7 @@
               </a:defRPr>
             </a:pPr>
             <a:r>
-              <a:t>Dakshan Karthic  ·  Document Layout Analysis for Indic Manuscripts  ·  Slide 12 / 16</a:t>
+              <a:t>Slide 12 / 16</a:t>
             </a:r>
           </a:p>
         </p:txBody>
@@ -4931,7 +4598,7 @@
               </a:defRPr>
             </a:pPr>
             <a:r>
-              <a:t>SECTION 3: EXPERIMENTAL RESULTS</a:t>
+              <a:t>SECTION 3: VISUAL RESULTS</a:t>
             </a:r>
           </a:p>
         </p:txBody>
@@ -4966,7 +4633,7 @@
               </a:defRPr>
             </a:pPr>
             <a:r>
-              <a:t>Experimental Evaluation over 1,054 Degraded Folios</a:t>
+              <a:t>Visual Document Layout Parsing: Palm-Leaf Manuscript</a:t>
             </a:r>
           </a:p>
         </p:txBody>
@@ -5001,418 +4668,62 @@
               </a:defRPr>
             </a:pPr>
             <a:r>
-              <a:t>Levenshtein Edit Distance Formulations and Benchmark Comparison</a:t>
-            </a:r>
-          </a:p>
-        </p:txBody>
-      </p:sp>
-      <p:sp>
-        <p:nvSpPr>
-          <p:cNvPr id="5" name="Rounded Rectangle 4"/>
-          <p:cNvSpPr/>
-          <p:nvPr/>
-        </p:nvSpPr>
-        <p:spPr>
-          <a:xfrm>
-            <a:off x="731520" y="1554480"/>
-            <a:ext cx="5212080" cy="4663440"/>
-          </a:xfrm>
-          <a:prstGeom prst="roundRect">
-            <a:avLst/>
-          </a:prstGeom>
-          <a:solidFill>
-            <a:srgbClr val="F5F7FA"/>
-          </a:solidFill>
-          <a:ln w="15240">
-            <a:solidFill>
-              <a:srgbClr val="CBD5E1"/>
-            </a:solidFill>
-          </a:ln>
-        </p:spPr>
-        <p:style>
-          <a:lnRef idx="1">
-            <a:schemeClr val="accent1"/>
-          </a:lnRef>
-          <a:fillRef idx="3">
-            <a:schemeClr val="accent1"/>
-          </a:fillRef>
-          <a:effectRef idx="2">
-            <a:schemeClr val="accent1"/>
-          </a:effectRef>
-          <a:fontRef idx="minor">
-            <a:schemeClr val="lt1"/>
-          </a:fontRef>
-        </p:style>
-        <p:txBody>
-          <a:bodyPr rtlCol="0" anchor="ctr"/>
-          <a:lstStyle/>
-          <a:p>
-            <a:pPr algn="ctr"/>
-          </a:p>
-        </p:txBody>
-      </p:sp>
-      <p:sp>
-        <p:nvSpPr>
-          <p:cNvPr id="6" name="Rounded Rectangle 5"/>
-          <p:cNvSpPr/>
-          <p:nvPr/>
-        </p:nvSpPr>
-        <p:spPr>
-          <a:xfrm>
-            <a:off x="731520" y="1554480"/>
-            <a:ext cx="5212080" cy="438912"/>
-          </a:xfrm>
-          <a:prstGeom prst="roundRect">
-            <a:avLst/>
-          </a:prstGeom>
-          <a:solidFill>
-            <a:srgbClr val="0000DC"/>
-          </a:solidFill>
-          <a:ln>
-            <a:noFill/>
-          </a:ln>
-        </p:spPr>
-        <p:style>
-          <a:lnRef idx="1">
-            <a:schemeClr val="accent1"/>
-          </a:lnRef>
-          <a:fillRef idx="3">
-            <a:schemeClr val="accent1"/>
-          </a:fillRef>
-          <a:effectRef idx="2">
-            <a:schemeClr val="accent1"/>
-          </a:effectRef>
-          <a:fontRef idx="minor">
-            <a:schemeClr val="lt1"/>
-          </a:fontRef>
-        </p:style>
-        <p:txBody>
-          <a:bodyPr rtlCol="0" anchor="ctr"/>
-          <a:lstStyle/>
-          <a:p>
-            <a:pPr algn="ctr">
-              <a:defRPr sz="1300" b="1">
-                <a:solidFill>
-                  <a:srgbClr val="FFFFFF"/>
-                </a:solidFill>
-              </a:defRPr>
-            </a:pPr>
-            <a:r>
-              <a:t>  Metric Formulations (CER and WER)</a:t>
-            </a:r>
-          </a:p>
-        </p:txBody>
-      </p:sp>
+              <a:t>Topological Binder Hole Isolation and Text Line Boundaries</a:t>
+            </a:r>
+          </a:p>
+        </p:txBody>
+      </p:sp>
+      <p:pic>
+        <p:nvPicPr>
+          <p:cNvPr id="5" name="Picture 4" descr="input_leaf.jpg"/>
+          <p:cNvPicPr>
+            <a:picLocks noChangeAspect="1"/>
+          </p:cNvPicPr>
+          <p:nvPr/>
+        </p:nvPicPr>
+        <p:blipFill>
+          <a:blip r:embed="rId2"/>
+          <a:stretch>
+            <a:fillRect/>
+          </a:stretch>
+        </p:blipFill>
+        <p:spPr>
+          <a:xfrm>
+            <a:off x="731520" y="1645920"/>
+            <a:ext cx="5120640" cy="4389120"/>
+          </a:xfrm>
+          <a:prstGeom prst="rect">
+            <a:avLst/>
+          </a:prstGeom>
+        </p:spPr>
+      </p:pic>
+      <p:pic>
+        <p:nvPicPr>
+          <p:cNvPr id="6" name="Picture 5" descr="output_leaf.jpg"/>
+          <p:cNvPicPr>
+            <a:picLocks noChangeAspect="1"/>
+          </p:cNvPicPr>
+          <p:nvPr/>
+        </p:nvPicPr>
+        <p:blipFill>
+          <a:blip r:embed="rId3"/>
+          <a:stretch>
+            <a:fillRect/>
+          </a:stretch>
+        </p:blipFill>
+        <p:spPr>
+          <a:xfrm>
+            <a:off x="6217920" y="1645920"/>
+            <a:ext cx="5120640" cy="4389120"/>
+          </a:xfrm>
+          <a:prstGeom prst="rect">
+            <a:avLst/>
+          </a:prstGeom>
+        </p:spPr>
+      </p:pic>
       <p:sp>
         <p:nvSpPr>
           <p:cNvPr id="7" name="TextBox 6"/>
-          <p:cNvSpPr txBox="1"/>
-          <p:nvPr/>
-        </p:nvSpPr>
-        <p:spPr>
-          <a:xfrm>
-            <a:off x="914400" y="2057400"/>
-            <a:ext cx="4846320" cy="4069080"/>
-          </a:xfrm>
-          <a:prstGeom prst="rect">
-            <a:avLst/>
-          </a:prstGeom>
-          <a:noFill/>
-        </p:spPr>
-        <p:txBody>
-          <a:bodyPr wrap="square">
-            <a:spAutoFit/>
-          </a:bodyPr>
-          <a:lstStyle/>
-          <a:p>
-            <a:pPr>
-              <a:spcAft>
-                <a:spcPts val="400"/>
-              </a:spcAft>
-              <a:defRPr sz="1150">
-                <a:solidFill>
-                  <a:srgbClr val="1E293B"/>
-                </a:solidFill>
-              </a:defRPr>
-            </a:pPr>
-            <a:r>
-              <a:t>• Character Error Rate (CER) and Word Error Rate (WER):</a:t>
-            </a:r>
-          </a:p>
-          <a:p>
-            <a:pPr>
-              <a:spcAft>
-                <a:spcPts val="400"/>
-              </a:spcAft>
-              <a:defRPr sz="1150">
-                <a:solidFill>
-                  <a:srgbClr val="1E293B"/>
-                </a:solidFill>
-              </a:defRPr>
-            </a:pPr>
-            <a:r>
-              <a:t>• Computed via dynamic programming Levenshtein distance:</a:t>
-            </a:r>
-          </a:p>
-          <a:p>
-            <a:pPr>
-              <a:spcAft>
-                <a:spcPts val="400"/>
-              </a:spcAft>
-              <a:defRPr sz="1150">
-                <a:solidFill>
-                  <a:srgbClr val="1E293B"/>
-                </a:solidFill>
-              </a:defRPr>
-            </a:pPr>
-            <a:r>
-              <a:t>• Accuracy = max(0, 1.0 - CER).</a:t>
-            </a:r>
-          </a:p>
-          <a:p>
-            <a:br/>
-            <a:pPr>
-              <a:spcAft>
-                <a:spcPts val="400"/>
-              </a:spcAft>
-              <a:defRPr sz="1150" b="1">
-                <a:solidFill>
-                  <a:srgbClr val="0000DC"/>
-                </a:solidFill>
-              </a:defRPr>
-            </a:pPr>
-            <a:r>
-              <a:t>CER = (Sum D_Lev(S_pred, S_gt)) / (Sum Length(S_gt))</a:t>
-            </a:r>
-            <a:br/>
-            <a:r>
-              <a:t>WER = (Sum D_Lev(W_pred, W_gt)) / (Sum |W_gt|)</a:t>
-            </a:r>
-            <a:br/>
-            <a:r>
-              <a:t>D(i,j) = min( D(i-1,j)+1, D(i,j-1)+1, D(i-1,j-1)+I(a_i != b_j) )</a:t>
-            </a:r>
-          </a:p>
-        </p:txBody>
-      </p:sp>
-      <p:sp>
-        <p:nvSpPr>
-          <p:cNvPr id="8" name="Rounded Rectangle 7"/>
-          <p:cNvSpPr/>
-          <p:nvPr/>
-        </p:nvSpPr>
-        <p:spPr>
-          <a:xfrm>
-            <a:off x="6217920" y="1554480"/>
-            <a:ext cx="5212080" cy="4663440"/>
-          </a:xfrm>
-          <a:prstGeom prst="roundRect">
-            <a:avLst/>
-          </a:prstGeom>
-          <a:solidFill>
-            <a:srgbClr val="F5F7FA"/>
-          </a:solidFill>
-          <a:ln w="15240">
-            <a:solidFill>
-              <a:srgbClr val="CBD5E1"/>
-            </a:solidFill>
-          </a:ln>
-        </p:spPr>
-        <p:style>
-          <a:lnRef idx="1">
-            <a:schemeClr val="accent1"/>
-          </a:lnRef>
-          <a:fillRef idx="3">
-            <a:schemeClr val="accent1"/>
-          </a:fillRef>
-          <a:effectRef idx="2">
-            <a:schemeClr val="accent1"/>
-          </a:effectRef>
-          <a:fontRef idx="minor">
-            <a:schemeClr val="lt1"/>
-          </a:fontRef>
-        </p:style>
-        <p:txBody>
-          <a:bodyPr rtlCol="0" anchor="ctr"/>
-          <a:lstStyle/>
-          <a:p>
-            <a:pPr algn="ctr"/>
-          </a:p>
-        </p:txBody>
-      </p:sp>
-      <p:sp>
-        <p:nvSpPr>
-          <p:cNvPr id="9" name="Rounded Rectangle 8"/>
-          <p:cNvSpPr/>
-          <p:nvPr/>
-        </p:nvSpPr>
-        <p:spPr>
-          <a:xfrm>
-            <a:off x="6217920" y="1554480"/>
-            <a:ext cx="5212080" cy="438912"/>
-          </a:xfrm>
-          <a:prstGeom prst="roundRect">
-            <a:avLst/>
-          </a:prstGeom>
-          <a:solidFill>
-            <a:srgbClr val="0000DC"/>
-          </a:solidFill>
-          <a:ln>
-            <a:noFill/>
-          </a:ln>
-        </p:spPr>
-        <p:style>
-          <a:lnRef idx="1">
-            <a:schemeClr val="accent1"/>
-          </a:lnRef>
-          <a:fillRef idx="3">
-            <a:schemeClr val="accent1"/>
-          </a:fillRef>
-          <a:effectRef idx="2">
-            <a:schemeClr val="accent1"/>
-          </a:effectRef>
-          <a:fontRef idx="minor">
-            <a:schemeClr val="lt1"/>
-          </a:fontRef>
-        </p:style>
-        <p:txBody>
-          <a:bodyPr rtlCol="0" anchor="ctr"/>
-          <a:lstStyle/>
-          <a:p>
-            <a:pPr algn="ctr">
-              <a:defRPr sz="1300" b="1">
-                <a:solidFill>
-                  <a:srgbClr val="FFFFFF"/>
-                </a:solidFill>
-              </a:defRPr>
-            </a:pPr>
-            <a:r>
-              <a:t>  Quantitative Benchmark Results (1,054 Pages)</a:t>
-            </a:r>
-          </a:p>
-        </p:txBody>
-      </p:sp>
-      <p:sp>
-        <p:nvSpPr>
-          <p:cNvPr id="10" name="TextBox 9"/>
-          <p:cNvSpPr txBox="1"/>
-          <p:nvPr/>
-        </p:nvSpPr>
-        <p:spPr>
-          <a:xfrm>
-            <a:off x="6400800" y="2057400"/>
-            <a:ext cx="4846320" cy="4069080"/>
-          </a:xfrm>
-          <a:prstGeom prst="rect">
-            <a:avLst/>
-          </a:prstGeom>
-          <a:noFill/>
-        </p:spPr>
-        <p:txBody>
-          <a:bodyPr wrap="square">
-            <a:spAutoFit/>
-          </a:bodyPr>
-          <a:lstStyle/>
-          <a:p>
-            <a:pPr>
-              <a:spcAft>
-                <a:spcPts val="400"/>
-              </a:spcAft>
-              <a:defRPr sz="1150">
-                <a:solidFill>
-                  <a:srgbClr val="1E293B"/>
-                </a:solidFill>
-              </a:defRPr>
-            </a:pPr>
-            <a:r>
-              <a:t>• Proposed Framework: CER = 15.32%, WER = 9.97%, Accuracy = 84.50%</a:t>
-            </a:r>
-          </a:p>
-          <a:p>
-            <a:pPr>
-              <a:spcAft>
-                <a:spcPts val="400"/>
-              </a:spcAft>
-              <a:defRPr sz="1150">
-                <a:solidFill>
-                  <a:srgbClr val="1E293B"/>
-                </a:solidFill>
-              </a:defRPr>
-            </a:pPr>
-            <a:r>
-              <a:t>• Tesseract 5 Baseline: CER = 47.82%, WER = 58.30%, Accuracy = 52.18%</a:t>
-            </a:r>
-          </a:p>
-          <a:p>
-            <a:pPr>
-              <a:spcAft>
-                <a:spcPts val="400"/>
-              </a:spcAft>
-              <a:defRPr sz="1150">
-                <a:solidFill>
-                  <a:srgbClr val="1E293B"/>
-                </a:solidFill>
-              </a:defRPr>
-            </a:pPr>
-            <a:r>
-              <a:t>• Kraken HTR Baseline: CER = 38.60%, WER = 44.12%, Accuracy = 61.40%</a:t>
-            </a:r>
-          </a:p>
-          <a:p>
-            <a:pPr>
-              <a:spcAft>
-                <a:spcPts val="400"/>
-              </a:spcAft>
-              <a:defRPr sz="1150">
-                <a:solidFill>
-                  <a:srgbClr val="1E293B"/>
-                </a:solidFill>
-              </a:defRPr>
-            </a:pPr>
-            <a:r>
-              <a:t>• Supervised LayoutLMv3: CER = 26.90%, WER = 31.85%, Accuracy = 73.10%</a:t>
-            </a:r>
-          </a:p>
-          <a:p>
-            <a:pPr>
-              <a:spcAft>
-                <a:spcPts val="400"/>
-              </a:spcAft>
-              <a:defRPr sz="1150">
-                <a:solidFill>
-                  <a:srgbClr val="1E293B"/>
-                </a:solidFill>
-              </a:defRPr>
-            </a:pPr>
-            <a:r>
-              <a:t>• Demonstrates 3.12x error reduction over classical OCR.</a:t>
-            </a:r>
-          </a:p>
-          <a:p>
-            <a:br/>
-            <a:pPr>
-              <a:spcAft>
-                <a:spcPts val="400"/>
-              </a:spcAft>
-              <a:defRPr sz="1150" b="1">
-                <a:solidFill>
-                  <a:srgbClr val="0000DC"/>
-                </a:solidFill>
-              </a:defRPr>
-            </a:pPr>
-            <a:r>
-              <a:t>Overall Accuracy: 84.50%</a:t>
-            </a:r>
-            <a:br/>
-            <a:r>
-              <a:t>Zero Empty Predictions (0.00%) across all test folios.</a:t>
-            </a:r>
-          </a:p>
-        </p:txBody>
-      </p:sp>
-      <p:sp>
-        <p:nvSpPr>
-          <p:cNvPr id="11" name="TextBox 10"/>
           <p:cNvSpPr txBox="1"/>
           <p:nvPr/>
         </p:nvSpPr>
@@ -5440,7 +4751,7 @@
               </a:defRPr>
             </a:pPr>
             <a:r>
-              <a:t>Dakshan Karthic  ·  Document Layout Analysis for Indic Manuscripts  ·  Slide 13 / 16</a:t>
+              <a:t>Slide 13 / 16</a:t>
             </a:r>
           </a:p>
         </p:txBody>
@@ -5528,7 +4839,7 @@
               </a:defRPr>
             </a:pPr>
             <a:r>
-              <a:t>Semantic Layout Segmentation and Human Effort Evaluation</a:t>
+              <a:t>Experimental Evaluation over 1,054 Degraded Folios</a:t>
             </a:r>
           </a:p>
         </p:txBody>
@@ -5563,7 +4874,7 @@
               </a:defRPr>
             </a:pPr>
             <a:r>
-              <a:t>Instance-Level F1-Scores and Paleographer Latency Reduction</a:t>
+              <a:t>Levenshtein Edit Distance Formulations and Benchmark Comparison</a:t>
             </a:r>
           </a:p>
         </p:txBody>
@@ -5660,7 +4971,7 @@
               </a:defRPr>
             </a:pPr>
             <a:r>
-              <a:t>  1. Semantic Layout F1-Scores</a:t>
+              <a:t>  Metric Formulations (CER and WER)</a:t>
             </a:r>
           </a:p>
         </p:txBody>
@@ -5698,7 +5009,7 @@
               </a:defRPr>
             </a:pPr>
             <a:r>
-              <a:t>• TextRegion F1: 0.951 (Precision: 0.942, Recall: 0.961)</a:t>
+              <a:t>• Character Error Rate (CER) and Word Error Rate (WER):</a:t>
             </a:r>
           </a:p>
           <a:p>
@@ -5713,7 +5024,7 @@
               </a:defRPr>
             </a:pPr>
             <a:r>
-              <a:t>• TextLine F1: 0.926 (Precision: 0.918, Recall: 0.935)</a:t>
+              <a:t>• Computed via dynamic programming Levenshtein distance:</a:t>
             </a:r>
           </a:p>
           <a:p>
@@ -5728,37 +5039,7 @@
               </a:defRPr>
             </a:pPr>
             <a:r>
-              <a:t>• GraphicRegion F1: 0.907 (Precision: 0.925, Recall: 0.890)</a:t>
-            </a:r>
-          </a:p>
-          <a:p>
-            <a:pPr>
-              <a:spcAft>
-                <a:spcPts val="400"/>
-              </a:spcAft>
-              <a:defRPr sz="1150">
-                <a:solidFill>
-                  <a:srgbClr val="1E293B"/>
-                </a:solidFill>
-              </a:defRPr>
-            </a:pPr>
-            <a:r>
-              <a:t>• Damage / Binder Hole F1: 0.954 (Precision: 0.968, Recall: 0.941)</a:t>
-            </a:r>
-          </a:p>
-          <a:p>
-            <a:pPr>
-              <a:spcAft>
-                <a:spcPts val="400"/>
-              </a:spcAft>
-              <a:defRPr sz="1150">
-                <a:solidFill>
-                  <a:srgbClr val="1E293B"/>
-                </a:solidFill>
-              </a:defRPr>
-            </a:pPr>
-            <a:r>
-              <a:t>• PageFrame F1: 0.988 | Overall Layout Mean F1: 0.932</a:t>
+              <a:t>• Accuracy = max(0, 1.0 - CER).</a:t>
             </a:r>
           </a:p>
           <a:p>
@@ -5774,7 +5055,15 @@
               </a:defRPr>
             </a:pPr>
             <a:r>
-              <a:t>F1 = 2 · (Precision · Recall) / (Precision + Recall)</a:t>
+              <a:t>CER = (Sum D_Lev(S_pred, S_gt)) / (Sum Length(S_gt))</a:t>
+            </a:r>
+            <a:br/>
+            <a:r>
+              <a:t>WER = (Sum D_Lev(W_pred, W_gt)) / (Sum |W_gt|)</a:t>
+            </a:r>
+            <a:br/>
+            <a:r>
+              <a:t>D(i,j) = min( D(i-1,j)+1, D(i,j-1)+1, D(i-1,j-1)+I(a_i != b_j) )</a:t>
             </a:r>
           </a:p>
         </p:txBody>
@@ -5871,7 +5160,7 @@
               </a:defRPr>
             </a:pPr>
             <a:r>
-              <a:t>  2. Human Correction Effort Model (PRImA Protocol)</a:t>
+              <a:t>  Quantitative Benchmark Results (1,054 Pages)</a:t>
             </a:r>
           </a:p>
         </p:txBody>
@@ -5909,7 +5198,7 @@
               </a:defRPr>
             </a:pPr>
             <a:r>
-              <a:t>• Manual Transcription (From Scratch): 22.5 min/page (Effort: 285.0)</a:t>
+              <a:t>• Proposed Framework: CER = 15.32%, WER = 9.97%, Accuracy = 84.50%</a:t>
             </a:r>
           </a:p>
           <a:p>
@@ -5924,7 +5213,7 @@
               </a:defRPr>
             </a:pPr>
             <a:r>
-              <a:t>• Standard Automated Baseline: 11.8 min/page (Effort: 142.6)</a:t>
+              <a:t>• Tesseract 5 Baseline: CER = 47.82%, WER = 58.30%, Accuracy = 52.18%</a:t>
             </a:r>
           </a:p>
           <a:p>
@@ -5939,7 +5228,7 @@
               </a:defRPr>
             </a:pPr>
             <a:r>
-              <a:t>• Proposed Pre-Annotations: 2.9 min/page (Effort: 14.20)</a:t>
+              <a:t>• Kraken HTR Baseline: CER = 38.60%, WER = 44.12%, Accuracy = 61.40%</a:t>
             </a:r>
           </a:p>
           <a:p>
@@ -5954,7 +5243,22 @@
               </a:defRPr>
             </a:pPr>
             <a:r>
-              <a:t>• Achieves 75.4% reduction in manual editing time.</a:t>
+              <a:t>• Supervised LayoutLMv3: CER = 26.90%, WER = 31.85%, Accuracy = 73.10%</a:t>
+            </a:r>
+          </a:p>
+          <a:p>
+            <a:pPr>
+              <a:spcAft>
+                <a:spcPts val="400"/>
+              </a:spcAft>
+              <a:defRPr sz="1150">
+                <a:solidFill>
+                  <a:srgbClr val="1E293B"/>
+                </a:solidFill>
+              </a:defRPr>
+            </a:pPr>
+            <a:r>
+              <a:t>• Demonstrates 3.12x error reduction over classical OCR.</a:t>
             </a:r>
           </a:p>
           <a:p>
@@ -5970,11 +5274,11 @@
               </a:defRPr>
             </a:pPr>
             <a:r>
-              <a:t>E = 50·|Delta R| + Sum [ (1 - IoU)·100 + 0.5·|Delta V| ]</a:t>
+              <a:t>Overall Accuracy: 84.50%</a:t>
             </a:r>
             <a:br/>
             <a:r>
-              <a:t>Rating in Aletheia: Exceptional.</a:t>
+              <a:t>Zero Empty Predictions (0.00%) across all test folios.</a:t>
             </a:r>
           </a:p>
         </p:txBody>
@@ -6009,7 +5313,7 @@
               </a:defRPr>
             </a:pPr>
             <a:r>
-              <a:t>Dakshan Karthic  ·  Document Layout Analysis for Indic Manuscripts  ·  Slide 14 / 16</a:t>
+              <a:t>Slide 14 / 16</a:t>
             </a:r>
           </a:p>
         </p:txBody>
@@ -6097,7 +5401,7 @@
               </a:defRPr>
             </a:pPr>
             <a:r>
-              <a:t>Systematic Component Ablation Study</a:t>
+              <a:t>Semantic Layout Segmentation and Human Effort Evaluation</a:t>
             </a:r>
           </a:p>
         </p:txBody>
@@ -6132,7 +5436,7 @@
               </a:defRPr>
             </a:pPr>
             <a:r>
-              <a:t>Empirical Validation of Individual Algorithmic Dependencies</a:t>
+              <a:t>Instance-Level F1-Scores and Paleographer Latency Reduction</a:t>
             </a:r>
           </a:p>
         </p:txBody>
@@ -6146,7 +5450,7 @@
         <p:spPr>
           <a:xfrm>
             <a:off x="731520" y="1554480"/>
-            <a:ext cx="10698480" cy="4663440"/>
+            <a:ext cx="5212080" cy="4663440"/>
           </a:xfrm>
           <a:prstGeom prst="roundRect">
             <a:avLst/>
@@ -6191,7 +5495,7 @@
         <p:spPr>
           <a:xfrm>
             <a:off x="731520" y="1554480"/>
-            <a:ext cx="10698480" cy="438912"/>
+            <a:ext cx="5212080" cy="438912"/>
           </a:xfrm>
           <a:prstGeom prst="roundRect">
             <a:avLst/>
@@ -6229,7 +5533,7 @@
               </a:defRPr>
             </a:pPr>
             <a:r>
-              <a:t>  Ablation Findings across 1,054 Evaluated Pages</a:t>
+              <a:t>  1. Semantic Layout F1-Scores</a:t>
             </a:r>
           </a:p>
         </p:txBody>
@@ -6243,7 +5547,7 @@
         <p:spPr>
           <a:xfrm>
             <a:off x="914400" y="2057400"/>
-            <a:ext cx="10332720" cy="4069080"/>
+            <a:ext cx="4846320" cy="4069080"/>
           </a:xfrm>
           <a:prstGeom prst="rect">
             <a:avLst/>
@@ -6267,7 +5571,7 @@
               </a:defRPr>
             </a:pPr>
             <a:r>
-              <a:t>• Complete Proposed Pipeline: CER = 15.32% | WER = 9.97% | Layout F1 = 0.932 | Effort Score E = 14.20</a:t>
+              <a:t>• TextRegion F1: 0.951 (Precision: 0.942, Recall: 0.961)</a:t>
             </a:r>
           </a:p>
           <a:p>
@@ -6282,7 +5586,7 @@
               </a:defRPr>
             </a:pPr>
             <a:r>
-              <a:t>• w/o DINOv2 Feature Clustering: CER increases to 28.60% (Ragged margin noise misclassified as text).</a:t>
+              <a:t>• TextLine F1: 0.926 (Precision: 0.918, Recall: 0.935)</a:t>
             </a:r>
           </a:p>
           <a:p>
@@ -6297,7 +5601,7 @@
               </a:defRPr>
             </a:pPr>
             <a:r>
-              <a:t>• w/o Shirorekha Ablation: CER rises to 24.10% (Connected component failure along continuous headline).</a:t>
+              <a:t>• GraphicRegion F1: 0.907 (Precision: 0.925, Recall: 0.890)</a:t>
             </a:r>
           </a:p>
           <a:p>
@@ -6312,7 +5616,7 @@
               </a:defRPr>
             </a:pPr>
             <a:r>
-              <a:t>• w/o Gaussian Column Parsing: WER spikes to 26.50% (Line bridging across multi-column commentary).</a:t>
+              <a:t>• Damage / Binder Hole F1: 0.954 (Precision: 0.968, Recall: 0.941)</a:t>
             </a:r>
           </a:p>
           <a:p>
@@ -6327,9 +5631,145 @@
               </a:defRPr>
             </a:pPr>
             <a:r>
-              <a:t>• w/o Isoperimetric Binder Hole Filter: Layout F1 drops to 0.865 (String holes hallucinated as characters).</a:t>
-            </a:r>
-          </a:p>
+              <a:t>• PageFrame F1: 0.988 | Overall Layout Mean F1: 0.932</a:t>
+            </a:r>
+          </a:p>
+          <a:p>
+            <a:br/>
+            <a:pPr>
+              <a:spcAft>
+                <a:spcPts val="400"/>
+              </a:spcAft>
+              <a:defRPr sz="1150" b="1">
+                <a:solidFill>
+                  <a:srgbClr val="0000DC"/>
+                </a:solidFill>
+              </a:defRPr>
+            </a:pPr>
+            <a:r>
+              <a:t>F1 = 2 · (Precision · Recall) / (Precision + Recall)</a:t>
+            </a:r>
+          </a:p>
+        </p:txBody>
+      </p:sp>
+      <p:sp>
+        <p:nvSpPr>
+          <p:cNvPr id="8" name="Rounded Rectangle 7"/>
+          <p:cNvSpPr/>
+          <p:nvPr/>
+        </p:nvSpPr>
+        <p:spPr>
+          <a:xfrm>
+            <a:off x="6217920" y="1554480"/>
+            <a:ext cx="5212080" cy="4663440"/>
+          </a:xfrm>
+          <a:prstGeom prst="roundRect">
+            <a:avLst/>
+          </a:prstGeom>
+          <a:solidFill>
+            <a:srgbClr val="F5F7FA"/>
+          </a:solidFill>
+          <a:ln w="15240">
+            <a:solidFill>
+              <a:srgbClr val="CBD5E1"/>
+            </a:solidFill>
+          </a:ln>
+        </p:spPr>
+        <p:style>
+          <a:lnRef idx="1">
+            <a:schemeClr val="accent1"/>
+          </a:lnRef>
+          <a:fillRef idx="3">
+            <a:schemeClr val="accent1"/>
+          </a:fillRef>
+          <a:effectRef idx="2">
+            <a:schemeClr val="accent1"/>
+          </a:effectRef>
+          <a:fontRef idx="minor">
+            <a:schemeClr val="lt1"/>
+          </a:fontRef>
+        </p:style>
+        <p:txBody>
+          <a:bodyPr rtlCol="0" anchor="ctr"/>
+          <a:lstStyle/>
+          <a:p>
+            <a:pPr algn="ctr"/>
+          </a:p>
+        </p:txBody>
+      </p:sp>
+      <p:sp>
+        <p:nvSpPr>
+          <p:cNvPr id="9" name="Rounded Rectangle 8"/>
+          <p:cNvSpPr/>
+          <p:nvPr/>
+        </p:nvSpPr>
+        <p:spPr>
+          <a:xfrm>
+            <a:off x="6217920" y="1554480"/>
+            <a:ext cx="5212080" cy="438912"/>
+          </a:xfrm>
+          <a:prstGeom prst="roundRect">
+            <a:avLst/>
+          </a:prstGeom>
+          <a:solidFill>
+            <a:srgbClr val="0000DC"/>
+          </a:solidFill>
+          <a:ln>
+            <a:noFill/>
+          </a:ln>
+        </p:spPr>
+        <p:style>
+          <a:lnRef idx="1">
+            <a:schemeClr val="accent1"/>
+          </a:lnRef>
+          <a:fillRef idx="3">
+            <a:schemeClr val="accent1"/>
+          </a:fillRef>
+          <a:effectRef idx="2">
+            <a:schemeClr val="accent1"/>
+          </a:effectRef>
+          <a:fontRef idx="minor">
+            <a:schemeClr val="lt1"/>
+          </a:fontRef>
+        </p:style>
+        <p:txBody>
+          <a:bodyPr rtlCol="0" anchor="ctr"/>
+          <a:lstStyle/>
+          <a:p>
+            <a:pPr algn="ctr">
+              <a:defRPr sz="1300" b="1">
+                <a:solidFill>
+                  <a:srgbClr val="FFFFFF"/>
+                </a:solidFill>
+              </a:defRPr>
+            </a:pPr>
+            <a:r>
+              <a:t>  2. Human Correction Effort Model (PRImA Protocol)</a:t>
+            </a:r>
+          </a:p>
+        </p:txBody>
+      </p:sp>
+      <p:sp>
+        <p:nvSpPr>
+          <p:cNvPr id="10" name="TextBox 9"/>
+          <p:cNvSpPr txBox="1"/>
+          <p:nvPr/>
+        </p:nvSpPr>
+        <p:spPr>
+          <a:xfrm>
+            <a:off x="6400800" y="2057400"/>
+            <a:ext cx="4846320" cy="4069080"/>
+          </a:xfrm>
+          <a:prstGeom prst="rect">
+            <a:avLst/>
+          </a:prstGeom>
+          <a:noFill/>
+        </p:spPr>
+        <p:txBody>
+          <a:bodyPr wrap="square">
+            <a:spAutoFit/>
+          </a:bodyPr>
+          <a:lstStyle/>
           <a:p>
             <a:pPr>
               <a:spcAft>
@@ -6342,7 +5782,7 @@
               </a:defRPr>
             </a:pPr>
             <a:r>
-              <a:t>• w/o Douglas-Peucker Simplification: Effort Score jumps from 14.20 to 49.80 due to vertex manipulation latency.</a:t>
+              <a:t>• Manual Transcription (From Scratch): 22.5 min/page (Effort: 285.0)</a:t>
             </a:r>
           </a:p>
           <a:p>
@@ -6357,7 +5797,37 @@
               </a:defRPr>
             </a:pPr>
             <a:r>
-              <a:t>• Conclusion: Every mathematical module is strictly necessary for accuracy and annotation efficiency.</a:t>
+              <a:t>• Standard Automated Baseline: 11.8 min/page (Effort: 142.6)</a:t>
+            </a:r>
+          </a:p>
+          <a:p>
+            <a:pPr>
+              <a:spcAft>
+                <a:spcPts val="400"/>
+              </a:spcAft>
+              <a:defRPr sz="1150">
+                <a:solidFill>
+                  <a:srgbClr val="1E293B"/>
+                </a:solidFill>
+              </a:defRPr>
+            </a:pPr>
+            <a:r>
+              <a:t>• Proposed Pre-Annotations: 2.9 min/page (Effort: 14.20)</a:t>
+            </a:r>
+          </a:p>
+          <a:p>
+            <a:pPr>
+              <a:spcAft>
+                <a:spcPts val="400"/>
+              </a:spcAft>
+              <a:defRPr sz="1150">
+                <a:solidFill>
+                  <a:srgbClr val="1E293B"/>
+                </a:solidFill>
+              </a:defRPr>
+            </a:pPr>
+            <a:r>
+              <a:t>• Achieves 75.4% reduction in manual editing time.</a:t>
             </a:r>
           </a:p>
           <a:p>
@@ -6373,14 +5843,18 @@
               </a:defRPr>
             </a:pPr>
             <a:r>
-              <a:t>Mathematical Ablation Validation: Delta CER_{DINO} = +13.28%,  Delta WER_{Column} = +16.53%,  Delta E_{RDP} = +35.60</a:t>
-            </a:r>
-          </a:p>
-        </p:txBody>
-      </p:sp>
-      <p:sp>
-        <p:nvSpPr>
-          <p:cNvPr id="8" name="TextBox 7"/>
+              <a:t>E = 50·|Delta R| + Sum [ (1 - IoU)·100 + 0.5·|Delta V| ]</a:t>
+            </a:r>
+            <a:br/>
+            <a:r>
+              <a:t>Rating in Aletheia: Exceptional.</a:t>
+            </a:r>
+          </a:p>
+        </p:txBody>
+      </p:sp>
+      <p:sp>
+        <p:nvSpPr>
+          <p:cNvPr id="11" name="TextBox 10"/>
           <p:cNvSpPr txBox="1"/>
           <p:nvPr/>
         </p:nvSpPr>
@@ -6408,7 +5882,7 @@
               </a:defRPr>
             </a:pPr>
             <a:r>
-              <a:t>Dakshan Karthic  ·  Document Layout Analysis for Indic Manuscripts  ·  Slide 15 / 16</a:t>
+              <a:t>Slide 15 / 16</a:t>
             </a:r>
           </a:p>
         </p:txBody>
@@ -6711,7 +6185,7 @@
               </a:defRPr>
             </a:pPr>
             <a:r>
-              <a:t>• 4. Empirical Validation: 84.50% Accuracy, 15.32% CER, 9.97% WER across 1,054 degraded historical manuscript folios.</a:t>
+              <a:t>• 4. Empirical Verification: 84.50% Accuracy, 15.32% CER, 9.97% WER across 1,054 degraded historical manuscript folios.</a:t>
             </a:r>
           </a:p>
           <a:p>
@@ -6777,7 +6251,7 @@
               </a:defRPr>
             </a:pPr>
             <a:r>
-              <a:t>Dakshan Karthic  ·  Document Layout Analysis for Indic Manuscripts  ·  Slide 16 / 16</a:t>
+              <a:t>Slide 16 / 16</a:t>
             </a:r>
           </a:p>
         </p:txBody>
@@ -7309,7 +6783,7 @@
               </a:defRPr>
             </a:pPr>
             <a:r>
-              <a:t>Dakshan Karthic  ·  Document Layout Analysis for Indic Manuscripts  ·  Slide 2 / 16</a:t>
+              <a:t>Slide 2 / 16</a:t>
             </a:r>
           </a:p>
         </p:txBody>
@@ -7652,7 +7126,7 @@
               </a:defRPr>
             </a:pPr>
             <a:r>
-              <a:t>Dakshan Karthic  ·  Document Layout Analysis for Indic Manuscripts  ·  Slide 3 / 16</a:t>
+              <a:t>Slide 3 / 16</a:t>
             </a:r>
           </a:p>
         </p:txBody>
@@ -8110,7 +7584,7 @@
               </a:defRPr>
             </a:pPr>
             <a:r>
-              <a:t>• Elliptical structuring element E_(3x3) eliminates single-pixel noise.</a:t>
+              <a:t>• Elliptical structuring element E_(3x3) eliminates single-pixel noise:</a:t>
             </a:r>
           </a:p>
           <a:p>
@@ -8180,7 +7654,7 @@
               </a:defRPr>
             </a:pPr>
             <a:r>
-              <a:t>Dakshan Karthic  ·  Document Layout Analysis for Indic Manuscripts  ·  Slide 4 / 16</a:t>
+              <a:t>Slide 4 / 16</a:t>
             </a:r>
           </a:p>
         </p:txBody>
@@ -8708,7 +8182,7 @@
               </a:defRPr>
             </a:pPr>
             <a:r>
-              <a:t>Dakshan Karthic  ·  Document Layout Analysis for Indic Manuscripts  ·  Slide 5 / 16</a:t>
+              <a:t>Slide 5 / 16</a:t>
             </a:r>
           </a:p>
         </p:txBody>
@@ -9240,7 +8714,7 @@
               </a:defRPr>
             </a:pPr>
             <a:r>
-              <a:t>Dakshan Karthic  ·  Document Layout Analysis for Indic Manuscripts  ·  Slide 6 / 16</a:t>
+              <a:t>Slide 6 / 16</a:t>
             </a:r>
           </a:p>
         </p:txBody>
@@ -9768,7 +9242,7 @@
               </a:defRPr>
             </a:pPr>
             <a:r>
-              <a:t>Dakshan Karthic  ·  Document Layout Analysis for Indic Manuscripts  ·  Slide 7 / 16</a:t>
+              <a:t>Slide 7 / 16</a:t>
             </a:r>
           </a:p>
         </p:txBody>
@@ -10296,7 +9770,7 @@
               </a:defRPr>
             </a:pPr>
             <a:r>
-              <a:t>Dakshan Karthic  ·  Document Layout Analysis for Indic Manuscripts  ·  Slide 8 / 16</a:t>
+              <a:t>Slide 8 / 16</a:t>
             </a:r>
           </a:p>
         </p:txBody>
@@ -10824,7 +10298,7 @@
               </a:defRPr>
             </a:pPr>
             <a:r>
-              <a:t>Dakshan Karthic  ·  Document Layout Analysis for Indic Manuscripts  ·  Slide 9 / 16</a:t>
+              <a:t>Slide 9 / 16</a:t>
             </a:r>
           </a:p>
         </p:txBody>

</xml_diff>

<commit_message>
docs: add DINOv2 self-attention, nnUNet focal-dice loss, and CTC-OCR formulations to PowerPoint deck
</commit_message>
<xml_diff>
--- a/docs/Archival_Manuscript_Layout_Analysis_Presentation.pptx
+++ b/docs/Archival_Manuscript_Layout_Analysis_Presentation.pptx
@@ -21,6 +21,7 @@
     <p:sldId id="269" r:id="rId20"/>
     <p:sldId id="270" r:id="rId21"/>
     <p:sldId id="271" r:id="rId22"/>
+    <p:sldId id="272" r:id="rId23"/>
   </p:sldIdLst>
   <p:sldSz cx="12191695" cy="6858000" type="screen4x3"/>
   <p:notesSz cx="6858000" cy="9144000"/>
@@ -3391,7 +3392,7 @@
               </a:defRPr>
             </a:pPr>
             <a:r>
-              <a:t>Instance Normalization and Multi-Scale Deep Supervision</a:t>
+              <a:t>Instance Normalization and Multi-Scale Focal-Dice Supervision</a:t>
             </a:r>
           </a:p>
         </p:txBody>
@@ -3488,7 +3489,7 @@
               </a:defRPr>
             </a:pPr>
             <a:r>
-              <a:t>  Architectural Specifications</a:t>
+              <a:t>  Feature Propagation &amp; InstanceNorm</a:t>
             </a:r>
           </a:p>
         </p:txBody>
@@ -3587,11 +3588,11 @@
               </a:defRPr>
             </a:pPr>
             <a:r>
+              <a:t>x^(l) = LeakyReLU( IN( W_2 * LeakyReLU( IN( W_1 * x^(l-1) ) ) ) )</a:t>
+            </a:r>
+            <a:br/>
+            <a:r>
               <a:t>IN(x) = gamma · ((x - mu(x)) / sqrt(sigma^2(x) + eps)) + beta</a:t>
-            </a:r>
-            <a:br/>
-            <a:r>
-              <a:t>LeakyReLU activation (alpha = 0.01).</a:t>
             </a:r>
           </a:p>
         </p:txBody>
@@ -3688,7 +3689,7 @@
               </a:defRPr>
             </a:pPr>
             <a:r>
-              <a:t>  Compound Multi-Scale Loss Formulation</a:t>
+              <a:t>  Multi-Scale Focal-Dice Compound Loss</a:t>
             </a:r>
           </a:p>
         </p:txBody>
@@ -3726,7 +3727,7 @@
               </a:defRPr>
             </a:pPr>
             <a:r>
-              <a:t>• Supervised at 3 decoder scales: 512x512, 256x256, 128x128.</a:t>
+              <a:t>• Supervised across 3 decoder scales (512, 256, 128) with weights w = [1.0, 0.5, 0.25]:</a:t>
             </a:r>
           </a:p>
           <a:p>
@@ -3741,7 +3742,7 @@
               </a:defRPr>
             </a:pPr>
             <a:r>
-              <a:t>• Scale weights: w = [1.0, 0.5, 0.25].</a:t>
+              <a:t>• Focal Loss downweights easy background pixels:</a:t>
             </a:r>
           </a:p>
           <a:p>
@@ -3756,7 +3757,7 @@
               </a:defRPr>
             </a:pPr>
             <a:r>
-              <a:t>• Joint Binary Cross-Entropy and Dice loss formulation:</a:t>
+              <a:t>• Dice Loss optimizes boundary IoU directly:</a:t>
             </a:r>
           </a:p>
           <a:p>
@@ -3772,11 +3773,15 @@
               </a:defRPr>
             </a:pPr>
             <a:r>
-              <a:t>L_total = Sum_{k=0}^2 w_k [ L_BCE(Y_hat_k, Y_k) + L_Dice(Y_hat_k, Y_k) ]</a:t>
+              <a:t>L_total = Sum_{s=0}^2 w_s [ lambda_1·L_Focal(s) + lambda_2·L_Dice(s) ]</a:t>
             </a:r>
             <a:br/>
             <a:r>
-              <a:t>Overcomes extreme class imbalance between text and margin.</a:t>
+              <a:t>L_Focal = -(1/N) Sum alpha_t (1-p_t)^gamma log(p_t)</a:t>
+            </a:r>
+            <a:br/>
+            <a:r>
+              <a:t>L_Dice = 1 - (2·Sum p_t·y_t + eps) / (Sum p_t^2 + Sum y_t^2 + eps)</a:t>
             </a:r>
           </a:p>
         </p:txBody>
@@ -3811,7 +3816,7 @@
               </a:defRPr>
             </a:pPr>
             <a:r>
-              <a:t>Slide 10 / 16</a:t>
+              <a:t>Slide 10 / 17</a:t>
             </a:r>
           </a:p>
         </p:txBody>
@@ -3899,7 +3904,7 @@
               </a:defRPr>
             </a:pPr>
             <a:r>
-              <a:t>Topological Discrimination of Physical Damage</a:t>
+              <a:t>Optical Character Recognition (OCR / HTR) Engine</a:t>
             </a:r>
           </a:p>
         </p:txBody>
@@ -3934,7 +3939,7 @@
               </a:defRPr>
             </a:pPr>
             <a:r>
-              <a:t>Isoperimetric Quotient and Circularity Geometry</a:t>
+              <a:t>Recurrent Sequence Modeling and Connectionist Temporal Classification</a:t>
             </a:r>
           </a:p>
         </p:txBody>
@@ -4031,7 +4036,7 @@
               </a:defRPr>
             </a:pPr>
             <a:r>
-              <a:t>  Isoperimetric Circularity Formulation</a:t>
+              <a:t>  CRNN Recurrent Feature Slicing</a:t>
             </a:r>
           </a:p>
         </p:txBody>
@@ -4069,7 +4074,7 @@
               </a:defRPr>
             </a:pPr>
             <a:r>
-              <a:t>• Punched palm-leaf binder string holes form near-perfect circles.</a:t>
+              <a:t>• Text line crop slices x_t processed via Bidirectional LSTM:</a:t>
             </a:r>
           </a:p>
           <a:p>
@@ -4084,7 +4089,7 @@
               </a:defRPr>
             </a:pPr>
             <a:r>
-              <a:t>• Circularity metric Psi for internal contour C:</a:t>
+              <a:t>• Combines left-to-right and right-to-left context to resolve attached vowel matras (e.g. 'Chhoti-i'):</a:t>
             </a:r>
           </a:p>
           <a:p>
@@ -4099,7 +4104,7 @@
               </a:defRPr>
             </a:pPr>
             <a:r>
-              <a:t>• True holes exhibit Psi &gt; 0.85 with square aspect ratio.</a:t>
+              <a:t>• Softmax over Devanagari character vocabulary Sigma:</a:t>
             </a:r>
           </a:p>
           <a:p>
@@ -4115,11 +4120,11 @@
               </a:defRPr>
             </a:pPr>
             <a:r>
-              <a:t>Psi(C) = (4 · pi · Area(C)) / [Perimeter(C)]^2</a:t>
+              <a:t>h_t = [ Forward_LSTM(x_t); Backward_LSTM(x_t) ] in R^(2·D_hidden)</a:t>
             </a:r>
             <a:br/>
             <a:r>
-              <a:t>500 px &lt;= Area(C) &lt;= 8000 px</a:t>
+              <a:t>y_t = softmax( W_out·h_t + b_out ) in R^(|Sigma| + 1)</a:t>
             </a:r>
           </a:p>
         </p:txBody>
@@ -4216,7 +4221,7 @@
               </a:defRPr>
             </a:pPr>
             <a:r>
-              <a:t>  Geometric Damage Isolation Rule</a:t>
+              <a:t>  Connectionist Temporal Classification (CTC)</a:t>
             </a:r>
           </a:p>
         </p:txBody>
@@ -4254,7 +4259,7 @@
               </a:defRPr>
             </a:pPr>
             <a:r>
-              <a:t>• Contour classified as UnknownRegion (damage) if and only if:</a:t>
+              <a:t>• Eliminates manual character timestamp alignment:</a:t>
             </a:r>
           </a:p>
           <a:p>
@@ -4269,7 +4274,7 @@
               </a:defRPr>
             </a:pPr>
             <a:r>
-              <a:t>• Damage regions are masked prior to text OCR inference.</a:t>
+              <a:t>• Collapse operator B removes consecutive duplicates &amp; blanks:</a:t>
             </a:r>
           </a:p>
           <a:p>
@@ -4284,7 +4289,7 @@
               </a:defRPr>
             </a:pPr>
             <a:r>
-              <a:t>• Prevents false-positive character hallucinations (e.g. 'Tha').</a:t>
+              <a:t>• Beam Search with Sanskrit Language Model LM:</a:t>
             </a:r>
           </a:p>
           <a:p>
@@ -4300,11 +4305,15 @@
               </a:defRPr>
             </a:pPr>
             <a:r>
-              <a:t>C in R_damage &lt;==&gt; (500 &lt;= Area &lt;= 8000) and (Psi &gt; 0.85) and (0.5 &lt;= W/H &lt;= 2.0)</a:t>
+              <a:t>P(Y|X) = Sum_{pi in B^(-1)(Y)} Product_{t=1}^T y_{pi_t}^t</a:t>
             </a:r>
             <a:br/>
             <a:r>
-              <a:t>Eliminates 99.4% of false damage classifications.</a:t>
+              <a:t>Y_hat = argmax_Y [ log P_CTC(Y|X) + alpha·log P_LM(Y) + beta·|Y| ]</a:t>
+            </a:r>
+            <a:br/>
+            <a:r>
+              <a:t>P_LM enforces valid Sanskrit root grammar.</a:t>
             </a:r>
           </a:p>
         </p:txBody>
@@ -4339,7 +4348,7 @@
               </a:defRPr>
             </a:pPr>
             <a:r>
-              <a:t>Slide 11 / 16</a:t>
+              <a:t>Slide 11 / 17</a:t>
             </a:r>
           </a:p>
         </p:txBody>
@@ -4392,7 +4401,7 @@
               </a:defRPr>
             </a:pPr>
             <a:r>
-              <a:t>SECTION 3: VISUAL RESULTS</a:t>
+              <a:t>SECTION 2: METHODOLOGY</a:t>
             </a:r>
           </a:p>
         </p:txBody>
@@ -4427,7 +4436,7 @@
               </a:defRPr>
             </a:pPr>
             <a:r>
-              <a:t>Visual Document Layout Parsing: Degraded Lithographic Folio</a:t>
+              <a:t>Topological Discrimination of Physical Damage</a:t>
             </a:r>
           </a:p>
         </p:txBody>
@@ -4462,62 +4471,384 @@
               </a:defRPr>
             </a:pPr>
             <a:r>
-              <a:t>Side-by-Side Verification of Segmented Bounding Polygons</a:t>
-            </a:r>
-          </a:p>
-        </p:txBody>
-      </p:sp>
-      <p:pic>
-        <p:nvPicPr>
-          <p:cNvPr id="5" name="Picture 4" descr="input_folio.jpg"/>
-          <p:cNvPicPr>
-            <a:picLocks noChangeAspect="1"/>
-          </p:cNvPicPr>
-          <p:nvPr/>
-        </p:nvPicPr>
-        <p:blipFill>
-          <a:blip r:embed="rId2"/>
-          <a:stretch>
-            <a:fillRect/>
-          </a:stretch>
-        </p:blipFill>
-        <p:spPr>
-          <a:xfrm>
-            <a:off x="731520" y="1645920"/>
-            <a:ext cx="5120640" cy="4389120"/>
+              <a:t>Isoperimetric Quotient and Circularity Geometry</a:t>
+            </a:r>
+          </a:p>
+        </p:txBody>
+      </p:sp>
+      <p:sp>
+        <p:nvSpPr>
+          <p:cNvPr id="5" name="Rounded Rectangle 4"/>
+          <p:cNvSpPr/>
+          <p:nvPr/>
+        </p:nvSpPr>
+        <p:spPr>
+          <a:xfrm>
+            <a:off x="731520" y="1554480"/>
+            <a:ext cx="5212080" cy="4663440"/>
+          </a:xfrm>
+          <a:prstGeom prst="roundRect">
+            <a:avLst/>
+          </a:prstGeom>
+          <a:solidFill>
+            <a:srgbClr val="F5F7FA"/>
+          </a:solidFill>
+          <a:ln w="15240">
+            <a:solidFill>
+              <a:srgbClr val="CBD5E1"/>
+            </a:solidFill>
+          </a:ln>
+        </p:spPr>
+        <p:style>
+          <a:lnRef idx="1">
+            <a:schemeClr val="accent1"/>
+          </a:lnRef>
+          <a:fillRef idx="3">
+            <a:schemeClr val="accent1"/>
+          </a:fillRef>
+          <a:effectRef idx="2">
+            <a:schemeClr val="accent1"/>
+          </a:effectRef>
+          <a:fontRef idx="minor">
+            <a:schemeClr val="lt1"/>
+          </a:fontRef>
+        </p:style>
+        <p:txBody>
+          <a:bodyPr rtlCol="0" anchor="ctr"/>
+          <a:lstStyle/>
+          <a:p>
+            <a:pPr algn="ctr"/>
+          </a:p>
+        </p:txBody>
+      </p:sp>
+      <p:sp>
+        <p:nvSpPr>
+          <p:cNvPr id="6" name="Rounded Rectangle 5"/>
+          <p:cNvSpPr/>
+          <p:nvPr/>
+        </p:nvSpPr>
+        <p:spPr>
+          <a:xfrm>
+            <a:off x="731520" y="1554480"/>
+            <a:ext cx="5212080" cy="438912"/>
+          </a:xfrm>
+          <a:prstGeom prst="roundRect">
+            <a:avLst/>
+          </a:prstGeom>
+          <a:solidFill>
+            <a:srgbClr val="0000DC"/>
+          </a:solidFill>
+          <a:ln>
+            <a:noFill/>
+          </a:ln>
+        </p:spPr>
+        <p:style>
+          <a:lnRef idx="1">
+            <a:schemeClr val="accent1"/>
+          </a:lnRef>
+          <a:fillRef idx="3">
+            <a:schemeClr val="accent1"/>
+          </a:fillRef>
+          <a:effectRef idx="2">
+            <a:schemeClr val="accent1"/>
+          </a:effectRef>
+          <a:fontRef idx="minor">
+            <a:schemeClr val="lt1"/>
+          </a:fontRef>
+        </p:style>
+        <p:txBody>
+          <a:bodyPr rtlCol="0" anchor="ctr"/>
+          <a:lstStyle/>
+          <a:p>
+            <a:pPr algn="ctr">
+              <a:defRPr sz="1300" b="1">
+                <a:solidFill>
+                  <a:srgbClr val="FFFFFF"/>
+                </a:solidFill>
+              </a:defRPr>
+            </a:pPr>
+            <a:r>
+              <a:t>  Isoperimetric Circularity Formulation</a:t>
+            </a:r>
+          </a:p>
+        </p:txBody>
+      </p:sp>
+      <p:sp>
+        <p:nvSpPr>
+          <p:cNvPr id="7" name="TextBox 6"/>
+          <p:cNvSpPr txBox="1"/>
+          <p:nvPr/>
+        </p:nvSpPr>
+        <p:spPr>
+          <a:xfrm>
+            <a:off x="914400" y="2057400"/>
+            <a:ext cx="4846320" cy="4069080"/>
           </a:xfrm>
           <a:prstGeom prst="rect">
             <a:avLst/>
           </a:prstGeom>
-        </p:spPr>
-      </p:pic>
-      <p:pic>
-        <p:nvPicPr>
-          <p:cNvPr id="6" name="Picture 5" descr="output_annotation.jpg"/>
-          <p:cNvPicPr>
-            <a:picLocks noChangeAspect="1"/>
-          </p:cNvPicPr>
-          <p:nvPr/>
-        </p:nvPicPr>
-        <p:blipFill>
-          <a:blip r:embed="rId3"/>
-          <a:stretch>
-            <a:fillRect/>
-          </a:stretch>
-        </p:blipFill>
-        <p:spPr>
-          <a:xfrm>
-            <a:off x="6217920" y="1645920"/>
-            <a:ext cx="5120640" cy="4389120"/>
+          <a:noFill/>
+        </p:spPr>
+        <p:txBody>
+          <a:bodyPr wrap="square">
+            <a:spAutoFit/>
+          </a:bodyPr>
+          <a:lstStyle/>
+          <a:p>
+            <a:pPr>
+              <a:spcAft>
+                <a:spcPts val="400"/>
+              </a:spcAft>
+              <a:defRPr sz="1150">
+                <a:solidFill>
+                  <a:srgbClr val="1E293B"/>
+                </a:solidFill>
+              </a:defRPr>
+            </a:pPr>
+            <a:r>
+              <a:t>• Punched palm-leaf binder string holes form near-perfect circles.</a:t>
+            </a:r>
+          </a:p>
+          <a:p>
+            <a:pPr>
+              <a:spcAft>
+                <a:spcPts val="400"/>
+              </a:spcAft>
+              <a:defRPr sz="1150">
+                <a:solidFill>
+                  <a:srgbClr val="1E293B"/>
+                </a:solidFill>
+              </a:defRPr>
+            </a:pPr>
+            <a:r>
+              <a:t>• Circularity metric Psi for internal contour C:</a:t>
+            </a:r>
+          </a:p>
+          <a:p>
+            <a:pPr>
+              <a:spcAft>
+                <a:spcPts val="400"/>
+              </a:spcAft>
+              <a:defRPr sz="1150">
+                <a:solidFill>
+                  <a:srgbClr val="1E293B"/>
+                </a:solidFill>
+              </a:defRPr>
+            </a:pPr>
+            <a:r>
+              <a:t>• True holes exhibit Psi &gt; 0.85 with square aspect ratio.</a:t>
+            </a:r>
+          </a:p>
+          <a:p>
+            <a:br/>
+            <a:pPr>
+              <a:spcAft>
+                <a:spcPts val="400"/>
+              </a:spcAft>
+              <a:defRPr sz="1150" b="1">
+                <a:solidFill>
+                  <a:srgbClr val="0000DC"/>
+                </a:solidFill>
+              </a:defRPr>
+            </a:pPr>
+            <a:r>
+              <a:t>Psi(C) = (4 · pi · Area(C)) / [Perimeter(C)]^2</a:t>
+            </a:r>
+            <a:br/>
+            <a:r>
+              <a:t>500 px &lt;= Area(C) &lt;= 8000 px</a:t>
+            </a:r>
+          </a:p>
+        </p:txBody>
+      </p:sp>
+      <p:sp>
+        <p:nvSpPr>
+          <p:cNvPr id="8" name="Rounded Rectangle 7"/>
+          <p:cNvSpPr/>
+          <p:nvPr/>
+        </p:nvSpPr>
+        <p:spPr>
+          <a:xfrm>
+            <a:off x="6217920" y="1554480"/>
+            <a:ext cx="5212080" cy="4663440"/>
+          </a:xfrm>
+          <a:prstGeom prst="roundRect">
+            <a:avLst/>
+          </a:prstGeom>
+          <a:solidFill>
+            <a:srgbClr val="F5F7FA"/>
+          </a:solidFill>
+          <a:ln w="15240">
+            <a:solidFill>
+              <a:srgbClr val="CBD5E1"/>
+            </a:solidFill>
+          </a:ln>
+        </p:spPr>
+        <p:style>
+          <a:lnRef idx="1">
+            <a:schemeClr val="accent1"/>
+          </a:lnRef>
+          <a:fillRef idx="3">
+            <a:schemeClr val="accent1"/>
+          </a:fillRef>
+          <a:effectRef idx="2">
+            <a:schemeClr val="accent1"/>
+          </a:effectRef>
+          <a:fontRef idx="minor">
+            <a:schemeClr val="lt1"/>
+          </a:fontRef>
+        </p:style>
+        <p:txBody>
+          <a:bodyPr rtlCol="0" anchor="ctr"/>
+          <a:lstStyle/>
+          <a:p>
+            <a:pPr algn="ctr"/>
+          </a:p>
+        </p:txBody>
+      </p:sp>
+      <p:sp>
+        <p:nvSpPr>
+          <p:cNvPr id="9" name="Rounded Rectangle 8"/>
+          <p:cNvSpPr/>
+          <p:nvPr/>
+        </p:nvSpPr>
+        <p:spPr>
+          <a:xfrm>
+            <a:off x="6217920" y="1554480"/>
+            <a:ext cx="5212080" cy="438912"/>
+          </a:xfrm>
+          <a:prstGeom prst="roundRect">
+            <a:avLst/>
+          </a:prstGeom>
+          <a:solidFill>
+            <a:srgbClr val="0000DC"/>
+          </a:solidFill>
+          <a:ln>
+            <a:noFill/>
+          </a:ln>
+        </p:spPr>
+        <p:style>
+          <a:lnRef idx="1">
+            <a:schemeClr val="accent1"/>
+          </a:lnRef>
+          <a:fillRef idx="3">
+            <a:schemeClr val="accent1"/>
+          </a:fillRef>
+          <a:effectRef idx="2">
+            <a:schemeClr val="accent1"/>
+          </a:effectRef>
+          <a:fontRef idx="minor">
+            <a:schemeClr val="lt1"/>
+          </a:fontRef>
+        </p:style>
+        <p:txBody>
+          <a:bodyPr rtlCol="0" anchor="ctr"/>
+          <a:lstStyle/>
+          <a:p>
+            <a:pPr algn="ctr">
+              <a:defRPr sz="1300" b="1">
+                <a:solidFill>
+                  <a:srgbClr val="FFFFFF"/>
+                </a:solidFill>
+              </a:defRPr>
+            </a:pPr>
+            <a:r>
+              <a:t>  Geometric Damage Isolation Rule</a:t>
+            </a:r>
+          </a:p>
+        </p:txBody>
+      </p:sp>
+      <p:sp>
+        <p:nvSpPr>
+          <p:cNvPr id="10" name="TextBox 9"/>
+          <p:cNvSpPr txBox="1"/>
+          <p:nvPr/>
+        </p:nvSpPr>
+        <p:spPr>
+          <a:xfrm>
+            <a:off x="6400800" y="2057400"/>
+            <a:ext cx="4846320" cy="4069080"/>
           </a:xfrm>
           <a:prstGeom prst="rect">
             <a:avLst/>
           </a:prstGeom>
-        </p:spPr>
-      </p:pic>
-      <p:sp>
-        <p:nvSpPr>
-          <p:cNvPr id="7" name="TextBox 6"/>
+          <a:noFill/>
+        </p:spPr>
+        <p:txBody>
+          <a:bodyPr wrap="square">
+            <a:spAutoFit/>
+          </a:bodyPr>
+          <a:lstStyle/>
+          <a:p>
+            <a:pPr>
+              <a:spcAft>
+                <a:spcPts val="400"/>
+              </a:spcAft>
+              <a:defRPr sz="1150">
+                <a:solidFill>
+                  <a:srgbClr val="1E293B"/>
+                </a:solidFill>
+              </a:defRPr>
+            </a:pPr>
+            <a:r>
+              <a:t>• Contour classified as UnknownRegion (damage) if and only if:</a:t>
+            </a:r>
+          </a:p>
+          <a:p>
+            <a:pPr>
+              <a:spcAft>
+                <a:spcPts val="400"/>
+              </a:spcAft>
+              <a:defRPr sz="1150">
+                <a:solidFill>
+                  <a:srgbClr val="1E293B"/>
+                </a:solidFill>
+              </a:defRPr>
+            </a:pPr>
+            <a:r>
+              <a:t>• Damage regions are masked prior to text OCR inference.</a:t>
+            </a:r>
+          </a:p>
+          <a:p>
+            <a:pPr>
+              <a:spcAft>
+                <a:spcPts val="400"/>
+              </a:spcAft>
+              <a:defRPr sz="1150">
+                <a:solidFill>
+                  <a:srgbClr val="1E293B"/>
+                </a:solidFill>
+              </a:defRPr>
+            </a:pPr>
+            <a:r>
+              <a:t>• Prevents false-positive character hallucinations (e.g. 'Tha').</a:t>
+            </a:r>
+          </a:p>
+          <a:p>
+            <a:br/>
+            <a:pPr>
+              <a:spcAft>
+                <a:spcPts val="400"/>
+              </a:spcAft>
+              <a:defRPr sz="1150" b="1">
+                <a:solidFill>
+                  <a:srgbClr val="0000DC"/>
+                </a:solidFill>
+              </a:defRPr>
+            </a:pPr>
+            <a:r>
+              <a:t>C in R_damage &lt;==&gt; (500 &lt;= Area &lt;= 8000) and (Psi &gt; 0.85) and (0.5 &lt;= W/H &lt;= 2.0)</a:t>
+            </a:r>
+            <a:br/>
+            <a:r>
+              <a:t>Eliminates 99.4% of false damage classifications.</a:t>
+            </a:r>
+          </a:p>
+        </p:txBody>
+      </p:sp>
+      <p:sp>
+        <p:nvSpPr>
+          <p:cNvPr id="11" name="TextBox 10"/>
           <p:cNvSpPr txBox="1"/>
           <p:nvPr/>
         </p:nvSpPr>
@@ -4545,7 +4876,7 @@
               </a:defRPr>
             </a:pPr>
             <a:r>
-              <a:t>Slide 12 / 16</a:t>
+              <a:t>Slide 12 / 17</a:t>
             </a:r>
           </a:p>
         </p:txBody>
@@ -4633,7 +4964,7 @@
               </a:defRPr>
             </a:pPr>
             <a:r>
-              <a:t>Visual Document Layout Parsing: Palm-Leaf Manuscript</a:t>
+              <a:t>Visual Document Layout Parsing: Degraded Lithographic Folio</a:t>
             </a:r>
           </a:p>
         </p:txBody>
@@ -4668,14 +4999,14 @@
               </a:defRPr>
             </a:pPr>
             <a:r>
-              <a:t>Topological Binder Hole Isolation and Text Line Boundaries</a:t>
+              <a:t>Side-by-Side Verification of Segmented Bounding Polygons</a:t>
             </a:r>
           </a:p>
         </p:txBody>
       </p:sp>
       <p:pic>
         <p:nvPicPr>
-          <p:cNvPr id="5" name="Picture 4" descr="input_leaf.jpg"/>
+          <p:cNvPr id="5" name="Picture 4" descr="input_folio.jpg"/>
           <p:cNvPicPr>
             <a:picLocks noChangeAspect="1"/>
           </p:cNvPicPr>
@@ -4699,7 +5030,7 @@
       </p:pic>
       <p:pic>
         <p:nvPicPr>
-          <p:cNvPr id="6" name="Picture 5" descr="output_leaf.jpg"/>
+          <p:cNvPr id="6" name="Picture 5" descr="output_annotation.jpg"/>
           <p:cNvPicPr>
             <a:picLocks noChangeAspect="1"/>
           </p:cNvPicPr>
@@ -4751,7 +5082,7 @@
               </a:defRPr>
             </a:pPr>
             <a:r>
-              <a:t>Slide 13 / 16</a:t>
+              <a:t>Slide 13 / 17</a:t>
             </a:r>
           </a:p>
         </p:txBody>
@@ -4804,7 +5135,7 @@
               </a:defRPr>
             </a:pPr>
             <a:r>
-              <a:t>SECTION 3: EXPERIMENTAL RESULTS</a:t>
+              <a:t>SECTION 3: VISUAL RESULTS</a:t>
             </a:r>
           </a:p>
         </p:txBody>
@@ -4839,7 +5170,7 @@
               </a:defRPr>
             </a:pPr>
             <a:r>
-              <a:t>Experimental Evaluation over 1,054 Degraded Folios</a:t>
+              <a:t>Visual Document Layout Parsing: Palm-Leaf Manuscript</a:t>
             </a:r>
           </a:p>
         </p:txBody>
@@ -4874,418 +5205,62 @@
               </a:defRPr>
             </a:pPr>
             <a:r>
-              <a:t>Levenshtein Edit Distance Formulations and Benchmark Comparison</a:t>
-            </a:r>
-          </a:p>
-        </p:txBody>
-      </p:sp>
-      <p:sp>
-        <p:nvSpPr>
-          <p:cNvPr id="5" name="Rounded Rectangle 4"/>
-          <p:cNvSpPr/>
-          <p:nvPr/>
-        </p:nvSpPr>
-        <p:spPr>
-          <a:xfrm>
-            <a:off x="731520" y="1554480"/>
-            <a:ext cx="5212080" cy="4663440"/>
-          </a:xfrm>
-          <a:prstGeom prst="roundRect">
-            <a:avLst/>
-          </a:prstGeom>
-          <a:solidFill>
-            <a:srgbClr val="F5F7FA"/>
-          </a:solidFill>
-          <a:ln w="15240">
-            <a:solidFill>
-              <a:srgbClr val="CBD5E1"/>
-            </a:solidFill>
-          </a:ln>
-        </p:spPr>
-        <p:style>
-          <a:lnRef idx="1">
-            <a:schemeClr val="accent1"/>
-          </a:lnRef>
-          <a:fillRef idx="3">
-            <a:schemeClr val="accent1"/>
-          </a:fillRef>
-          <a:effectRef idx="2">
-            <a:schemeClr val="accent1"/>
-          </a:effectRef>
-          <a:fontRef idx="minor">
-            <a:schemeClr val="lt1"/>
-          </a:fontRef>
-        </p:style>
-        <p:txBody>
-          <a:bodyPr rtlCol="0" anchor="ctr"/>
-          <a:lstStyle/>
-          <a:p>
-            <a:pPr algn="ctr"/>
-          </a:p>
-        </p:txBody>
-      </p:sp>
-      <p:sp>
-        <p:nvSpPr>
-          <p:cNvPr id="6" name="Rounded Rectangle 5"/>
-          <p:cNvSpPr/>
-          <p:nvPr/>
-        </p:nvSpPr>
-        <p:spPr>
-          <a:xfrm>
-            <a:off x="731520" y="1554480"/>
-            <a:ext cx="5212080" cy="438912"/>
-          </a:xfrm>
-          <a:prstGeom prst="roundRect">
-            <a:avLst/>
-          </a:prstGeom>
-          <a:solidFill>
-            <a:srgbClr val="0000DC"/>
-          </a:solidFill>
-          <a:ln>
-            <a:noFill/>
-          </a:ln>
-        </p:spPr>
-        <p:style>
-          <a:lnRef idx="1">
-            <a:schemeClr val="accent1"/>
-          </a:lnRef>
-          <a:fillRef idx="3">
-            <a:schemeClr val="accent1"/>
-          </a:fillRef>
-          <a:effectRef idx="2">
-            <a:schemeClr val="accent1"/>
-          </a:effectRef>
-          <a:fontRef idx="minor">
-            <a:schemeClr val="lt1"/>
-          </a:fontRef>
-        </p:style>
-        <p:txBody>
-          <a:bodyPr rtlCol="0" anchor="ctr"/>
-          <a:lstStyle/>
-          <a:p>
-            <a:pPr algn="ctr">
-              <a:defRPr sz="1300" b="1">
-                <a:solidFill>
-                  <a:srgbClr val="FFFFFF"/>
-                </a:solidFill>
-              </a:defRPr>
-            </a:pPr>
-            <a:r>
-              <a:t>  Metric Formulations (CER and WER)</a:t>
-            </a:r>
-          </a:p>
-        </p:txBody>
-      </p:sp>
+              <a:t>Topological Binder Hole Isolation and Text Line Boundaries</a:t>
+            </a:r>
+          </a:p>
+        </p:txBody>
+      </p:sp>
+      <p:pic>
+        <p:nvPicPr>
+          <p:cNvPr id="5" name="Picture 4" descr="input_leaf.jpg"/>
+          <p:cNvPicPr>
+            <a:picLocks noChangeAspect="1"/>
+          </p:cNvPicPr>
+          <p:nvPr/>
+        </p:nvPicPr>
+        <p:blipFill>
+          <a:blip r:embed="rId2"/>
+          <a:stretch>
+            <a:fillRect/>
+          </a:stretch>
+        </p:blipFill>
+        <p:spPr>
+          <a:xfrm>
+            <a:off x="731520" y="1645920"/>
+            <a:ext cx="5120640" cy="4389120"/>
+          </a:xfrm>
+          <a:prstGeom prst="rect">
+            <a:avLst/>
+          </a:prstGeom>
+        </p:spPr>
+      </p:pic>
+      <p:pic>
+        <p:nvPicPr>
+          <p:cNvPr id="6" name="Picture 5" descr="output_leaf.jpg"/>
+          <p:cNvPicPr>
+            <a:picLocks noChangeAspect="1"/>
+          </p:cNvPicPr>
+          <p:nvPr/>
+        </p:nvPicPr>
+        <p:blipFill>
+          <a:blip r:embed="rId3"/>
+          <a:stretch>
+            <a:fillRect/>
+          </a:stretch>
+        </p:blipFill>
+        <p:spPr>
+          <a:xfrm>
+            <a:off x="6217920" y="1645920"/>
+            <a:ext cx="5120640" cy="4389120"/>
+          </a:xfrm>
+          <a:prstGeom prst="rect">
+            <a:avLst/>
+          </a:prstGeom>
+        </p:spPr>
+      </p:pic>
       <p:sp>
         <p:nvSpPr>
           <p:cNvPr id="7" name="TextBox 6"/>
-          <p:cNvSpPr txBox="1"/>
-          <p:nvPr/>
-        </p:nvSpPr>
-        <p:spPr>
-          <a:xfrm>
-            <a:off x="914400" y="2057400"/>
-            <a:ext cx="4846320" cy="4069080"/>
-          </a:xfrm>
-          <a:prstGeom prst="rect">
-            <a:avLst/>
-          </a:prstGeom>
-          <a:noFill/>
-        </p:spPr>
-        <p:txBody>
-          <a:bodyPr wrap="square">
-            <a:spAutoFit/>
-          </a:bodyPr>
-          <a:lstStyle/>
-          <a:p>
-            <a:pPr>
-              <a:spcAft>
-                <a:spcPts val="400"/>
-              </a:spcAft>
-              <a:defRPr sz="1150">
-                <a:solidFill>
-                  <a:srgbClr val="1E293B"/>
-                </a:solidFill>
-              </a:defRPr>
-            </a:pPr>
-            <a:r>
-              <a:t>• Character Error Rate (CER) and Word Error Rate (WER):</a:t>
-            </a:r>
-          </a:p>
-          <a:p>
-            <a:pPr>
-              <a:spcAft>
-                <a:spcPts val="400"/>
-              </a:spcAft>
-              <a:defRPr sz="1150">
-                <a:solidFill>
-                  <a:srgbClr val="1E293B"/>
-                </a:solidFill>
-              </a:defRPr>
-            </a:pPr>
-            <a:r>
-              <a:t>• Computed via dynamic programming Levenshtein distance:</a:t>
-            </a:r>
-          </a:p>
-          <a:p>
-            <a:pPr>
-              <a:spcAft>
-                <a:spcPts val="400"/>
-              </a:spcAft>
-              <a:defRPr sz="1150">
-                <a:solidFill>
-                  <a:srgbClr val="1E293B"/>
-                </a:solidFill>
-              </a:defRPr>
-            </a:pPr>
-            <a:r>
-              <a:t>• Accuracy = max(0, 1.0 - CER).</a:t>
-            </a:r>
-          </a:p>
-          <a:p>
-            <a:br/>
-            <a:pPr>
-              <a:spcAft>
-                <a:spcPts val="400"/>
-              </a:spcAft>
-              <a:defRPr sz="1150" b="1">
-                <a:solidFill>
-                  <a:srgbClr val="0000DC"/>
-                </a:solidFill>
-              </a:defRPr>
-            </a:pPr>
-            <a:r>
-              <a:t>CER = (Sum D_Lev(S_pred, S_gt)) / (Sum Length(S_gt))</a:t>
-            </a:r>
-            <a:br/>
-            <a:r>
-              <a:t>WER = (Sum D_Lev(W_pred, W_gt)) / (Sum |W_gt|)</a:t>
-            </a:r>
-            <a:br/>
-            <a:r>
-              <a:t>D(i,j) = min( D(i-1,j)+1, D(i,j-1)+1, D(i-1,j-1)+I(a_i != b_j) )</a:t>
-            </a:r>
-          </a:p>
-        </p:txBody>
-      </p:sp>
-      <p:sp>
-        <p:nvSpPr>
-          <p:cNvPr id="8" name="Rounded Rectangle 7"/>
-          <p:cNvSpPr/>
-          <p:nvPr/>
-        </p:nvSpPr>
-        <p:spPr>
-          <a:xfrm>
-            <a:off x="6217920" y="1554480"/>
-            <a:ext cx="5212080" cy="4663440"/>
-          </a:xfrm>
-          <a:prstGeom prst="roundRect">
-            <a:avLst/>
-          </a:prstGeom>
-          <a:solidFill>
-            <a:srgbClr val="F5F7FA"/>
-          </a:solidFill>
-          <a:ln w="15240">
-            <a:solidFill>
-              <a:srgbClr val="CBD5E1"/>
-            </a:solidFill>
-          </a:ln>
-        </p:spPr>
-        <p:style>
-          <a:lnRef idx="1">
-            <a:schemeClr val="accent1"/>
-          </a:lnRef>
-          <a:fillRef idx="3">
-            <a:schemeClr val="accent1"/>
-          </a:fillRef>
-          <a:effectRef idx="2">
-            <a:schemeClr val="accent1"/>
-          </a:effectRef>
-          <a:fontRef idx="minor">
-            <a:schemeClr val="lt1"/>
-          </a:fontRef>
-        </p:style>
-        <p:txBody>
-          <a:bodyPr rtlCol="0" anchor="ctr"/>
-          <a:lstStyle/>
-          <a:p>
-            <a:pPr algn="ctr"/>
-          </a:p>
-        </p:txBody>
-      </p:sp>
-      <p:sp>
-        <p:nvSpPr>
-          <p:cNvPr id="9" name="Rounded Rectangle 8"/>
-          <p:cNvSpPr/>
-          <p:nvPr/>
-        </p:nvSpPr>
-        <p:spPr>
-          <a:xfrm>
-            <a:off x="6217920" y="1554480"/>
-            <a:ext cx="5212080" cy="438912"/>
-          </a:xfrm>
-          <a:prstGeom prst="roundRect">
-            <a:avLst/>
-          </a:prstGeom>
-          <a:solidFill>
-            <a:srgbClr val="0000DC"/>
-          </a:solidFill>
-          <a:ln>
-            <a:noFill/>
-          </a:ln>
-        </p:spPr>
-        <p:style>
-          <a:lnRef idx="1">
-            <a:schemeClr val="accent1"/>
-          </a:lnRef>
-          <a:fillRef idx="3">
-            <a:schemeClr val="accent1"/>
-          </a:fillRef>
-          <a:effectRef idx="2">
-            <a:schemeClr val="accent1"/>
-          </a:effectRef>
-          <a:fontRef idx="minor">
-            <a:schemeClr val="lt1"/>
-          </a:fontRef>
-        </p:style>
-        <p:txBody>
-          <a:bodyPr rtlCol="0" anchor="ctr"/>
-          <a:lstStyle/>
-          <a:p>
-            <a:pPr algn="ctr">
-              <a:defRPr sz="1300" b="1">
-                <a:solidFill>
-                  <a:srgbClr val="FFFFFF"/>
-                </a:solidFill>
-              </a:defRPr>
-            </a:pPr>
-            <a:r>
-              <a:t>  Quantitative Benchmark Results (1,054 Pages)</a:t>
-            </a:r>
-          </a:p>
-        </p:txBody>
-      </p:sp>
-      <p:sp>
-        <p:nvSpPr>
-          <p:cNvPr id="10" name="TextBox 9"/>
-          <p:cNvSpPr txBox="1"/>
-          <p:nvPr/>
-        </p:nvSpPr>
-        <p:spPr>
-          <a:xfrm>
-            <a:off x="6400800" y="2057400"/>
-            <a:ext cx="4846320" cy="4069080"/>
-          </a:xfrm>
-          <a:prstGeom prst="rect">
-            <a:avLst/>
-          </a:prstGeom>
-          <a:noFill/>
-        </p:spPr>
-        <p:txBody>
-          <a:bodyPr wrap="square">
-            <a:spAutoFit/>
-          </a:bodyPr>
-          <a:lstStyle/>
-          <a:p>
-            <a:pPr>
-              <a:spcAft>
-                <a:spcPts val="400"/>
-              </a:spcAft>
-              <a:defRPr sz="1150">
-                <a:solidFill>
-                  <a:srgbClr val="1E293B"/>
-                </a:solidFill>
-              </a:defRPr>
-            </a:pPr>
-            <a:r>
-              <a:t>• Proposed Framework: CER = 15.32%, WER = 9.97%, Accuracy = 84.50%</a:t>
-            </a:r>
-          </a:p>
-          <a:p>
-            <a:pPr>
-              <a:spcAft>
-                <a:spcPts val="400"/>
-              </a:spcAft>
-              <a:defRPr sz="1150">
-                <a:solidFill>
-                  <a:srgbClr val="1E293B"/>
-                </a:solidFill>
-              </a:defRPr>
-            </a:pPr>
-            <a:r>
-              <a:t>• Tesseract 5 Baseline: CER = 47.82%, WER = 58.30%, Accuracy = 52.18%</a:t>
-            </a:r>
-          </a:p>
-          <a:p>
-            <a:pPr>
-              <a:spcAft>
-                <a:spcPts val="400"/>
-              </a:spcAft>
-              <a:defRPr sz="1150">
-                <a:solidFill>
-                  <a:srgbClr val="1E293B"/>
-                </a:solidFill>
-              </a:defRPr>
-            </a:pPr>
-            <a:r>
-              <a:t>• Kraken HTR Baseline: CER = 38.60%, WER = 44.12%, Accuracy = 61.40%</a:t>
-            </a:r>
-          </a:p>
-          <a:p>
-            <a:pPr>
-              <a:spcAft>
-                <a:spcPts val="400"/>
-              </a:spcAft>
-              <a:defRPr sz="1150">
-                <a:solidFill>
-                  <a:srgbClr val="1E293B"/>
-                </a:solidFill>
-              </a:defRPr>
-            </a:pPr>
-            <a:r>
-              <a:t>• Supervised LayoutLMv3: CER = 26.90%, WER = 31.85%, Accuracy = 73.10%</a:t>
-            </a:r>
-          </a:p>
-          <a:p>
-            <a:pPr>
-              <a:spcAft>
-                <a:spcPts val="400"/>
-              </a:spcAft>
-              <a:defRPr sz="1150">
-                <a:solidFill>
-                  <a:srgbClr val="1E293B"/>
-                </a:solidFill>
-              </a:defRPr>
-            </a:pPr>
-            <a:r>
-              <a:t>• Demonstrates 3.12x error reduction over classical OCR.</a:t>
-            </a:r>
-          </a:p>
-          <a:p>
-            <a:br/>
-            <a:pPr>
-              <a:spcAft>
-                <a:spcPts val="400"/>
-              </a:spcAft>
-              <a:defRPr sz="1150" b="1">
-                <a:solidFill>
-                  <a:srgbClr val="0000DC"/>
-                </a:solidFill>
-              </a:defRPr>
-            </a:pPr>
-            <a:r>
-              <a:t>Overall Accuracy: 84.50%</a:t>
-            </a:r>
-            <a:br/>
-            <a:r>
-              <a:t>Zero Empty Predictions (0.00%) across all test folios.</a:t>
-            </a:r>
-          </a:p>
-        </p:txBody>
-      </p:sp>
-      <p:sp>
-        <p:nvSpPr>
-          <p:cNvPr id="11" name="TextBox 10"/>
           <p:cNvSpPr txBox="1"/>
           <p:nvPr/>
         </p:nvSpPr>
@@ -5313,7 +5288,7 @@
               </a:defRPr>
             </a:pPr>
             <a:r>
-              <a:t>Slide 14 / 16</a:t>
+              <a:t>Slide 14 / 17</a:t>
             </a:r>
           </a:p>
         </p:txBody>
@@ -5401,7 +5376,7 @@
               </a:defRPr>
             </a:pPr>
             <a:r>
-              <a:t>Semantic Layout Segmentation and Human Effort Evaluation</a:t>
+              <a:t>Experimental Evaluation over 1,054 Degraded Folios</a:t>
             </a:r>
           </a:p>
         </p:txBody>
@@ -5436,7 +5411,7 @@
               </a:defRPr>
             </a:pPr>
             <a:r>
-              <a:t>Instance-Level F1-Scores and Paleographer Latency Reduction</a:t>
+              <a:t>Levenshtein Edit Distance Formulations and Benchmark Comparison</a:t>
             </a:r>
           </a:p>
         </p:txBody>
@@ -5533,7 +5508,7 @@
               </a:defRPr>
             </a:pPr>
             <a:r>
-              <a:t>  1. Semantic Layout F1-Scores</a:t>
+              <a:t>  Metric Formulations (CER and WER)</a:t>
             </a:r>
           </a:p>
         </p:txBody>
@@ -5571,7 +5546,7 @@
               </a:defRPr>
             </a:pPr>
             <a:r>
-              <a:t>• TextRegion F1: 0.951 (Precision: 0.942, Recall: 0.961)</a:t>
+              <a:t>• Character Error Rate (CER) and Word Error Rate (WER):</a:t>
             </a:r>
           </a:p>
           <a:p>
@@ -5586,7 +5561,7 @@
               </a:defRPr>
             </a:pPr>
             <a:r>
-              <a:t>• TextLine F1: 0.926 (Precision: 0.918, Recall: 0.935)</a:t>
+              <a:t>• Computed via dynamic programming Levenshtein distance:</a:t>
             </a:r>
           </a:p>
           <a:p>
@@ -5601,53 +5576,31 @@
               </a:defRPr>
             </a:pPr>
             <a:r>
-              <a:t>• GraphicRegion F1: 0.907 (Precision: 0.925, Recall: 0.890)</a:t>
-            </a:r>
-          </a:p>
-          <a:p>
+              <a:t>• Accuracy = max(0, 1.0 - CER).</a:t>
+            </a:r>
+          </a:p>
+          <a:p>
+            <a:br/>
             <a:pPr>
               <a:spcAft>
                 <a:spcPts val="400"/>
               </a:spcAft>
-              <a:defRPr sz="1150">
-                <a:solidFill>
-                  <a:srgbClr val="1E293B"/>
-                </a:solidFill>
-              </a:defRPr>
-            </a:pPr>
-            <a:r>
-              <a:t>• Damage / Binder Hole F1: 0.954 (Precision: 0.968, Recall: 0.941)</a:t>
-            </a:r>
-          </a:p>
-          <a:p>
-            <a:pPr>
-              <a:spcAft>
-                <a:spcPts val="400"/>
-              </a:spcAft>
-              <a:defRPr sz="1150">
-                <a:solidFill>
-                  <a:srgbClr val="1E293B"/>
-                </a:solidFill>
-              </a:defRPr>
-            </a:pPr>
-            <a:r>
-              <a:t>• PageFrame F1: 0.988 | Overall Layout Mean F1: 0.932</a:t>
-            </a:r>
-          </a:p>
-          <a:p>
+              <a:defRPr sz="1150" b="1">
+                <a:solidFill>
+                  <a:srgbClr val="0000DC"/>
+                </a:solidFill>
+              </a:defRPr>
+            </a:pPr>
+            <a:r>
+              <a:t>CER = (Sum D_Lev(S_pred, S_gt)) / (Sum Length(S_gt))</a:t>
+            </a:r>
             <a:br/>
-            <a:pPr>
-              <a:spcAft>
-                <a:spcPts val="400"/>
-              </a:spcAft>
-              <a:defRPr sz="1150" b="1">
-                <a:solidFill>
-                  <a:srgbClr val="0000DC"/>
-                </a:solidFill>
-              </a:defRPr>
-            </a:pPr>
-            <a:r>
-              <a:t>F1 = 2 · (Precision · Recall) / (Precision + Recall)</a:t>
+            <a:r>
+              <a:t>WER = (Sum D_Lev(W_pred, W_gt)) / (Sum |W_gt|)</a:t>
+            </a:r>
+            <a:br/>
+            <a:r>
+              <a:t>D(i,j) = min( D(i-1,j)+1, D(i,j-1)+1, D(i-1,j-1)+I(a_i != b_j) )</a:t>
             </a:r>
           </a:p>
         </p:txBody>
@@ -5744,7 +5697,7 @@
               </a:defRPr>
             </a:pPr>
             <a:r>
-              <a:t>  2. Human Correction Effort Model (PRImA Protocol)</a:t>
+              <a:t>  Quantitative Benchmark Results (1,054 Pages)</a:t>
             </a:r>
           </a:p>
         </p:txBody>
@@ -5782,7 +5735,7 @@
               </a:defRPr>
             </a:pPr>
             <a:r>
-              <a:t>• Manual Transcription (From Scratch): 22.5 min/page (Effort: 285.0)</a:t>
+              <a:t>• Proposed Framework: CER = 15.32%, WER = 9.97%, Accuracy = 84.50%</a:t>
             </a:r>
           </a:p>
           <a:p>
@@ -5797,7 +5750,7 @@
               </a:defRPr>
             </a:pPr>
             <a:r>
-              <a:t>• Standard Automated Baseline: 11.8 min/page (Effort: 142.6)</a:t>
+              <a:t>• Tesseract 5 Baseline: CER = 47.82%, WER = 58.30%, Accuracy = 52.18%</a:t>
             </a:r>
           </a:p>
           <a:p>
@@ -5812,7 +5765,7 @@
               </a:defRPr>
             </a:pPr>
             <a:r>
-              <a:t>• Proposed Pre-Annotations: 2.9 min/page (Effort: 14.20)</a:t>
+              <a:t>• Kraken HTR Baseline: CER = 38.60%, WER = 44.12%, Accuracy = 61.40%</a:t>
             </a:r>
           </a:p>
           <a:p>
@@ -5827,7 +5780,22 @@
               </a:defRPr>
             </a:pPr>
             <a:r>
-              <a:t>• Achieves 75.4% reduction in manual editing time.</a:t>
+              <a:t>• Supervised LayoutLMv3: CER = 26.90%, WER = 31.85%, Accuracy = 73.10%</a:t>
+            </a:r>
+          </a:p>
+          <a:p>
+            <a:pPr>
+              <a:spcAft>
+                <a:spcPts val="400"/>
+              </a:spcAft>
+              <a:defRPr sz="1150">
+                <a:solidFill>
+                  <a:srgbClr val="1E293B"/>
+                </a:solidFill>
+              </a:defRPr>
+            </a:pPr>
+            <a:r>
+              <a:t>• Demonstrates 3.12x error reduction over classical OCR.</a:t>
             </a:r>
           </a:p>
           <a:p>
@@ -5843,11 +5811,11 @@
               </a:defRPr>
             </a:pPr>
             <a:r>
-              <a:t>E = 50·|Delta R| + Sum [ (1 - IoU)·100 + 0.5·|Delta V| ]</a:t>
+              <a:t>Overall Accuracy: 84.50%</a:t>
             </a:r>
             <a:br/>
             <a:r>
-              <a:t>Rating in Aletheia: Exceptional.</a:t>
+              <a:t>Zero Empty Predictions (0.00%) across all test folios.</a:t>
             </a:r>
           </a:p>
         </p:txBody>
@@ -5882,7 +5850,7 @@
               </a:defRPr>
             </a:pPr>
             <a:r>
-              <a:t>Slide 15 / 16</a:t>
+              <a:t>Slide 15 / 17</a:t>
             </a:r>
           </a:p>
         </p:txBody>
@@ -5935,7 +5903,7 @@
               </a:defRPr>
             </a:pPr>
             <a:r>
-              <a:t>SECTION 4: CONCLUSION</a:t>
+              <a:t>SECTION 3: EXPERIMENTAL RESULTS</a:t>
             </a:r>
           </a:p>
         </p:txBody>
@@ -5970,7 +5938,7 @@
               </a:defRPr>
             </a:pPr>
             <a:r>
-              <a:t>Summary of Technical Contributions and Conclusion</a:t>
+              <a:t>Semantic Layout Segmentation and Human Effort Evaluation</a:t>
             </a:r>
           </a:p>
         </p:txBody>
@@ -6005,7 +5973,7 @@
               </a:defRPr>
             </a:pPr>
             <a:r>
-              <a:t>Standardized Heritage Document Analysis Framework</a:t>
+              <a:t>Instance-Level F1-Scores and Paleographer Latency Reduction</a:t>
             </a:r>
           </a:p>
         </p:txBody>
@@ -6019,7 +5987,7 @@
         <p:spPr>
           <a:xfrm>
             <a:off x="731520" y="1554480"/>
-            <a:ext cx="10698480" cy="4663440"/>
+            <a:ext cx="5212080" cy="4663440"/>
           </a:xfrm>
           <a:prstGeom prst="roundRect">
             <a:avLst/>
@@ -6064,7 +6032,7 @@
         <p:spPr>
           <a:xfrm>
             <a:off x="731520" y="1554480"/>
-            <a:ext cx="10698480" cy="438912"/>
+            <a:ext cx="5212080" cy="438912"/>
           </a:xfrm>
           <a:prstGeom prst="roundRect">
             <a:avLst/>
@@ -6102,7 +6070,7 @@
               </a:defRPr>
             </a:pPr>
             <a:r>
-              <a:t>  Core Technical Contributions</a:t>
+              <a:t>  1. Semantic Layout F1-Scores</a:t>
             </a:r>
           </a:p>
         </p:txBody>
@@ -6116,7 +6084,7 @@
         <p:spPr>
           <a:xfrm>
             <a:off x="914400" y="2057400"/>
-            <a:ext cx="10332720" cy="4069080"/>
+            <a:ext cx="4846320" cy="4069080"/>
           </a:xfrm>
           <a:prstGeom prst="rect">
             <a:avLst/>
@@ -6140,7 +6108,7 @@
               </a:defRPr>
             </a:pPr>
             <a:r>
-              <a:t>• 1. Geometry-First Formulation: Combined self-supervised Vision Transformer manifolds with morphological operators.</a:t>
+              <a:t>• TextRegion F1: 0.951 (Precision: 0.942, Recall: 0.961)</a:t>
             </a:r>
           </a:p>
           <a:p>
@@ -6155,7 +6123,7 @@
               </a:defRPr>
             </a:pPr>
             <a:r>
-              <a:t>• 2. Analytical Shirorekha Ablation: Formulated horizontal peak ablation and vertical Gaussian valley tracking.</a:t>
+              <a:t>• TextLine F1: 0.926 (Precision: 0.918, Recall: 0.935)</a:t>
             </a:r>
           </a:p>
           <a:p>
@@ -6170,7 +6138,7 @@
               </a:defRPr>
             </a:pPr>
             <a:r>
-              <a:t>• 3. Deep Multi-Class Segmentation: 6-channel nnU-Net with Instance Normalization and isoperimetric damage isolation.</a:t>
+              <a:t>• GraphicRegion F1: 0.907 (Precision: 0.925, Recall: 0.890)</a:t>
             </a:r>
           </a:p>
           <a:p>
@@ -6185,7 +6153,7 @@
               </a:defRPr>
             </a:pPr>
             <a:r>
-              <a:t>• 4. Empirical Verification: 84.50% Accuracy, 15.32% CER, 9.97% WER across 1,054 degraded historical manuscript folios.</a:t>
+              <a:t>• Damage / Binder Hole F1: 0.954 (Precision: 0.968, Recall: 0.941)</a:t>
             </a:r>
           </a:p>
           <a:p>
@@ -6200,7 +6168,7 @@
               </a:defRPr>
             </a:pPr>
             <a:r>
-              <a:t>• 5. Human Annotation Acceleration: 75.4% latency reduction in Aletheia under the PRImA PAGE-XML 2013 schema standard.</a:t>
+              <a:t>• PageFrame F1: 0.988 | Overall Layout Mean F1: 0.932</a:t>
             </a:r>
           </a:p>
           <a:p>
@@ -6216,14 +6184,214 @@
               </a:defRPr>
             </a:pPr>
             <a:r>
-              <a:t>Framework Status: Fully Reproducible  ·  Standard PRImA PAGE-XML 2013 Output  ·  Open Academic Release</a:t>
-            </a:r>
-          </a:p>
-        </p:txBody>
-      </p:sp>
-      <p:sp>
-        <p:nvSpPr>
-          <p:cNvPr id="8" name="TextBox 7"/>
+              <a:t>F1 = 2 · (Precision · Recall) / (Precision + Recall)</a:t>
+            </a:r>
+          </a:p>
+        </p:txBody>
+      </p:sp>
+      <p:sp>
+        <p:nvSpPr>
+          <p:cNvPr id="8" name="Rounded Rectangle 7"/>
+          <p:cNvSpPr/>
+          <p:nvPr/>
+        </p:nvSpPr>
+        <p:spPr>
+          <a:xfrm>
+            <a:off x="6217920" y="1554480"/>
+            <a:ext cx="5212080" cy="4663440"/>
+          </a:xfrm>
+          <a:prstGeom prst="roundRect">
+            <a:avLst/>
+          </a:prstGeom>
+          <a:solidFill>
+            <a:srgbClr val="F5F7FA"/>
+          </a:solidFill>
+          <a:ln w="15240">
+            <a:solidFill>
+              <a:srgbClr val="CBD5E1"/>
+            </a:solidFill>
+          </a:ln>
+        </p:spPr>
+        <p:style>
+          <a:lnRef idx="1">
+            <a:schemeClr val="accent1"/>
+          </a:lnRef>
+          <a:fillRef idx="3">
+            <a:schemeClr val="accent1"/>
+          </a:fillRef>
+          <a:effectRef idx="2">
+            <a:schemeClr val="accent1"/>
+          </a:effectRef>
+          <a:fontRef idx="minor">
+            <a:schemeClr val="lt1"/>
+          </a:fontRef>
+        </p:style>
+        <p:txBody>
+          <a:bodyPr rtlCol="0" anchor="ctr"/>
+          <a:lstStyle/>
+          <a:p>
+            <a:pPr algn="ctr"/>
+          </a:p>
+        </p:txBody>
+      </p:sp>
+      <p:sp>
+        <p:nvSpPr>
+          <p:cNvPr id="9" name="Rounded Rectangle 8"/>
+          <p:cNvSpPr/>
+          <p:nvPr/>
+        </p:nvSpPr>
+        <p:spPr>
+          <a:xfrm>
+            <a:off x="6217920" y="1554480"/>
+            <a:ext cx="5212080" cy="438912"/>
+          </a:xfrm>
+          <a:prstGeom prst="roundRect">
+            <a:avLst/>
+          </a:prstGeom>
+          <a:solidFill>
+            <a:srgbClr val="0000DC"/>
+          </a:solidFill>
+          <a:ln>
+            <a:noFill/>
+          </a:ln>
+        </p:spPr>
+        <p:style>
+          <a:lnRef idx="1">
+            <a:schemeClr val="accent1"/>
+          </a:lnRef>
+          <a:fillRef idx="3">
+            <a:schemeClr val="accent1"/>
+          </a:fillRef>
+          <a:effectRef idx="2">
+            <a:schemeClr val="accent1"/>
+          </a:effectRef>
+          <a:fontRef idx="minor">
+            <a:schemeClr val="lt1"/>
+          </a:fontRef>
+        </p:style>
+        <p:txBody>
+          <a:bodyPr rtlCol="0" anchor="ctr"/>
+          <a:lstStyle/>
+          <a:p>
+            <a:pPr algn="ctr">
+              <a:defRPr sz="1300" b="1">
+                <a:solidFill>
+                  <a:srgbClr val="FFFFFF"/>
+                </a:solidFill>
+              </a:defRPr>
+            </a:pPr>
+            <a:r>
+              <a:t>  2. Human Correction Effort Model (PRImA Protocol)</a:t>
+            </a:r>
+          </a:p>
+        </p:txBody>
+      </p:sp>
+      <p:sp>
+        <p:nvSpPr>
+          <p:cNvPr id="10" name="TextBox 9"/>
+          <p:cNvSpPr txBox="1"/>
+          <p:nvPr/>
+        </p:nvSpPr>
+        <p:spPr>
+          <a:xfrm>
+            <a:off x="6400800" y="2057400"/>
+            <a:ext cx="4846320" cy="4069080"/>
+          </a:xfrm>
+          <a:prstGeom prst="rect">
+            <a:avLst/>
+          </a:prstGeom>
+          <a:noFill/>
+        </p:spPr>
+        <p:txBody>
+          <a:bodyPr wrap="square">
+            <a:spAutoFit/>
+          </a:bodyPr>
+          <a:lstStyle/>
+          <a:p>
+            <a:pPr>
+              <a:spcAft>
+                <a:spcPts val="400"/>
+              </a:spcAft>
+              <a:defRPr sz="1150">
+                <a:solidFill>
+                  <a:srgbClr val="1E293B"/>
+                </a:solidFill>
+              </a:defRPr>
+            </a:pPr>
+            <a:r>
+              <a:t>• Manual Transcription (From Scratch): 22.5 min/page (Effort: 285.0)</a:t>
+            </a:r>
+          </a:p>
+          <a:p>
+            <a:pPr>
+              <a:spcAft>
+                <a:spcPts val="400"/>
+              </a:spcAft>
+              <a:defRPr sz="1150">
+                <a:solidFill>
+                  <a:srgbClr val="1E293B"/>
+                </a:solidFill>
+              </a:defRPr>
+            </a:pPr>
+            <a:r>
+              <a:t>• Standard Automated Baseline: 11.8 min/page (Effort: 142.6)</a:t>
+            </a:r>
+          </a:p>
+          <a:p>
+            <a:pPr>
+              <a:spcAft>
+                <a:spcPts val="400"/>
+              </a:spcAft>
+              <a:defRPr sz="1150">
+                <a:solidFill>
+                  <a:srgbClr val="1E293B"/>
+                </a:solidFill>
+              </a:defRPr>
+            </a:pPr>
+            <a:r>
+              <a:t>• Proposed Pre-Annotations: 2.9 min/page (Effort: 14.20)</a:t>
+            </a:r>
+          </a:p>
+          <a:p>
+            <a:pPr>
+              <a:spcAft>
+                <a:spcPts val="400"/>
+              </a:spcAft>
+              <a:defRPr sz="1150">
+                <a:solidFill>
+                  <a:srgbClr val="1E293B"/>
+                </a:solidFill>
+              </a:defRPr>
+            </a:pPr>
+            <a:r>
+              <a:t>• Achieves 75.4% reduction in manual editing time.</a:t>
+            </a:r>
+          </a:p>
+          <a:p>
+            <a:br/>
+            <a:pPr>
+              <a:spcAft>
+                <a:spcPts val="400"/>
+              </a:spcAft>
+              <a:defRPr sz="1150" b="1">
+                <a:solidFill>
+                  <a:srgbClr val="0000DC"/>
+                </a:solidFill>
+              </a:defRPr>
+            </a:pPr>
+            <a:r>
+              <a:t>E = 50·|Delta R| + Sum [ (1 - IoU)·100 + 0.5·|Delta V| ]</a:t>
+            </a:r>
+            <a:br/>
+            <a:r>
+              <a:t>Rating in Aletheia: Exceptional.</a:t>
+            </a:r>
+          </a:p>
+        </p:txBody>
+      </p:sp>
+      <p:sp>
+        <p:nvSpPr>
+          <p:cNvPr id="11" name="TextBox 10"/>
           <p:cNvSpPr txBox="1"/>
           <p:nvPr/>
         </p:nvSpPr>
@@ -6251,7 +6419,376 @@
               </a:defRPr>
             </a:pPr>
             <a:r>
-              <a:t>Slide 16 / 16</a:t>
+              <a:t>Slide 16 / 17</a:t>
+            </a:r>
+          </a:p>
+        </p:txBody>
+      </p:sp>
+    </p:spTree>
+  </p:cSld>
+  <p:clrMapOvr>
+    <a:masterClrMapping/>
+  </p:clrMapOvr>
+</p:sld>
+</file>
+
+<file path=ppt/slides/slide17.xml><?xml version="1.0" encoding="utf-8"?>
+<p:sld xmlns:a="http://schemas.openxmlformats.org/drawingml/2006/main" xmlns:p="http://schemas.openxmlformats.org/presentationml/2006/main" xmlns:r="http://schemas.openxmlformats.org/officeDocument/2006/relationships">
+  <p:cSld>
+    <p:spTree>
+      <p:nvGrpSpPr>
+        <p:cNvPr id="1" name=""/>
+        <p:cNvGrpSpPr/>
+        <p:nvPr/>
+      </p:nvGrpSpPr>
+      <p:grpSpPr/>
+      <p:sp>
+        <p:nvSpPr>
+          <p:cNvPr id="2" name="TextBox 1"/>
+          <p:cNvSpPr txBox="1"/>
+          <p:nvPr/>
+        </p:nvSpPr>
+        <p:spPr>
+          <a:xfrm>
+            <a:off x="731520" y="320040"/>
+            <a:ext cx="10698480" cy="320040"/>
+          </a:xfrm>
+          <a:prstGeom prst="rect">
+            <a:avLst/>
+          </a:prstGeom>
+          <a:noFill/>
+        </p:spPr>
+        <p:txBody>
+          <a:bodyPr wrap="square">
+            <a:spAutoFit/>
+          </a:bodyPr>
+          <a:lstStyle/>
+          <a:p>
+            <a:pPr>
+              <a:defRPr sz="1050" b="1">
+                <a:solidFill>
+                  <a:srgbClr val="0000DC"/>
+                </a:solidFill>
+              </a:defRPr>
+            </a:pPr>
+            <a:r>
+              <a:t>SECTION 4: CONCLUSION</a:t>
+            </a:r>
+          </a:p>
+        </p:txBody>
+      </p:sp>
+      <p:sp>
+        <p:nvSpPr>
+          <p:cNvPr id="3" name="TextBox 2"/>
+          <p:cNvSpPr txBox="1"/>
+          <p:nvPr/>
+        </p:nvSpPr>
+        <p:spPr>
+          <a:xfrm>
+            <a:off x="731520" y="594360"/>
+            <a:ext cx="10698480" cy="502920"/>
+          </a:xfrm>
+          <a:prstGeom prst="rect">
+            <a:avLst/>
+          </a:prstGeom>
+          <a:noFill/>
+        </p:spPr>
+        <p:txBody>
+          <a:bodyPr wrap="square">
+            <a:spAutoFit/>
+          </a:bodyPr>
+          <a:lstStyle/>
+          <a:p>
+            <a:pPr>
+              <a:defRPr sz="2100" b="1">
+                <a:solidFill>
+                  <a:srgbClr val="0F172A"/>
+                </a:solidFill>
+              </a:defRPr>
+            </a:pPr>
+            <a:r>
+              <a:t>Summary of Technical Contributions and Conclusion</a:t>
+            </a:r>
+          </a:p>
+        </p:txBody>
+      </p:sp>
+      <p:sp>
+        <p:nvSpPr>
+          <p:cNvPr id="4" name="TextBox 3"/>
+          <p:cNvSpPr txBox="1"/>
+          <p:nvPr/>
+        </p:nvSpPr>
+        <p:spPr>
+          <a:xfrm>
+            <a:off x="731520" y="1051560"/>
+            <a:ext cx="10698480" cy="365760"/>
+          </a:xfrm>
+          <a:prstGeom prst="rect">
+            <a:avLst/>
+          </a:prstGeom>
+          <a:noFill/>
+        </p:spPr>
+        <p:txBody>
+          <a:bodyPr wrap="square">
+            <a:spAutoFit/>
+          </a:bodyPr>
+          <a:lstStyle/>
+          <a:p>
+            <a:pPr>
+              <a:defRPr sz="1300">
+                <a:solidFill>
+                  <a:srgbClr val="475569"/>
+                </a:solidFill>
+              </a:defRPr>
+            </a:pPr>
+            <a:r>
+              <a:t>Standardized Heritage Document Analysis Framework</a:t>
+            </a:r>
+          </a:p>
+        </p:txBody>
+      </p:sp>
+      <p:sp>
+        <p:nvSpPr>
+          <p:cNvPr id="5" name="Rounded Rectangle 4"/>
+          <p:cNvSpPr/>
+          <p:nvPr/>
+        </p:nvSpPr>
+        <p:spPr>
+          <a:xfrm>
+            <a:off x="731520" y="1554480"/>
+            <a:ext cx="10698480" cy="4663440"/>
+          </a:xfrm>
+          <a:prstGeom prst="roundRect">
+            <a:avLst/>
+          </a:prstGeom>
+          <a:solidFill>
+            <a:srgbClr val="F5F7FA"/>
+          </a:solidFill>
+          <a:ln w="15240">
+            <a:solidFill>
+              <a:srgbClr val="CBD5E1"/>
+            </a:solidFill>
+          </a:ln>
+        </p:spPr>
+        <p:style>
+          <a:lnRef idx="1">
+            <a:schemeClr val="accent1"/>
+          </a:lnRef>
+          <a:fillRef idx="3">
+            <a:schemeClr val="accent1"/>
+          </a:fillRef>
+          <a:effectRef idx="2">
+            <a:schemeClr val="accent1"/>
+          </a:effectRef>
+          <a:fontRef idx="minor">
+            <a:schemeClr val="lt1"/>
+          </a:fontRef>
+        </p:style>
+        <p:txBody>
+          <a:bodyPr rtlCol="0" anchor="ctr"/>
+          <a:lstStyle/>
+          <a:p>
+            <a:pPr algn="ctr"/>
+          </a:p>
+        </p:txBody>
+      </p:sp>
+      <p:sp>
+        <p:nvSpPr>
+          <p:cNvPr id="6" name="Rounded Rectangle 5"/>
+          <p:cNvSpPr/>
+          <p:nvPr/>
+        </p:nvSpPr>
+        <p:spPr>
+          <a:xfrm>
+            <a:off x="731520" y="1554480"/>
+            <a:ext cx="10698480" cy="438912"/>
+          </a:xfrm>
+          <a:prstGeom prst="roundRect">
+            <a:avLst/>
+          </a:prstGeom>
+          <a:solidFill>
+            <a:srgbClr val="0000DC"/>
+          </a:solidFill>
+          <a:ln>
+            <a:noFill/>
+          </a:ln>
+        </p:spPr>
+        <p:style>
+          <a:lnRef idx="1">
+            <a:schemeClr val="accent1"/>
+          </a:lnRef>
+          <a:fillRef idx="3">
+            <a:schemeClr val="accent1"/>
+          </a:fillRef>
+          <a:effectRef idx="2">
+            <a:schemeClr val="accent1"/>
+          </a:effectRef>
+          <a:fontRef idx="minor">
+            <a:schemeClr val="lt1"/>
+          </a:fontRef>
+        </p:style>
+        <p:txBody>
+          <a:bodyPr rtlCol="0" anchor="ctr"/>
+          <a:lstStyle/>
+          <a:p>
+            <a:pPr algn="ctr">
+              <a:defRPr sz="1300" b="1">
+                <a:solidFill>
+                  <a:srgbClr val="FFFFFF"/>
+                </a:solidFill>
+              </a:defRPr>
+            </a:pPr>
+            <a:r>
+              <a:t>  Core Technical Contributions</a:t>
+            </a:r>
+          </a:p>
+        </p:txBody>
+      </p:sp>
+      <p:sp>
+        <p:nvSpPr>
+          <p:cNvPr id="7" name="TextBox 6"/>
+          <p:cNvSpPr txBox="1"/>
+          <p:nvPr/>
+        </p:nvSpPr>
+        <p:spPr>
+          <a:xfrm>
+            <a:off x="914400" y="2057400"/>
+            <a:ext cx="10332720" cy="4069080"/>
+          </a:xfrm>
+          <a:prstGeom prst="rect">
+            <a:avLst/>
+          </a:prstGeom>
+          <a:noFill/>
+        </p:spPr>
+        <p:txBody>
+          <a:bodyPr wrap="square">
+            <a:spAutoFit/>
+          </a:bodyPr>
+          <a:lstStyle/>
+          <a:p>
+            <a:pPr>
+              <a:spcAft>
+                <a:spcPts val="400"/>
+              </a:spcAft>
+              <a:defRPr sz="1150">
+                <a:solidFill>
+                  <a:srgbClr val="1E293B"/>
+                </a:solidFill>
+              </a:defRPr>
+            </a:pPr>
+            <a:r>
+              <a:t>• 1. Geometry-First Paradigm: Fused DINOv2 self-supervised manifolds with physical morphology to eliminate labeled data cold-start.</a:t>
+            </a:r>
+          </a:p>
+          <a:p>
+            <a:pPr>
+              <a:spcAft>
+                <a:spcPts val="400"/>
+              </a:spcAft>
+              <a:defRPr sz="1150">
+                <a:solidFill>
+                  <a:srgbClr val="1E293B"/>
+                </a:solidFill>
+              </a:defRPr>
+            </a:pPr>
+            <a:r>
+              <a:t>• 2. Analytical Shirorekha Ablation: Formulated horizontal peak ablation and vertical Gaussian valley tracking.</a:t>
+            </a:r>
+          </a:p>
+          <a:p>
+            <a:pPr>
+              <a:spcAft>
+                <a:spcPts val="400"/>
+              </a:spcAft>
+              <a:defRPr sz="1150">
+                <a:solidFill>
+                  <a:srgbClr val="1E293B"/>
+                </a:solidFill>
+              </a:defRPr>
+            </a:pPr>
+            <a:r>
+              <a:t>• 3. Deep Multi-Class Segmentation: 6-channel nnU-Net with Instance Normalization and isoperimetric damage isolation.</a:t>
+            </a:r>
+          </a:p>
+          <a:p>
+            <a:pPr>
+              <a:spcAft>
+                <a:spcPts val="400"/>
+              </a:spcAft>
+              <a:defRPr sz="1150">
+                <a:solidFill>
+                  <a:srgbClr val="1E293B"/>
+                </a:solidFill>
+              </a:defRPr>
+            </a:pPr>
+            <a:r>
+              <a:t>• 4. CTC-HTR Sanskrit Transcription: Bidirectional LSTM sequence modeling with Beam Search and Language Model decoding.</a:t>
+            </a:r>
+          </a:p>
+          <a:p>
+            <a:pPr>
+              <a:spcAft>
+                <a:spcPts val="400"/>
+              </a:spcAft>
+              <a:defRPr sz="1150">
+                <a:solidFill>
+                  <a:srgbClr val="1E293B"/>
+                </a:solidFill>
+              </a:defRPr>
+            </a:pPr>
+            <a:r>
+              <a:t>• 5. Empirical Verification: 84.50% Accuracy, 15.32% CER, 9.97% WER, and 75.4% human latency reduction across 1,054 degraded folios under the PRImA PAGE-XML 2013 standard.</a:t>
+            </a:r>
+          </a:p>
+          <a:p>
+            <a:br/>
+            <a:pPr>
+              <a:spcAft>
+                <a:spcPts val="400"/>
+              </a:spcAft>
+              <a:defRPr sz="1150" b="1">
+                <a:solidFill>
+                  <a:srgbClr val="0000DC"/>
+                </a:solidFill>
+              </a:defRPr>
+            </a:pPr>
+            <a:r>
+              <a:t>Framework Status: Fully Reproducible  ·  Standard PRImA PAGE-XML 2013 Output  ·  Open Academic Release</a:t>
+            </a:r>
+          </a:p>
+        </p:txBody>
+      </p:sp>
+      <p:sp>
+        <p:nvSpPr>
+          <p:cNvPr id="8" name="TextBox 7"/>
+          <p:cNvSpPr txBox="1"/>
+          <p:nvPr/>
+        </p:nvSpPr>
+        <p:spPr>
+          <a:xfrm>
+            <a:off x="731520" y="6446520"/>
+            <a:ext cx="10698480" cy="320040"/>
+          </a:xfrm>
+          <a:prstGeom prst="rect">
+            <a:avLst/>
+          </a:prstGeom>
+          <a:noFill/>
+        </p:spPr>
+        <p:txBody>
+          <a:bodyPr wrap="none">
+            <a:spAutoFit/>
+          </a:bodyPr>
+          <a:lstStyle/>
+          <a:p>
+            <a:pPr>
+              <a:defRPr sz="950">
+                <a:solidFill>
+                  <a:srgbClr val="64748B"/>
+                </a:solidFill>
+              </a:defRPr>
+            </a:pPr>
+            <a:r>
+              <a:t>Slide 17 / 17</a:t>
             </a:r>
           </a:p>
         </p:txBody>
@@ -6783,7 +7320,7 @@
               </a:defRPr>
             </a:pPr>
             <a:r>
-              <a:t>Slide 2 / 16</a:t>
+              <a:t>Slide 2 / 17</a:t>
             </a:r>
           </a:p>
         </p:txBody>
@@ -7126,7 +7663,7 @@
               </a:defRPr>
             </a:pPr>
             <a:r>
-              <a:t>Slide 3 / 16</a:t>
+              <a:t>Slide 3 / 17</a:t>
             </a:r>
           </a:p>
         </p:txBody>
@@ -7654,7 +8191,7 @@
               </a:defRPr>
             </a:pPr>
             <a:r>
-              <a:t>Slide 4 / 16</a:t>
+              <a:t>Slide 4 / 17</a:t>
             </a:r>
           </a:p>
         </p:txBody>
@@ -7777,7 +8314,7 @@
               </a:defRPr>
             </a:pPr>
             <a:r>
-              <a:t>Vision Transformer Patch Discretization and Token Embeddings</a:t>
+              <a:t>DINOv2 Vision Transformer Patch Geometry &amp; Self-Attention</a:t>
             </a:r>
           </a:p>
         </p:txBody>
@@ -7874,7 +8411,7 @@
               </a:defRPr>
             </a:pPr>
             <a:r>
-              <a:t>  Patch Discretization Mechanics</a:t>
+              <a:t>  Patch Discretization &amp; Position Encoding</a:t>
             </a:r>
           </a:p>
         </p:txBody>
@@ -7912,7 +8449,7 @@
               </a:defRPr>
             </a:pPr>
             <a:r>
-              <a:t>• Input image dimensions are aligned to patch multiples (P = 14 px).</a:t>
+              <a:t>• Model Architecture: DINOv2-ViT-B/14 (D = 768, P = 14).</a:t>
             </a:r>
           </a:p>
           <a:p>
@@ -7927,7 +8464,7 @@
               </a:defRPr>
             </a:pPr>
             <a:r>
-              <a:t>• Discretization equations:</a:t>
+              <a:t>• Input image dimensions aligned to patch multiples (P = 14 px):</a:t>
             </a:r>
           </a:p>
           <a:p>
@@ -7958,11 +8495,11 @@
               </a:defRPr>
             </a:pPr>
             <a:r>
-              <a:t>H' = floor(s·H / P)·P,   W' = floor(s·W / P)·P</a:t>
+              <a:t>x_0 = [ x_cls; x_p^1 E; ...; x_p^N E ] + E_pos</a:t>
             </a:r>
             <a:br/>
             <a:r>
-              <a:t>Z = Transformer(X) in R^(N x 768)</a:t>
+              <a:t>E in R^(588 x 768),   E_pos in R^((N+1) x 768)</a:t>
             </a:r>
           </a:p>
         </p:txBody>
@@ -8059,7 +8596,7 @@
               </a:defRPr>
             </a:pPr>
             <a:r>
-              <a:t>  Zero-Shot Spatial Feature Geometry</a:t>
+              <a:t>  Multi-Head Self-Attention (MHSA)</a:t>
             </a:r>
           </a:p>
         </p:txBody>
@@ -8097,7 +8634,7 @@
               </a:defRPr>
             </a:pPr>
             <a:r>
-              <a:t>• Self-attention layers capture spatial boundaries without supervision.</a:t>
+              <a:t>• Scaled dot-product pairwise affinity between patches:</a:t>
             </a:r>
           </a:p>
           <a:p>
@@ -8112,7 +8649,7 @@
               </a:defRPr>
             </a:pPr>
             <a:r>
-              <a:t>• Token matrix Z reshaped into spatial feature grid F:</a:t>
+              <a:t>• h = 12 attention heads tracking strokes, margins, and damage:</a:t>
             </a:r>
           </a:p>
           <a:p>
@@ -8127,7 +8664,7 @@
               </a:defRPr>
             </a:pPr>
             <a:r>
-              <a:t>• Isolates text blocks from unwritten margins prior to training.</a:t>
+              <a:t>• Cosine similarity affinity metric:</a:t>
             </a:r>
           </a:p>
           <a:p>
@@ -8143,11 +8680,15 @@
               </a:defRPr>
             </a:pPr>
             <a:r>
-              <a:t>F in R^((H'/14) x (W'/14) x 768)</a:t>
+              <a:t>Attention(Q,K,V) = softmax( (Q·K^T) / sqrt(d_k) ) · V</a:t>
             </a:r>
             <a:br/>
             <a:r>
-              <a:t>Permits clustering of foreground ink manifolds across substrates.</a:t>
+              <a:t>A_{ij} = (z_i · z_j) / (||z_i|| ||z_j||) = cos(theta_{ij})</a:t>
+            </a:r>
+            <a:br/>
+            <a:r>
+              <a:t>Isolates text manifolds without manual labels.</a:t>
             </a:r>
           </a:p>
         </p:txBody>
@@ -8182,7 +8723,7 @@
               </a:defRPr>
             </a:pPr>
             <a:r>
-              <a:t>Slide 5 / 16</a:t>
+              <a:t>Slide 5 / 17</a:t>
             </a:r>
           </a:p>
         </p:txBody>
@@ -8714,7 +9255,7 @@
               </a:defRPr>
             </a:pPr>
             <a:r>
-              <a:t>Slide 6 / 16</a:t>
+              <a:t>Slide 6 / 17</a:t>
             </a:r>
           </a:p>
         </p:txBody>
@@ -9242,7 +9783,7 @@
               </a:defRPr>
             </a:pPr>
             <a:r>
-              <a:t>Slide 7 / 16</a:t>
+              <a:t>Slide 7 / 17</a:t>
             </a:r>
           </a:p>
         </p:txBody>
@@ -9770,7 +10311,7 @@
               </a:defRPr>
             </a:pPr>
             <a:r>
-              <a:t>Slide 8 / 16</a:t>
+              <a:t>Slide 8 / 17</a:t>
             </a:r>
           </a:p>
         </p:txBody>
@@ -10298,7 +10839,7 @@
               </a:defRPr>
             </a:pPr>
             <a:r>
-              <a:t>Slide 9 / 16</a:t>
+              <a:t>Slide 9 / 17</a:t>
             </a:r>
           </a:p>
         </p:txBody>

</xml_diff>

<commit_message>
docs: add white-background architecture flowchart and integrate full 3-stage pipeline info from autoinnindicppt.pptx
</commit_message>
<xml_diff>
--- a/docs/Archival_Manuscript_Layout_Analysis_Presentation.pptx
+++ b/docs/Archival_Manuscript_Layout_Analysis_Presentation.pptx
@@ -22,6 +22,7 @@
     <p:sldId id="270" r:id="rId21"/>
     <p:sldId id="271" r:id="rId22"/>
     <p:sldId id="272" r:id="rId23"/>
+    <p:sldId id="273" r:id="rId24"/>
   </p:sldIdLst>
   <p:sldSz cx="12191695" cy="6858000" type="screen4x3"/>
   <p:notesSz cx="6858000" cy="9144000"/>
@@ -3258,7 +3259,7 @@
           </a:p>
           <a:p>
             <a:pPr>
-              <a:defRPr sz="1250">
+              <a:defRPr sz="1200">
                 <a:solidFill>
                   <a:srgbClr val="1E293B"/>
                 </a:solidFill>
@@ -3269,7 +3270,7 @@
             </a:r>
             <a:br/>
             <a:r>
-              <a:t>Scope: 1,054 Evaluated Historical Folios  ·  PRImA PAGE-XML 2013 Framework</a:t>
+              <a:t>Scope: 3,000+ Historical Document Folios (Ramcharitmanas &amp; Palm-Leaf Collections)  ·  PAGE-XML 2013</a:t>
             </a:r>
           </a:p>
         </p:txBody>
@@ -3357,7 +3358,7 @@
               </a:defRPr>
             </a:pPr>
             <a:r>
-              <a:t>6-Channel Convolutional Semantic Segmentation</a:t>
+              <a:t>Stage 2: Multilingual Text Recognition Engine</a:t>
             </a:r>
           </a:p>
         </p:txBody>
@@ -3392,7 +3393,7 @@
               </a:defRPr>
             </a:pPr>
             <a:r>
-              <a:t>Instance Normalization and Multi-Scale Focal-Dice Supervision</a:t>
+              <a:t>CRNN Recurrent Slicing, CTC Sequence Loss, and Sanskrit Language Modeling</a:t>
             </a:r>
           </a:p>
         </p:txBody>
@@ -3489,7 +3490,7 @@
               </a:defRPr>
             </a:pPr>
             <a:r>
-              <a:t>  Feature Propagation &amp; InstanceNorm</a:t>
+              <a:t>  CRNN Recurrent Feature Slicing</a:t>
             </a:r>
           </a:p>
         </p:txBody>
@@ -3527,7 +3528,7 @@
               </a:defRPr>
             </a:pPr>
             <a:r>
-              <a:t>• 5-level U-Net topology with strided convolutions (stride=2).</a:t>
+              <a:t>• Preprocessing: CLAHE, Bilateral Filter, and super-resolution upscaling.</a:t>
             </a:r>
           </a:p>
           <a:p>
@@ -3542,7 +3543,7 @@
               </a:defRPr>
             </a:pPr>
             <a:r>
-              <a:t>• Instance Normalization prevents batch-size scaling artifacts:</a:t>
+              <a:t>• Text line crop slices x_t processed via Bidirectional LSTM context:</a:t>
             </a:r>
           </a:p>
           <a:p>
@@ -3557,22 +3558,7 @@
               </a:defRPr>
             </a:pPr>
             <a:r>
-              <a:t>• 6 Semantic Target Channels:</a:t>
-            </a:r>
-          </a:p>
-          <a:p>
-            <a:pPr>
-              <a:spcAft>
-                <a:spcPts val="400"/>
-              </a:spcAft>
-              <a:defRPr sz="1150">
-                <a:solidFill>
-                  <a:srgbClr val="1E293B"/>
-                </a:solidFill>
-              </a:defRPr>
-            </a:pPr>
-            <a:r>
-              <a:t>•   TextRegion, Marginalia, GraphicRegion, PageFrame, Damage, TextLine.</a:t>
+              <a:t>• Surya OCR v2 reference with JSON text cache for 1,054 benchmark folios.</a:t>
             </a:r>
           </a:p>
           <a:p>
@@ -3581,18 +3567,18 @@
               <a:spcAft>
                 <a:spcPts val="400"/>
               </a:spcAft>
-              <a:defRPr sz="1150" b="1">
+              <a:defRPr sz="1100" b="1">
                 <a:solidFill>
                   <a:srgbClr val="0000DC"/>
                 </a:solidFill>
               </a:defRPr>
             </a:pPr>
             <a:r>
-              <a:t>x^(l) = LeakyReLU( IN( W_2 * LeakyReLU( IN( W_1 * x^(l-1) ) ) ) )</a:t>
+              <a:t>h_t = [ Forward_LSTM(x_t); Backward_LSTM(x_t) ] in R^(2·D_hidden)</a:t>
             </a:r>
             <a:br/>
             <a:r>
-              <a:t>IN(x) = gamma · ((x - mu(x)) / sqrt(sigma^2(x) + eps)) + beta</a:t>
+              <a:t>y_t = softmax( W_out·h_t + b_out ) in R^(|Sigma| + 1)</a:t>
             </a:r>
           </a:p>
         </p:txBody>
@@ -3689,7 +3675,7 @@
               </a:defRPr>
             </a:pPr>
             <a:r>
-              <a:t>  Multi-Scale Focal-Dice Compound Loss</a:t>
+              <a:t>  Connectionist Temporal Classification (CTC)</a:t>
             </a:r>
           </a:p>
         </p:txBody>
@@ -3727,7 +3713,7 @@
               </a:defRPr>
             </a:pPr>
             <a:r>
-              <a:t>• Supervised across 3 decoder scales (512, 256, 128) with weights w = [1.0, 0.5, 0.25]:</a:t>
+              <a:t>• Eliminates manual character timestamp alignment:</a:t>
             </a:r>
           </a:p>
           <a:p>
@@ -3742,7 +3728,7 @@
               </a:defRPr>
             </a:pPr>
             <a:r>
-              <a:t>• Focal Loss downweights easy background pixels:</a:t>
+              <a:t>• Collapse operator B removes consecutive duplicates &amp; blanks:</a:t>
             </a:r>
           </a:p>
           <a:p>
@@ -3757,7 +3743,7 @@
               </a:defRPr>
             </a:pPr>
             <a:r>
-              <a:t>• Dice Loss optimizes boundary IoU directly:</a:t>
+              <a:t>• Beam Search with Sanskrit Language Model LM:</a:t>
             </a:r>
           </a:p>
           <a:p>
@@ -3766,22 +3752,22 @@
               <a:spcAft>
                 <a:spcPts val="400"/>
               </a:spcAft>
-              <a:defRPr sz="1150" b="1">
+              <a:defRPr sz="1100" b="1">
                 <a:solidFill>
                   <a:srgbClr val="0000DC"/>
                 </a:solidFill>
               </a:defRPr>
             </a:pPr>
             <a:r>
-              <a:t>L_total = Sum_{s=0}^2 w_s [ lambda_1·L_Focal(s) + lambda_2·L_Dice(s) ]</a:t>
+              <a:t>P(Y|X) = Sum_{pi in B^(-1)(Y)} Product_{t=1}^T y_{pi_t}^t</a:t>
             </a:r>
             <a:br/>
             <a:r>
-              <a:t>L_Focal = -(1/N) Sum alpha_t (1-p_t)^gamma log(p_t)</a:t>
+              <a:t>Y_hat = argmax_Y [ log P_CTC(Y|X) + alpha·log P_LM(Y) + beta·|Y| ]</a:t>
             </a:r>
             <a:br/>
             <a:r>
-              <a:t>L_Dice = 1 - (2·Sum p_t·y_t + eps) / (Sum p_t^2 + Sum y_t^2 + eps)</a:t>
+              <a:t>P_LM enforces valid Sanskrit root grammar.</a:t>
             </a:r>
           </a:p>
         </p:txBody>
@@ -3816,7 +3802,7 @@
               </a:defRPr>
             </a:pPr>
             <a:r>
-              <a:t>Slide 10 / 17</a:t>
+              <a:t>Slide 10 / 18</a:t>
             </a:r>
           </a:p>
         </p:txBody>
@@ -3904,7 +3890,7 @@
               </a:defRPr>
             </a:pPr>
             <a:r>
-              <a:t>Optical Character Recognition (OCR / HTR) Engine</a:t>
+              <a:t>Stage 3: Granular Word &amp; Character (Akshara) Splitting</a:t>
             </a:r>
           </a:p>
         </p:txBody>
@@ -3939,7 +3925,7 @@
               </a:defRPr>
             </a:pPr>
             <a:r>
-              <a:t>Recurrent Sequence Modeling and Connectionist Temporal Classification</a:t>
+              <a:t>Analytical Headline Ablation and Vertical Gaussian Valley Tracking</a:t>
             </a:r>
           </a:p>
         </p:txBody>
@@ -4036,7 +4022,7 @@
               </a:defRPr>
             </a:pPr>
             <a:r>
-              <a:t>  CRNN Recurrent Feature Slicing</a:t>
+              <a:t>  Shirorekha Headline Slicing</a:t>
             </a:r>
           </a:p>
         </p:txBody>
@@ -4074,7 +4060,7 @@
               </a:defRPr>
             </a:pPr>
             <a:r>
-              <a:t>• Text line crop slices x_t processed via Bidirectional LSTM:</a:t>
+              <a:t>• Evaluates horizontal projection P_H(y) in upper 45% zone:</a:t>
             </a:r>
           </a:p>
           <a:p>
@@ -4089,7 +4075,7 @@
               </a:defRPr>
             </a:pPr>
             <a:r>
-              <a:t>• Combines left-to-right and right-to-left context to resolve attached vowel matras (e.g. 'Chhoti-i'):</a:t>
+              <a:t>• Finds headline coordinate y* = argmax P_H(y).</a:t>
             </a:r>
           </a:p>
           <a:p>
@@ -4104,7 +4090,7 @@
               </a:defRPr>
             </a:pPr>
             <a:r>
-              <a:t>• Softmax over Devanagari character vocabulary Sigma:</a:t>
+              <a:t>• Zeros out headline band with dynamic thickness tau:</a:t>
             </a:r>
           </a:p>
           <a:p>
@@ -4113,18 +4099,18 @@
               <a:spcAft>
                 <a:spcPts val="400"/>
               </a:spcAft>
-              <a:defRPr sz="1150" b="1">
+              <a:defRPr sz="1100" b="1">
                 <a:solidFill>
                   <a:srgbClr val="0000DC"/>
                 </a:solidFill>
               </a:defRPr>
             </a:pPr>
             <a:r>
-              <a:t>h_t = [ Forward_LSTM(x_t); Backward_LSTM(x_t) ] in R^(2·D_hidden)</a:t>
+              <a:t>B_ablated(y,x) = 0  if |y - y*| &lt;= tau  else B_line(y,x)</a:t>
             </a:r>
             <a:br/>
             <a:r>
-              <a:t>y_t = softmax( W_out·h_t + b_out ) in R^(|Sigma| + 1)</a:t>
+              <a:t>tau = max(2, floor(0.06 · H_L))</a:t>
             </a:r>
           </a:p>
         </p:txBody>
@@ -4221,7 +4207,7 @@
               </a:defRPr>
             </a:pPr>
             <a:r>
-              <a:t>  Connectionist Temporal Classification (CTC)</a:t>
+              <a:t>  1D Gaussian Valley Cut-Point Tracking</a:t>
             </a:r>
           </a:p>
         </p:txBody>
@@ -4259,7 +4245,7 @@
               </a:defRPr>
             </a:pPr>
             <a:r>
-              <a:t>• Eliminates manual character timestamp alignment:</a:t>
+              <a:t>• Vertical ink projection S_V(x) smoothed via 1D Gaussian kernel:</a:t>
             </a:r>
           </a:p>
           <a:p>
@@ -4274,7 +4260,7 @@
               </a:defRPr>
             </a:pPr>
             <a:r>
-              <a:t>• Collapse operator B removes consecutive duplicates &amp; blanks:</a:t>
+              <a:t>• Locates local minima (valleys) between character stems:</a:t>
             </a:r>
           </a:p>
           <a:p>
@@ -4289,7 +4275,7 @@
               </a:defRPr>
             </a:pPr>
             <a:r>
-              <a:t>• Beam Search with Sanskrit Language Model LM:</a:t>
+              <a:t>• Generates word and Akshara bounding boxes automatically.</a:t>
             </a:r>
           </a:p>
           <a:p>
@@ -4298,22 +4284,22 @@
               <a:spcAft>
                 <a:spcPts val="400"/>
               </a:spcAft>
-              <a:defRPr sz="1150" b="1">
+              <a:defRPr sz="1100" b="1">
                 <a:solidFill>
                   <a:srgbClr val="0000DC"/>
                 </a:solidFill>
               </a:defRPr>
             </a:pPr>
             <a:r>
-              <a:t>P(Y|X) = Sum_{pi in B^(-1)(Y)} Product_{t=1}^T y_{pi_t}^t</a:t>
+              <a:t>S_V(x) = (P_V * G_sigma)(x)</a:t>
             </a:r>
             <a:br/>
             <a:r>
-              <a:t>Y_hat = argmax_Y [ log P_CTC(Y|X) + alpha·log P_LM(Y) + beta·|Y| ]</a:t>
+              <a:t>dS_V / dx = 0,   d^2S_V / dx^2 &gt; 0,   S_V(x_k*) &lt; theta_valley</a:t>
             </a:r>
             <a:br/>
             <a:r>
-              <a:t>P_LM enforces valid Sanskrit root grammar.</a:t>
+              <a:t>theta_valley = 0.25 · ((Peak_L + Peak_R) / 2)</a:t>
             </a:r>
           </a:p>
         </p:txBody>
@@ -4348,7 +4334,7 @@
               </a:defRPr>
             </a:pPr>
             <a:r>
-              <a:t>Slide 11 / 17</a:t>
+              <a:t>Slide 11 / 18</a:t>
             </a:r>
           </a:p>
         </p:txBody>
@@ -4645,7 +4631,7 @@
               <a:spcAft>
                 <a:spcPts val="400"/>
               </a:spcAft>
-              <a:defRPr sz="1150" b="1">
+              <a:defRPr sz="1100" b="1">
                 <a:solidFill>
                   <a:srgbClr val="0000DC"/>
                 </a:solidFill>
@@ -4830,7 +4816,7 @@
               <a:spcAft>
                 <a:spcPts val="400"/>
               </a:spcAft>
-              <a:defRPr sz="1150" b="1">
+              <a:defRPr sz="1100" b="1">
                 <a:solidFill>
                   <a:srgbClr val="0000DC"/>
                 </a:solidFill>
@@ -4876,7 +4862,7 @@
               </a:defRPr>
             </a:pPr>
             <a:r>
-              <a:t>Slide 12 / 17</a:t>
+              <a:t>Slide 12 / 18</a:t>
             </a:r>
           </a:p>
         </p:txBody>
@@ -5082,7 +5068,7 @@
               </a:defRPr>
             </a:pPr>
             <a:r>
-              <a:t>Slide 13 / 17</a:t>
+              <a:t>Slide 13 / 18</a:t>
             </a:r>
           </a:p>
         </p:txBody>
@@ -5288,7 +5274,7 @@
               </a:defRPr>
             </a:pPr>
             <a:r>
-              <a:t>Slide 14 / 17</a:t>
+              <a:t>Slide 14 / 18</a:t>
             </a:r>
           </a:p>
         </p:txBody>
@@ -5585,7 +5571,7 @@
               <a:spcAft>
                 <a:spcPts val="400"/>
               </a:spcAft>
-              <a:defRPr sz="1150" b="1">
+              <a:defRPr sz="1100" b="1">
                 <a:solidFill>
                   <a:srgbClr val="0000DC"/>
                 </a:solidFill>
@@ -5804,7 +5790,7 @@
               <a:spcAft>
                 <a:spcPts val="400"/>
               </a:spcAft>
-              <a:defRPr sz="1150" b="1">
+              <a:defRPr sz="1100" b="1">
                 <a:solidFill>
                   <a:srgbClr val="0000DC"/>
                 </a:solidFill>
@@ -5850,7 +5836,7 @@
               </a:defRPr>
             </a:pPr>
             <a:r>
-              <a:t>Slide 15 / 17</a:t>
+              <a:t>Slide 15 / 18</a:t>
             </a:r>
           </a:p>
         </p:txBody>
@@ -6177,7 +6163,7 @@
               <a:spcAft>
                 <a:spcPts val="400"/>
               </a:spcAft>
-              <a:defRPr sz="1150" b="1">
+              <a:defRPr sz="1100" b="1">
                 <a:solidFill>
                   <a:srgbClr val="0000DC"/>
                 </a:solidFill>
@@ -6373,7 +6359,7 @@
               <a:spcAft>
                 <a:spcPts val="400"/>
               </a:spcAft>
-              <a:defRPr sz="1150" b="1">
+              <a:defRPr sz="1100" b="1">
                 <a:solidFill>
                   <a:srgbClr val="0000DC"/>
                 </a:solidFill>
@@ -6419,7 +6405,7 @@
               </a:defRPr>
             </a:pPr>
             <a:r>
-              <a:t>Slide 16 / 17</a:t>
+              <a:t>Slide 16 / 18</a:t>
             </a:r>
           </a:p>
         </p:txBody>
@@ -6507,7 +6493,7 @@
               </a:defRPr>
             </a:pPr>
             <a:r>
-              <a:t>Summary of Technical Contributions and Conclusion</a:t>
+              <a:t>Standardized Output Formats &amp; Production Scaling</a:t>
             </a:r>
           </a:p>
         </p:txBody>
@@ -6542,7 +6528,7 @@
               </a:defRPr>
             </a:pPr>
             <a:r>
-              <a:t>Standardized Heritage Document Analysis Framework</a:t>
+              <a:t>PRImA PAGE-XML 2013 Schema Conformance and Production Readiness</a:t>
             </a:r>
           </a:p>
         </p:txBody>
@@ -6556,7 +6542,7 @@
         <p:spPr>
           <a:xfrm>
             <a:off x="731520" y="1554480"/>
-            <a:ext cx="10698480" cy="4663440"/>
+            <a:ext cx="5212080" cy="4663440"/>
           </a:xfrm>
           <a:prstGeom prst="roundRect">
             <a:avLst/>
@@ -6601,7 +6587,7 @@
         <p:spPr>
           <a:xfrm>
             <a:off x="731520" y="1554480"/>
-            <a:ext cx="10698480" cy="438912"/>
+            <a:ext cx="5212080" cy="438912"/>
           </a:xfrm>
           <a:prstGeom prst="roundRect">
             <a:avLst/>
@@ -6639,7 +6625,7 @@
               </a:defRPr>
             </a:pPr>
             <a:r>
-              <a:t>  Core Technical Contributions</a:t>
+              <a:t>  PRImA PAGE-XML 2013 Hierarchy</a:t>
             </a:r>
           </a:p>
         </p:txBody>
@@ -6653,7 +6639,7 @@
         <p:spPr>
           <a:xfrm>
             <a:off x="914400" y="2057400"/>
-            <a:ext cx="10332720" cy="4069080"/>
+            <a:ext cx="4846320" cy="4069080"/>
           </a:xfrm>
           <a:prstGeom prst="rect">
             <a:avLst/>
@@ -6677,7 +6663,7 @@
               </a:defRPr>
             </a:pPr>
             <a:r>
-              <a:t>• 1. Geometry-First Paradigm: Fused DINOv2 self-supervised manifolds with physical morphology to eliminate labeled data cold-start.</a:t>
+              <a:t>• PcGts (Root Archive Container)</a:t>
             </a:r>
           </a:p>
           <a:p>
@@ -6692,7 +6678,7 @@
               </a:defRPr>
             </a:pPr>
             <a:r>
-              <a:t>• 2. Analytical Shirorekha Ablation: Formulated horizontal peak ablation and vertical Gaussian valley tracking.</a:t>
+              <a:t>•   └── Page (Folio image dimensions)</a:t>
             </a:r>
           </a:p>
           <a:p>
@@ -6707,7 +6693,7 @@
               </a:defRPr>
             </a:pPr>
             <a:r>
-              <a:t>• 3. Deep Multi-Class Segmentation: 6-channel nnU-Net with Instance Normalization and isoperimetric damage isolation.</a:t>
+              <a:t>•        ├── TextRegion (Paragraph &amp; column bounds)</a:t>
             </a:r>
           </a:p>
           <a:p>
@@ -6722,7 +6708,7 @@
               </a:defRPr>
             </a:pPr>
             <a:r>
-              <a:t>• 4. CTC-HTR Sanskrit Transcription: Bidirectional LSTM sequence modeling with Beam Search and Language Model decoding.</a:t>
+              <a:t>•        │     └── TextLine (Line-level polygon + text)</a:t>
             </a:r>
           </a:p>
           <a:p>
@@ -6737,7 +6723,52 @@
               </a:defRPr>
             </a:pPr>
             <a:r>
-              <a:t>• 5. Empirical Verification: 84.50% Accuracy, 15.32% CER, 9.97% WER, and 75.4% human latency reduction across 1,054 degraded folios under the PRImA PAGE-XML 2013 standard.</a:t>
+              <a:t>•        │           └── Word (Word bbox + Unicode)</a:t>
+            </a:r>
+          </a:p>
+          <a:p>
+            <a:pPr>
+              <a:spcAft>
+                <a:spcPts val="400"/>
+              </a:spcAft>
+              <a:defRPr sz="1150">
+                <a:solidFill>
+                  <a:srgbClr val="1E293B"/>
+                </a:solidFill>
+              </a:defRPr>
+            </a:pPr>
+            <a:r>
+              <a:t>•        │                 └── Glyph (Akshara bbox)</a:t>
+            </a:r>
+          </a:p>
+          <a:p>
+            <a:pPr>
+              <a:spcAft>
+                <a:spcPts val="400"/>
+              </a:spcAft>
+              <a:defRPr sz="1150">
+                <a:solidFill>
+                  <a:srgbClr val="1E293B"/>
+                </a:solidFill>
+              </a:defRPr>
+            </a:pPr>
+            <a:r>
+              <a:t>•        └── GraphicRegion (Artwork / illustrations)</a:t>
+            </a:r>
+          </a:p>
+          <a:p>
+            <a:pPr>
+              <a:spcAft>
+                <a:spcPts val="400"/>
+              </a:spcAft>
+              <a:defRPr sz="1150">
+                <a:solidFill>
+                  <a:srgbClr val="1E293B"/>
+                </a:solidFill>
+              </a:defRPr>
+            </a:pPr>
+            <a:r>
+              <a:t>• Fully compatible with Aletheia, Transkribus, &amp; eScriptorium.</a:t>
             </a:r>
           </a:p>
           <a:p>
@@ -6746,21 +6777,240 @@
               <a:spcAft>
                 <a:spcPts val="400"/>
               </a:spcAft>
-              <a:defRPr sz="1150" b="1">
+              <a:defRPr sz="1100" b="1">
                 <a:solidFill>
                   <a:srgbClr val="0000DC"/>
                 </a:solidFill>
               </a:defRPr>
             </a:pPr>
             <a:r>
-              <a:t>Framework Status: Fully Reproducible  ·  Standard PRImA PAGE-XML 2013 Output  ·  Open Academic Release</a:t>
-            </a:r>
-          </a:p>
-        </p:txBody>
-      </p:sp>
-      <p:sp>
-        <p:nvSpPr>
-          <p:cNvPr id="8" name="TextBox 7"/>
+              <a:t>RDP Polygon Simplification:</a:t>
+            </a:r>
+            <a:br/>
+            <a:r>
+              <a:t>Perpendicular distance threshold eps = 0.005·ArcLength</a:t>
+            </a:r>
+            <a:br/>
+            <a:r>
+              <a:t>Reduces vertex count by 82.6% (IoU &gt; 0.98).</a:t>
+            </a:r>
+          </a:p>
+        </p:txBody>
+      </p:sp>
+      <p:sp>
+        <p:nvSpPr>
+          <p:cNvPr id="8" name="Rounded Rectangle 7"/>
+          <p:cNvSpPr/>
+          <p:nvPr/>
+        </p:nvSpPr>
+        <p:spPr>
+          <a:xfrm>
+            <a:off x="6217920" y="1554480"/>
+            <a:ext cx="5212080" cy="4663440"/>
+          </a:xfrm>
+          <a:prstGeom prst="roundRect">
+            <a:avLst/>
+          </a:prstGeom>
+          <a:solidFill>
+            <a:srgbClr val="F5F7FA"/>
+          </a:solidFill>
+          <a:ln w="15240">
+            <a:solidFill>
+              <a:srgbClr val="CBD5E1"/>
+            </a:solidFill>
+          </a:ln>
+        </p:spPr>
+        <p:style>
+          <a:lnRef idx="1">
+            <a:schemeClr val="accent1"/>
+          </a:lnRef>
+          <a:fillRef idx="3">
+            <a:schemeClr val="accent1"/>
+          </a:fillRef>
+          <a:effectRef idx="2">
+            <a:schemeClr val="accent1"/>
+          </a:effectRef>
+          <a:fontRef idx="minor">
+            <a:schemeClr val="lt1"/>
+          </a:fontRef>
+        </p:style>
+        <p:txBody>
+          <a:bodyPr rtlCol="0" anchor="ctr"/>
+          <a:lstStyle/>
+          <a:p>
+            <a:pPr algn="ctr"/>
+          </a:p>
+        </p:txBody>
+      </p:sp>
+      <p:sp>
+        <p:nvSpPr>
+          <p:cNvPr id="9" name="Rounded Rectangle 8"/>
+          <p:cNvSpPr/>
+          <p:nvPr/>
+        </p:nvSpPr>
+        <p:spPr>
+          <a:xfrm>
+            <a:off x="6217920" y="1554480"/>
+            <a:ext cx="5212080" cy="438912"/>
+          </a:xfrm>
+          <a:prstGeom prst="roundRect">
+            <a:avLst/>
+          </a:prstGeom>
+          <a:solidFill>
+            <a:srgbClr val="0000DC"/>
+          </a:solidFill>
+          <a:ln>
+            <a:noFill/>
+          </a:ln>
+        </p:spPr>
+        <p:style>
+          <a:lnRef idx="1">
+            <a:schemeClr val="accent1"/>
+          </a:lnRef>
+          <a:fillRef idx="3">
+            <a:schemeClr val="accent1"/>
+          </a:fillRef>
+          <a:effectRef idx="2">
+            <a:schemeClr val="accent1"/>
+          </a:effectRef>
+          <a:fontRef idx="minor">
+            <a:schemeClr val="lt1"/>
+          </a:fontRef>
+        </p:style>
+        <p:txBody>
+          <a:bodyPr rtlCol="0" anchor="ctr"/>
+          <a:lstStyle/>
+          <a:p>
+            <a:pPr algn="ctr">
+              <a:defRPr sz="1300" b="1">
+                <a:solidFill>
+                  <a:srgbClr val="FFFFFF"/>
+                </a:solidFill>
+              </a:defRPr>
+            </a:pPr>
+            <a:r>
+              <a:t>  Benchmark Accuracy Highlights</a:t>
+            </a:r>
+          </a:p>
+        </p:txBody>
+      </p:sp>
+      <p:sp>
+        <p:nvSpPr>
+          <p:cNvPr id="10" name="TextBox 9"/>
+          <p:cNvSpPr txBox="1"/>
+          <p:nvPr/>
+        </p:nvSpPr>
+        <p:spPr>
+          <a:xfrm>
+            <a:off x="6400800" y="2057400"/>
+            <a:ext cx="4846320" cy="4069080"/>
+          </a:xfrm>
+          <a:prstGeom prst="rect">
+            <a:avLst/>
+          </a:prstGeom>
+          <a:noFill/>
+        </p:spPr>
+        <p:txBody>
+          <a:bodyPr wrap="square">
+            <a:spAutoFit/>
+          </a:bodyPr>
+          <a:lstStyle/>
+          <a:p>
+            <a:pPr>
+              <a:spcAft>
+                <a:spcPts val="400"/>
+              </a:spcAft>
+              <a:defRPr sz="1150">
+                <a:solidFill>
+                  <a:srgbClr val="1E293B"/>
+                </a:solidFill>
+              </a:defRPr>
+            </a:pPr>
+            <a:r>
+              <a:t>• Overall Accuracy: 84.50%</a:t>
+            </a:r>
+          </a:p>
+          <a:p>
+            <a:pPr>
+              <a:spcAft>
+                <a:spcPts val="400"/>
+              </a:spcAft>
+              <a:defRPr sz="1150">
+                <a:solidFill>
+                  <a:srgbClr val="1E293B"/>
+                </a:solidFill>
+              </a:defRPr>
+            </a:pPr>
+            <a:r>
+              <a:t>• Character Error Rate (CER): 15.32%</a:t>
+            </a:r>
+          </a:p>
+          <a:p>
+            <a:pPr>
+              <a:spcAft>
+                <a:spcPts val="400"/>
+              </a:spcAft>
+              <a:defRPr sz="1150">
+                <a:solidFill>
+                  <a:srgbClr val="1E293B"/>
+                </a:solidFill>
+              </a:defRPr>
+            </a:pPr>
+            <a:r>
+              <a:t>• Word Error Rate (WER): 9.97%</a:t>
+            </a:r>
+          </a:p>
+          <a:p>
+            <a:pPr>
+              <a:spcAft>
+                <a:spcPts val="400"/>
+              </a:spcAft>
+              <a:defRPr sz="1150">
+                <a:solidFill>
+                  <a:srgbClr val="1E293B"/>
+                </a:solidFill>
+              </a:defRPr>
+            </a:pPr>
+            <a:r>
+              <a:t>• Human Correction Time: 2.9 min/page (75.4% reduction)</a:t>
+            </a:r>
+          </a:p>
+          <a:p>
+            <a:pPr>
+              <a:spcAft>
+                <a:spcPts val="400"/>
+              </a:spcAft>
+              <a:defRPr sz="1150">
+                <a:solidFill>
+                  <a:srgbClr val="1E293B"/>
+                </a:solidFill>
+              </a:defRPr>
+            </a:pPr>
+            <a:r>
+              <a:t>• Evaluated on 1,054 historical manuscript folios with 0.00% empty predictions.</a:t>
+            </a:r>
+          </a:p>
+          <a:p>
+            <a:br/>
+            <a:pPr>
+              <a:spcAft>
+                <a:spcPts val="400"/>
+              </a:spcAft>
+              <a:defRPr sz="1100" b="1">
+                <a:solidFill>
+                  <a:srgbClr val="0000DC"/>
+                </a:solidFill>
+              </a:defRPr>
+            </a:pPr>
+            <a:r>
+              <a:t>Scalable Pipeline: Batch processing at 350 ms/page on NVIDIA RTX GPU.</a:t>
+            </a:r>
+          </a:p>
+        </p:txBody>
+      </p:sp>
+      <p:sp>
+        <p:nvSpPr>
+          <p:cNvPr id="11" name="TextBox 10"/>
           <p:cNvSpPr txBox="1"/>
           <p:nvPr/>
         </p:nvSpPr>
@@ -6788,7 +7038,376 @@
               </a:defRPr>
             </a:pPr>
             <a:r>
-              <a:t>Slide 17 / 17</a:t>
+              <a:t>Slide 17 / 18</a:t>
+            </a:r>
+          </a:p>
+        </p:txBody>
+      </p:sp>
+    </p:spTree>
+  </p:cSld>
+  <p:clrMapOvr>
+    <a:masterClrMapping/>
+  </p:clrMapOvr>
+</p:sld>
+</file>
+
+<file path=ppt/slides/slide18.xml><?xml version="1.0" encoding="utf-8"?>
+<p:sld xmlns:a="http://schemas.openxmlformats.org/drawingml/2006/main" xmlns:p="http://schemas.openxmlformats.org/presentationml/2006/main" xmlns:r="http://schemas.openxmlformats.org/officeDocument/2006/relationships">
+  <p:cSld>
+    <p:spTree>
+      <p:nvGrpSpPr>
+        <p:cNvPr id="1" name=""/>
+        <p:cNvGrpSpPr/>
+        <p:nvPr/>
+      </p:nvGrpSpPr>
+      <p:grpSpPr/>
+      <p:sp>
+        <p:nvSpPr>
+          <p:cNvPr id="2" name="TextBox 1"/>
+          <p:cNvSpPr txBox="1"/>
+          <p:nvPr/>
+        </p:nvSpPr>
+        <p:spPr>
+          <a:xfrm>
+            <a:off x="731520" y="320040"/>
+            <a:ext cx="10698480" cy="320040"/>
+          </a:xfrm>
+          <a:prstGeom prst="rect">
+            <a:avLst/>
+          </a:prstGeom>
+          <a:noFill/>
+        </p:spPr>
+        <p:txBody>
+          <a:bodyPr wrap="square">
+            <a:spAutoFit/>
+          </a:bodyPr>
+          <a:lstStyle/>
+          <a:p>
+            <a:pPr>
+              <a:defRPr sz="1050" b="1">
+                <a:solidFill>
+                  <a:srgbClr val="0000DC"/>
+                </a:solidFill>
+              </a:defRPr>
+            </a:pPr>
+            <a:r>
+              <a:t>SECTION 4: CONCLUSION</a:t>
+            </a:r>
+          </a:p>
+        </p:txBody>
+      </p:sp>
+      <p:sp>
+        <p:nvSpPr>
+          <p:cNvPr id="3" name="TextBox 2"/>
+          <p:cNvSpPr txBox="1"/>
+          <p:nvPr/>
+        </p:nvSpPr>
+        <p:spPr>
+          <a:xfrm>
+            <a:off x="731520" y="594360"/>
+            <a:ext cx="10698480" cy="502920"/>
+          </a:xfrm>
+          <a:prstGeom prst="rect">
+            <a:avLst/>
+          </a:prstGeom>
+          <a:noFill/>
+        </p:spPr>
+        <p:txBody>
+          <a:bodyPr wrap="square">
+            <a:spAutoFit/>
+          </a:bodyPr>
+          <a:lstStyle/>
+          <a:p>
+            <a:pPr>
+              <a:defRPr sz="2100" b="1">
+                <a:solidFill>
+                  <a:srgbClr val="0F172A"/>
+                </a:solidFill>
+              </a:defRPr>
+            </a:pPr>
+            <a:r>
+              <a:t>Summary of Technical Contributions and Conclusion</a:t>
+            </a:r>
+          </a:p>
+        </p:txBody>
+      </p:sp>
+      <p:sp>
+        <p:nvSpPr>
+          <p:cNvPr id="4" name="TextBox 3"/>
+          <p:cNvSpPr txBox="1"/>
+          <p:nvPr/>
+        </p:nvSpPr>
+        <p:spPr>
+          <a:xfrm>
+            <a:off x="731520" y="1051560"/>
+            <a:ext cx="10698480" cy="365760"/>
+          </a:xfrm>
+          <a:prstGeom prst="rect">
+            <a:avLst/>
+          </a:prstGeom>
+          <a:noFill/>
+        </p:spPr>
+        <p:txBody>
+          <a:bodyPr wrap="square">
+            <a:spAutoFit/>
+          </a:bodyPr>
+          <a:lstStyle/>
+          <a:p>
+            <a:pPr>
+              <a:defRPr sz="1300">
+                <a:solidFill>
+                  <a:srgbClr val="475569"/>
+                </a:solidFill>
+              </a:defRPr>
+            </a:pPr>
+            <a:r>
+              <a:t>Standardized Heritage Document Analysis Framework</a:t>
+            </a:r>
+          </a:p>
+        </p:txBody>
+      </p:sp>
+      <p:sp>
+        <p:nvSpPr>
+          <p:cNvPr id="5" name="Rounded Rectangle 4"/>
+          <p:cNvSpPr/>
+          <p:nvPr/>
+        </p:nvSpPr>
+        <p:spPr>
+          <a:xfrm>
+            <a:off x="731520" y="1554480"/>
+            <a:ext cx="10698480" cy="4663440"/>
+          </a:xfrm>
+          <a:prstGeom prst="roundRect">
+            <a:avLst/>
+          </a:prstGeom>
+          <a:solidFill>
+            <a:srgbClr val="F5F7FA"/>
+          </a:solidFill>
+          <a:ln w="15240">
+            <a:solidFill>
+              <a:srgbClr val="CBD5E1"/>
+            </a:solidFill>
+          </a:ln>
+        </p:spPr>
+        <p:style>
+          <a:lnRef idx="1">
+            <a:schemeClr val="accent1"/>
+          </a:lnRef>
+          <a:fillRef idx="3">
+            <a:schemeClr val="accent1"/>
+          </a:fillRef>
+          <a:effectRef idx="2">
+            <a:schemeClr val="accent1"/>
+          </a:effectRef>
+          <a:fontRef idx="minor">
+            <a:schemeClr val="lt1"/>
+          </a:fontRef>
+        </p:style>
+        <p:txBody>
+          <a:bodyPr rtlCol="0" anchor="ctr"/>
+          <a:lstStyle/>
+          <a:p>
+            <a:pPr algn="ctr"/>
+          </a:p>
+        </p:txBody>
+      </p:sp>
+      <p:sp>
+        <p:nvSpPr>
+          <p:cNvPr id="6" name="Rounded Rectangle 5"/>
+          <p:cNvSpPr/>
+          <p:nvPr/>
+        </p:nvSpPr>
+        <p:spPr>
+          <a:xfrm>
+            <a:off x="731520" y="1554480"/>
+            <a:ext cx="10698480" cy="438912"/>
+          </a:xfrm>
+          <a:prstGeom prst="roundRect">
+            <a:avLst/>
+          </a:prstGeom>
+          <a:solidFill>
+            <a:srgbClr val="0000DC"/>
+          </a:solidFill>
+          <a:ln>
+            <a:noFill/>
+          </a:ln>
+        </p:spPr>
+        <p:style>
+          <a:lnRef idx="1">
+            <a:schemeClr val="accent1"/>
+          </a:lnRef>
+          <a:fillRef idx="3">
+            <a:schemeClr val="accent1"/>
+          </a:fillRef>
+          <a:effectRef idx="2">
+            <a:schemeClr val="accent1"/>
+          </a:effectRef>
+          <a:fontRef idx="minor">
+            <a:schemeClr val="lt1"/>
+          </a:fontRef>
+        </p:style>
+        <p:txBody>
+          <a:bodyPr rtlCol="0" anchor="ctr"/>
+          <a:lstStyle/>
+          <a:p>
+            <a:pPr algn="ctr">
+              <a:defRPr sz="1300" b="1">
+                <a:solidFill>
+                  <a:srgbClr val="FFFFFF"/>
+                </a:solidFill>
+              </a:defRPr>
+            </a:pPr>
+            <a:r>
+              <a:t>  Core Technical Contributions</a:t>
+            </a:r>
+          </a:p>
+        </p:txBody>
+      </p:sp>
+      <p:sp>
+        <p:nvSpPr>
+          <p:cNvPr id="7" name="TextBox 6"/>
+          <p:cNvSpPr txBox="1"/>
+          <p:nvPr/>
+        </p:nvSpPr>
+        <p:spPr>
+          <a:xfrm>
+            <a:off x="914400" y="2057400"/>
+            <a:ext cx="10332720" cy="4069080"/>
+          </a:xfrm>
+          <a:prstGeom prst="rect">
+            <a:avLst/>
+          </a:prstGeom>
+          <a:noFill/>
+        </p:spPr>
+        <p:txBody>
+          <a:bodyPr wrap="square">
+            <a:spAutoFit/>
+          </a:bodyPr>
+          <a:lstStyle/>
+          <a:p>
+            <a:pPr>
+              <a:spcAft>
+                <a:spcPts val="400"/>
+              </a:spcAft>
+              <a:defRPr sz="1150">
+                <a:solidFill>
+                  <a:srgbClr val="1E293B"/>
+                </a:solidFill>
+              </a:defRPr>
+            </a:pPr>
+            <a:r>
+              <a:t>• 1. Geometry-First Paradigm: Fused DINOv2 self-supervised manifolds with physical morphology to eliminate labeled data cold-start.</a:t>
+            </a:r>
+          </a:p>
+          <a:p>
+            <a:pPr>
+              <a:spcAft>
+                <a:spcPts val="400"/>
+              </a:spcAft>
+              <a:defRPr sz="1150">
+                <a:solidFill>
+                  <a:srgbClr val="1E293B"/>
+                </a:solidFill>
+              </a:defRPr>
+            </a:pPr>
+            <a:r>
+              <a:t>• 2. Analytical Shirorekha Ablation: Formulated horizontal peak ablation and vertical Gaussian valley tracking for Aksharas.</a:t>
+            </a:r>
+          </a:p>
+          <a:p>
+            <a:pPr>
+              <a:spcAft>
+                <a:spcPts val="400"/>
+              </a:spcAft>
+              <a:defRPr sz="1150">
+                <a:solidFill>
+                  <a:srgbClr val="1E293B"/>
+                </a:solidFill>
+              </a:defRPr>
+            </a:pPr>
+            <a:r>
+              <a:t>• 3. Deep Multi-Class Segmentation: 6-channel nnU-Net with Instance Normalization and isoperimetric damage isolation.</a:t>
+            </a:r>
+          </a:p>
+          <a:p>
+            <a:pPr>
+              <a:spcAft>
+                <a:spcPts val="400"/>
+              </a:spcAft>
+              <a:defRPr sz="1150">
+                <a:solidFill>
+                  <a:srgbClr val="1E293B"/>
+                </a:solidFill>
+              </a:defRPr>
+            </a:pPr>
+            <a:r>
+              <a:t>• 4. Multilingual CTC-HTR OCR: Bidirectional LSTM sequence modeling with Beam Search and Language Model decoding.</a:t>
+            </a:r>
+          </a:p>
+          <a:p>
+            <a:pPr>
+              <a:spcAft>
+                <a:spcPts val="400"/>
+              </a:spcAft>
+              <a:defRPr sz="1150">
+                <a:solidFill>
+                  <a:srgbClr val="1E293B"/>
+                </a:solidFill>
+              </a:defRPr>
+            </a:pPr>
+            <a:r>
+              <a:t>• 5. Empirical Verification: 84.50% Accuracy, 15.32% CER, 9.97% WER, and 75.4% human latency reduction across 1,054 degraded folios under the PRImA PAGE-XML 2013 standard.</a:t>
+            </a:r>
+          </a:p>
+          <a:p>
+            <a:br/>
+            <a:pPr>
+              <a:spcAft>
+                <a:spcPts val="400"/>
+              </a:spcAft>
+              <a:defRPr sz="1100" b="1">
+                <a:solidFill>
+                  <a:srgbClr val="0000DC"/>
+                </a:solidFill>
+              </a:defRPr>
+            </a:pPr>
+            <a:r>
+              <a:t>Framework Status: Fully Reproducible  ·  Standard PRImA PAGE-XML 2013 Output  ·  Open Academic Release</a:t>
+            </a:r>
+          </a:p>
+        </p:txBody>
+      </p:sp>
+      <p:sp>
+        <p:nvSpPr>
+          <p:cNvPr id="8" name="TextBox 7"/>
+          <p:cNvSpPr txBox="1"/>
+          <p:nvPr/>
+        </p:nvSpPr>
+        <p:spPr>
+          <a:xfrm>
+            <a:off x="731520" y="6446520"/>
+            <a:ext cx="10698480" cy="320040"/>
+          </a:xfrm>
+          <a:prstGeom prst="rect">
+            <a:avLst/>
+          </a:prstGeom>
+          <a:noFill/>
+        </p:spPr>
+        <p:txBody>
+          <a:bodyPr wrap="none">
+            <a:spAutoFit/>
+          </a:bodyPr>
+          <a:lstStyle/>
+          <a:p>
+            <a:pPr>
+              <a:defRPr sz="950">
+                <a:solidFill>
+                  <a:srgbClr val="64748B"/>
+                </a:solidFill>
+              </a:defRPr>
+            </a:pPr>
+            <a:r>
+              <a:t>Slide 18 / 18</a:t>
             </a:r>
           </a:p>
         </p:txBody>
@@ -6876,7 +7495,7 @@
               </a:defRPr>
             </a:pPr>
             <a:r>
-              <a:t>Physical and Orthographic Characteristics of Indic Manuscripts</a:t>
+              <a:t>Introduction &amp; Problem Statement</a:t>
             </a:r>
           </a:p>
         </p:txBody>
@@ -6911,7 +7530,7 @@
               </a:defRPr>
             </a:pPr>
             <a:r>
-              <a:t>Substrate Degradation and Connected Orthography Modeling</a:t>
+              <a:t>Historical Manuscript Degradation and Manual Annotation Bottlenecks</a:t>
             </a:r>
           </a:p>
         </p:txBody>
@@ -7008,7 +7627,7 @@
               </a:defRPr>
             </a:pPr>
             <a:r>
-              <a:t>  1. Continuous Headline (Shirorekha) Modeling</a:t>
+              <a:t>  1. Heritage at Risk &amp; OCR Limitations</a:t>
             </a:r>
           </a:p>
         </p:txBody>
@@ -7046,7 +7665,7 @@
               </a:defRPr>
             </a:pPr>
             <a:r>
-              <a:t>• Devanagari characters are bound along the upper boundary by a horizontal stroke.</a:t>
+              <a:t>• Thousands of Indic manuscripts (Ramcharitmanas, palm-leaf folios) suffer severe decay from humidity, insects, and ink corrosion.</a:t>
             </a:r>
           </a:p>
           <a:p>
@@ -7061,7 +7680,7 @@
               </a:defRPr>
             </a:pPr>
             <a:r>
-              <a:t>• Connected components group entire lines as single entities without segmentation.</a:t>
+              <a:t>• Standard OCR (Tesseract, Google Vision) fails on complex Devanagari with conjuncts, matras, and non-standard layouts.</a:t>
             </a:r>
           </a:p>
           <a:p>
@@ -7076,7 +7695,7 @@
               </a:defRPr>
             </a:pPr>
             <a:r>
-              <a:t>• Mathematical line union representation:</a:t>
+              <a:t>• Optical image formation equation:</a:t>
             </a:r>
           </a:p>
           <a:p>
@@ -7085,18 +7704,22 @@
               <a:spcAft>
                 <a:spcPts val="400"/>
               </a:spcAft>
-              <a:defRPr sz="1150" b="1">
+              <a:defRPr sz="1100" b="1">
                 <a:solidFill>
                   <a:srgbClr val="0000DC"/>
                 </a:solidFill>
               </a:defRPr>
             </a:pPr>
             <a:r>
-              <a:t>S_word = Union_{i=1}^M G_i  UNION  H_shirorekha</a:t>
+              <a:t>I(x,y) = R(x,y) · L(x,y) + eta(x,y)</a:t>
             </a:r>
             <a:br/>
             <a:r>
-              <a:t>where G_i denotes individual glyph components.</a:t>
+              <a:t>where R(x,y) is true reflectance, L(x,y) is illumination,</a:t>
+            </a:r>
+            <a:br/>
+            <a:r>
+              <a:t>and eta(x,y) is additive substrate decay noise.</a:t>
             </a:r>
           </a:p>
         </p:txBody>
@@ -7193,7 +7816,7 @@
               </a:defRPr>
             </a:pPr>
             <a:r>
-              <a:t>  2. Substrate Degradation &amp; Illumination Formulation</a:t>
+              <a:t>  2. Manual Annotation Bottleneck (3,000+ Pages)</a:t>
             </a:r>
           </a:p>
         </p:txBody>
@@ -7231,7 +7854,7 @@
               </a:defRPr>
             </a:pPr>
             <a:r>
-              <a:t>• Palm-leaf (Borassus flabellifer) and handmade papers exhibit non-uniform decay.</a:t>
+              <a:t>• Expert paleographers spend 30 to 60 minutes per page manually drawing bounding boxes for regions, lines, words, and aksharas.</a:t>
             </a:r>
           </a:p>
           <a:p>
@@ -7246,7 +7869,7 @@
               </a:defRPr>
             </a:pPr>
             <a:r>
-              <a:t>• Iron-gall ink bleed-through, fraying margins, and punched circular string holes.</a:t>
+              <a:t>• At 3,000+ historical pages, manual annotation requires over 2,000 human-hours.</a:t>
             </a:r>
           </a:p>
           <a:p>
@@ -7261,7 +7884,7 @@
               </a:defRPr>
             </a:pPr>
             <a:r>
-              <a:t>• Physical image formation equation:</a:t>
+              <a:t>• Continuous headline modeling:</a:t>
             </a:r>
           </a:p>
           <a:p>
@@ -7270,22 +7893,22 @@
               <a:spcAft>
                 <a:spcPts val="400"/>
               </a:spcAft>
-              <a:defRPr sz="1150" b="1">
+              <a:defRPr sz="1100" b="1">
                 <a:solidFill>
                   <a:srgbClr val="0000DC"/>
                 </a:solidFill>
               </a:defRPr>
             </a:pPr>
             <a:r>
-              <a:t>I(x,y) = R(x,y) · L(x,y) + eta(x,y)</a:t>
+              <a:t>S_word = Union_{i=1}^M G_i  UNION  H_shirorekha</a:t>
             </a:r>
             <a:br/>
             <a:r>
-              <a:t>where R(x,y) is true reflectance, L(x,y) is illumination,</a:t>
+              <a:t>Connected components group entire lines into single blobs,</a:t>
             </a:r>
             <a:br/>
             <a:r>
-              <a:t>and eta(x,y) is additive substrate noise.</a:t>
+              <a:t>preventing classical character segmentation.</a:t>
             </a:r>
           </a:p>
         </p:txBody>
@@ -7320,7 +7943,7 @@
               </a:defRPr>
             </a:pPr>
             <a:r>
-              <a:t>Slide 2 / 17</a:t>
+              <a:t>Slide 2 / 18</a:t>
             </a:r>
           </a:p>
         </p:txBody>
@@ -7540,7 +8163,7 @@
               </a:defRPr>
             </a:pPr>
             <a:r>
-              <a:t>  Formal Layout Hierarchy Definition</a:t>
+              <a:t>  Formal Layout Hierarchy Definition (PAGE-XML 2013 Standard)</a:t>
             </a:r>
           </a:p>
         </p:txBody>
@@ -7617,7 +8240,7 @@
               <a:spcAft>
                 <a:spcPts val="400"/>
               </a:spcAft>
-              <a:defRPr sz="1150" b="1">
+              <a:defRPr sz="1100" b="1">
                 <a:solidFill>
                   <a:srgbClr val="0000DC"/>
                 </a:solidFill>
@@ -7663,7 +8286,7 @@
               </a:defRPr>
             </a:pPr>
             <a:r>
-              <a:t>Slide 3 / 17</a:t>
+              <a:t>Slide 3 / 18</a:t>
             </a:r>
           </a:p>
         </p:txBody>
@@ -7751,7 +8374,7 @@
               </a:defRPr>
             </a:pPr>
             <a:r>
-              <a:t>Image Preprocessing and Local Illumination Compensation</a:t>
+              <a:t>Proposed 3-Stage End-to-End System Architecture</a:t>
             </a:r>
           </a:p>
         </p:txBody>
@@ -7786,384 +8409,38 @@
               </a:defRPr>
             </a:pPr>
             <a:r>
-              <a:t>Adaptive Gaussian Binarization and Morphological Filtering</a:t>
-            </a:r>
-          </a:p>
-        </p:txBody>
-      </p:sp>
-      <p:sp>
-        <p:nvSpPr>
-          <p:cNvPr id="5" name="Rounded Rectangle 4"/>
-          <p:cNvSpPr/>
-          <p:nvPr/>
-        </p:nvSpPr>
+              <a:t>Integration of Foundation Vision Models, Physical Morphology, and Deep Segmentation</a:t>
+            </a:r>
+          </a:p>
+        </p:txBody>
+      </p:sp>
+      <p:pic>
+        <p:nvPicPr>
+          <p:cNvPr id="5" name="Picture 4" descr="pipeline_flowchart_white.png"/>
+          <p:cNvPicPr>
+            <a:picLocks noChangeAspect="1"/>
+          </p:cNvPicPr>
+          <p:nvPr/>
+        </p:nvPicPr>
+        <p:blipFill>
+          <a:blip r:embed="rId2"/>
+          <a:stretch>
+            <a:fillRect/>
+          </a:stretch>
+        </p:blipFill>
         <p:spPr>
           <a:xfrm>
             <a:off x="731520" y="1554480"/>
-            <a:ext cx="5212080" cy="4663440"/>
-          </a:xfrm>
-          <a:prstGeom prst="roundRect">
-            <a:avLst/>
-          </a:prstGeom>
-          <a:solidFill>
-            <a:srgbClr val="F5F7FA"/>
-          </a:solidFill>
-          <a:ln w="15240">
-            <a:solidFill>
-              <a:srgbClr val="CBD5E1"/>
-            </a:solidFill>
-          </a:ln>
-        </p:spPr>
-        <p:style>
-          <a:lnRef idx="1">
-            <a:schemeClr val="accent1"/>
-          </a:lnRef>
-          <a:fillRef idx="3">
-            <a:schemeClr val="accent1"/>
-          </a:fillRef>
-          <a:effectRef idx="2">
-            <a:schemeClr val="accent1"/>
-          </a:effectRef>
-          <a:fontRef idx="minor">
-            <a:schemeClr val="lt1"/>
-          </a:fontRef>
-        </p:style>
-        <p:txBody>
-          <a:bodyPr rtlCol="0" anchor="ctr"/>
-          <a:lstStyle/>
-          <a:p>
-            <a:pPr algn="ctr"/>
-          </a:p>
-        </p:txBody>
-      </p:sp>
-      <p:sp>
-        <p:nvSpPr>
-          <p:cNvPr id="6" name="Rounded Rectangle 5"/>
-          <p:cNvSpPr/>
-          <p:nvPr/>
-        </p:nvSpPr>
-        <p:spPr>
-          <a:xfrm>
-            <a:off x="731520" y="1554480"/>
-            <a:ext cx="5212080" cy="438912"/>
-          </a:xfrm>
-          <a:prstGeom prst="roundRect">
-            <a:avLst/>
-          </a:prstGeom>
-          <a:solidFill>
-            <a:srgbClr val="0000DC"/>
-          </a:solidFill>
-          <a:ln>
-            <a:noFill/>
-          </a:ln>
-        </p:spPr>
-        <p:style>
-          <a:lnRef idx="1">
-            <a:schemeClr val="accent1"/>
-          </a:lnRef>
-          <a:fillRef idx="3">
-            <a:schemeClr val="accent1"/>
-          </a:fillRef>
-          <a:effectRef idx="2">
-            <a:schemeClr val="accent1"/>
-          </a:effectRef>
-          <a:fontRef idx="minor">
-            <a:schemeClr val="lt1"/>
-          </a:fontRef>
-        </p:style>
-        <p:txBody>
-          <a:bodyPr rtlCol="0" anchor="ctr"/>
-          <a:lstStyle/>
-          <a:p>
-            <a:pPr algn="ctr">
-              <a:defRPr sz="1300" b="1">
-                <a:solidFill>
-                  <a:srgbClr val="FFFFFF"/>
-                </a:solidFill>
-              </a:defRPr>
-            </a:pPr>
-            <a:r>
-              <a:t>  Adaptive Gaussian Thresholding</a:t>
-            </a:r>
-          </a:p>
-        </p:txBody>
-      </p:sp>
-      <p:sp>
-        <p:nvSpPr>
-          <p:cNvPr id="7" name="TextBox 6"/>
-          <p:cNvSpPr txBox="1"/>
-          <p:nvPr/>
-        </p:nvSpPr>
-        <p:spPr>
-          <a:xfrm>
-            <a:off x="914400" y="2057400"/>
-            <a:ext cx="4846320" cy="4069080"/>
+            <a:ext cx="10698480" cy="4572000"/>
           </a:xfrm>
           <a:prstGeom prst="rect">
             <a:avLst/>
           </a:prstGeom>
-          <a:noFill/>
-        </p:spPr>
-        <p:txBody>
-          <a:bodyPr wrap="square">
-            <a:spAutoFit/>
-          </a:bodyPr>
-          <a:lstStyle/>
-          <a:p>
-            <a:pPr>
-              <a:spcAft>
-                <a:spcPts val="400"/>
-              </a:spcAft>
-              <a:defRPr sz="1150">
-                <a:solidFill>
-                  <a:srgbClr val="1E293B"/>
-                </a:solidFill>
-              </a:defRPr>
-            </a:pPr>
-            <a:r>
-              <a:t>• Compensates for spatial illumination gradients L(x,y).</a:t>
-            </a:r>
-          </a:p>
-          <a:p>
-            <a:pPr>
-              <a:spcAft>
-                <a:spcPts val="400"/>
-              </a:spcAft>
-              <a:defRPr sz="1150">
-                <a:solidFill>
-                  <a:srgbClr val="1E293B"/>
-                </a:solidFill>
-              </a:defRPr>
-            </a:pPr>
-            <a:r>
-              <a:t>• Evaluates local neighborhood statistics in window (2r+1) x (2r+1):</a:t>
-            </a:r>
-          </a:p>
-          <a:p>
-            <a:pPr>
-              <a:spcAft>
-                <a:spcPts val="400"/>
-              </a:spcAft>
-              <a:defRPr sz="1150">
-                <a:solidFill>
-                  <a:srgbClr val="1E293B"/>
-                </a:solidFill>
-              </a:defRPr>
-            </a:pPr>
-            <a:r>
-              <a:t>• Parameter selection: r = 25, C = 5.</a:t>
-            </a:r>
-          </a:p>
-          <a:p>
-            <a:br/>
-            <a:pPr>
-              <a:spcAft>
-                <a:spcPts val="400"/>
-              </a:spcAft>
-              <a:defRPr sz="1150" b="1">
-                <a:solidFill>
-                  <a:srgbClr val="0000DC"/>
-                </a:solidFill>
-              </a:defRPr>
-            </a:pPr>
-            <a:r>
-              <a:t>B(x,y) = 1  if  I_gray(x,y) &lt; mu_G(x,y) - C  else  0</a:t>
-            </a:r>
-            <a:br/>
-            <a:r>
-              <a:t>mu_G(x,y) = (I_gray * G_sigma)(x,y)</a:t>
-            </a:r>
-          </a:p>
-        </p:txBody>
-      </p:sp>
-      <p:sp>
-        <p:nvSpPr>
-          <p:cNvPr id="8" name="Rounded Rectangle 7"/>
-          <p:cNvSpPr/>
-          <p:nvPr/>
-        </p:nvSpPr>
-        <p:spPr>
-          <a:xfrm>
-            <a:off x="6217920" y="1554480"/>
-            <a:ext cx="5212080" cy="4663440"/>
-          </a:xfrm>
-          <a:prstGeom prst="roundRect">
-            <a:avLst/>
-          </a:prstGeom>
-          <a:solidFill>
-            <a:srgbClr val="F5F7FA"/>
-          </a:solidFill>
-          <a:ln w="15240">
-            <a:solidFill>
-              <a:srgbClr val="CBD5E1"/>
-            </a:solidFill>
-          </a:ln>
-        </p:spPr>
-        <p:style>
-          <a:lnRef idx="1">
-            <a:schemeClr val="accent1"/>
-          </a:lnRef>
-          <a:fillRef idx="3">
-            <a:schemeClr val="accent1"/>
-          </a:fillRef>
-          <a:effectRef idx="2">
-            <a:schemeClr val="accent1"/>
-          </a:effectRef>
-          <a:fontRef idx="minor">
-            <a:schemeClr val="lt1"/>
-          </a:fontRef>
-        </p:style>
-        <p:txBody>
-          <a:bodyPr rtlCol="0" anchor="ctr"/>
-          <a:lstStyle/>
-          <a:p>
-            <a:pPr algn="ctr"/>
-          </a:p>
-        </p:txBody>
-      </p:sp>
-      <p:sp>
-        <p:nvSpPr>
-          <p:cNvPr id="9" name="Rounded Rectangle 8"/>
-          <p:cNvSpPr/>
-          <p:nvPr/>
-        </p:nvSpPr>
-        <p:spPr>
-          <a:xfrm>
-            <a:off x="6217920" y="1554480"/>
-            <a:ext cx="5212080" cy="438912"/>
-          </a:xfrm>
-          <a:prstGeom prst="roundRect">
-            <a:avLst/>
-          </a:prstGeom>
-          <a:solidFill>
-            <a:srgbClr val="0000DC"/>
-          </a:solidFill>
-          <a:ln>
-            <a:noFill/>
-          </a:ln>
-        </p:spPr>
-        <p:style>
-          <a:lnRef idx="1">
-            <a:schemeClr val="accent1"/>
-          </a:lnRef>
-          <a:fillRef idx="3">
-            <a:schemeClr val="accent1"/>
-          </a:fillRef>
-          <a:effectRef idx="2">
-            <a:schemeClr val="accent1"/>
-          </a:effectRef>
-          <a:fontRef idx="minor">
-            <a:schemeClr val="lt1"/>
-          </a:fontRef>
-        </p:style>
-        <p:txBody>
-          <a:bodyPr rtlCol="0" anchor="ctr"/>
-          <a:lstStyle/>
-          <a:p>
-            <a:pPr algn="ctr">
-              <a:defRPr sz="1300" b="1">
-                <a:solidFill>
-                  <a:srgbClr val="FFFFFF"/>
-                </a:solidFill>
-              </a:defRPr>
-            </a:pPr>
-            <a:r>
-              <a:t>  Morphological Opening Noise Suppression</a:t>
-            </a:r>
-          </a:p>
-        </p:txBody>
-      </p:sp>
-      <p:sp>
-        <p:nvSpPr>
-          <p:cNvPr id="10" name="TextBox 9"/>
-          <p:cNvSpPr txBox="1"/>
-          <p:nvPr/>
-        </p:nvSpPr>
-        <p:spPr>
-          <a:xfrm>
-            <a:off x="6400800" y="2057400"/>
-            <a:ext cx="4846320" cy="4069080"/>
-          </a:xfrm>
-          <a:prstGeom prst="rect">
-            <a:avLst/>
-          </a:prstGeom>
-          <a:noFill/>
-        </p:spPr>
-        <p:txBody>
-          <a:bodyPr wrap="square">
-            <a:spAutoFit/>
-          </a:bodyPr>
-          <a:lstStyle/>
-          <a:p>
-            <a:pPr>
-              <a:spcAft>
-                <a:spcPts val="400"/>
-              </a:spcAft>
-              <a:defRPr sz="1150">
-                <a:solidFill>
-                  <a:srgbClr val="1E293B"/>
-                </a:solidFill>
-              </a:defRPr>
-            </a:pPr>
-            <a:r>
-              <a:t>• Isolates true foreground ink from biological fiber artifacts.</a:t>
-            </a:r>
-          </a:p>
-          <a:p>
-            <a:pPr>
-              <a:spcAft>
-                <a:spcPts val="400"/>
-              </a:spcAft>
-              <a:defRPr sz="1150">
-                <a:solidFill>
-                  <a:srgbClr val="1E293B"/>
-                </a:solidFill>
-              </a:defRPr>
-            </a:pPr>
-            <a:r>
-              <a:t>• Elliptical structuring element E_(3x3) eliminates single-pixel noise:</a:t>
-            </a:r>
-          </a:p>
-          <a:p>
-            <a:pPr>
-              <a:spcAft>
-                <a:spcPts val="400"/>
-              </a:spcAft>
-              <a:defRPr sz="1150">
-                <a:solidFill>
-                  <a:srgbClr val="1E293B"/>
-                </a:solidFill>
-              </a:defRPr>
-            </a:pPr>
-            <a:r>
-              <a:t>• Morphological opening formulation:</a:t>
-            </a:r>
-          </a:p>
-          <a:p>
-            <a:br/>
-            <a:pPr>
-              <a:spcAft>
-                <a:spcPts val="400"/>
-              </a:spcAft>
-              <a:defRPr sz="1150" b="1">
-                <a:solidFill>
-                  <a:srgbClr val="0000DC"/>
-                </a:solidFill>
-              </a:defRPr>
-            </a:pPr>
-            <a:r>
-              <a:t>B_clean = (B (erosion) E_{3x3}) (dilation) E_{3x3}</a:t>
-            </a:r>
-            <a:br/>
-            <a:r>
-              <a:t>Preserves character strokes while removing background speckle.</a:t>
-            </a:r>
-          </a:p>
-        </p:txBody>
-      </p:sp>
-      <p:sp>
-        <p:nvSpPr>
-          <p:cNvPr id="11" name="TextBox 10"/>
+        </p:spPr>
+      </p:pic>
+      <p:sp>
+        <p:nvSpPr>
+          <p:cNvPr id="6" name="TextBox 5"/>
           <p:cNvSpPr txBox="1"/>
           <p:nvPr/>
         </p:nvSpPr>
@@ -8191,7 +8468,7 @@
               </a:defRPr>
             </a:pPr>
             <a:r>
-              <a:t>Slide 4 / 17</a:t>
+              <a:t>Slide 4 / 18</a:t>
             </a:r>
           </a:p>
         </p:txBody>
@@ -8279,7 +8556,7 @@
               </a:defRPr>
             </a:pPr>
             <a:r>
-              <a:t>Self-Supervised Feature Manifold Extraction</a:t>
+              <a:t>Image Preprocessing and Local Illumination Compensation</a:t>
             </a:r>
           </a:p>
         </p:txBody>
@@ -8314,7 +8591,7 @@
               </a:defRPr>
             </a:pPr>
             <a:r>
-              <a:t>DINOv2 Vision Transformer Patch Geometry &amp; Self-Attention</a:t>
+              <a:t>Adaptive Gaussian Binarization and Morphological Filtering</a:t>
             </a:r>
           </a:p>
         </p:txBody>
@@ -8411,7 +8688,7 @@
               </a:defRPr>
             </a:pPr>
             <a:r>
-              <a:t>  Patch Discretization &amp; Position Encoding</a:t>
+              <a:t>  Adaptive Gaussian Thresholding</a:t>
             </a:r>
           </a:p>
         </p:txBody>
@@ -8449,7 +8726,7 @@
               </a:defRPr>
             </a:pPr>
             <a:r>
-              <a:t>• Model Architecture: DINOv2-ViT-B/14 (D = 768, P = 14).</a:t>
+              <a:t>• Compensates for spatial illumination gradients L(x,y).</a:t>
             </a:r>
           </a:p>
           <a:p>
@@ -8464,7 +8741,7 @@
               </a:defRPr>
             </a:pPr>
             <a:r>
-              <a:t>• Input image dimensions aligned to patch multiples (P = 14 px):</a:t>
+              <a:t>• Evaluates local neighborhood statistics in window (2r+1) x (2r+1):</a:t>
             </a:r>
           </a:p>
           <a:p>
@@ -8479,7 +8756,7 @@
               </a:defRPr>
             </a:pPr>
             <a:r>
-              <a:t>• Total extracted tokens: N = (H'/14) * (W'/14).</a:t>
+              <a:t>• Parameter selection: r = 25, C = 5.</a:t>
             </a:r>
           </a:p>
           <a:p>
@@ -8488,18 +8765,18 @@
               <a:spcAft>
                 <a:spcPts val="400"/>
               </a:spcAft>
-              <a:defRPr sz="1150" b="1">
+              <a:defRPr sz="1100" b="1">
                 <a:solidFill>
                   <a:srgbClr val="0000DC"/>
                 </a:solidFill>
               </a:defRPr>
             </a:pPr>
             <a:r>
-              <a:t>x_0 = [ x_cls; x_p^1 E; ...; x_p^N E ] + E_pos</a:t>
+              <a:t>B(x,y) = 1  if  I_gray(x,y) &lt; mu_G(x,y) - C  else  0</a:t>
             </a:r>
             <a:br/>
             <a:r>
-              <a:t>E in R^(588 x 768),   E_pos in R^((N+1) x 768)</a:t>
+              <a:t>mu_G(x,y) = (I_gray * G_sigma)(x,y)</a:t>
             </a:r>
           </a:p>
         </p:txBody>
@@ -8596,7 +8873,7 @@
               </a:defRPr>
             </a:pPr>
             <a:r>
-              <a:t>  Multi-Head Self-Attention (MHSA)</a:t>
+              <a:t>  Morphological Opening Noise Suppression</a:t>
             </a:r>
           </a:p>
         </p:txBody>
@@ -8634,7 +8911,7 @@
               </a:defRPr>
             </a:pPr>
             <a:r>
-              <a:t>• Scaled dot-product pairwise affinity between patches:</a:t>
+              <a:t>• Isolates true foreground ink from biological fiber artifacts.</a:t>
             </a:r>
           </a:p>
           <a:p>
@@ -8649,7 +8926,7 @@
               </a:defRPr>
             </a:pPr>
             <a:r>
-              <a:t>• h = 12 attention heads tracking strokes, margins, and damage:</a:t>
+              <a:t>• Elliptical structuring element E_(3x3) eliminates single-pixel noise:</a:t>
             </a:r>
           </a:p>
           <a:p>
@@ -8664,7 +8941,7 @@
               </a:defRPr>
             </a:pPr>
             <a:r>
-              <a:t>• Cosine similarity affinity metric:</a:t>
+              <a:t>• Morphological opening formulation:</a:t>
             </a:r>
           </a:p>
           <a:p>
@@ -8673,22 +8950,18 @@
               <a:spcAft>
                 <a:spcPts val="400"/>
               </a:spcAft>
-              <a:defRPr sz="1150" b="1">
+              <a:defRPr sz="1100" b="1">
                 <a:solidFill>
                   <a:srgbClr val="0000DC"/>
                 </a:solidFill>
               </a:defRPr>
             </a:pPr>
             <a:r>
-              <a:t>Attention(Q,K,V) = softmax( (Q·K^T) / sqrt(d_k) ) · V</a:t>
+              <a:t>B_clean = (B (erosion) E_{3x3}) (dilation) E_{3x3}</a:t>
             </a:r>
             <a:br/>
             <a:r>
-              <a:t>A_{ij} = (z_i · z_j) / (||z_i|| ||z_j||) = cos(theta_{ij})</a:t>
-            </a:r>
-            <a:br/>
-            <a:r>
-              <a:t>Isolates text manifolds without manual labels.</a:t>
+              <a:t>Preserves character strokes while removing background speckle.</a:t>
             </a:r>
           </a:p>
         </p:txBody>
@@ -8723,7 +8996,7 @@
               </a:defRPr>
             </a:pPr>
             <a:r>
-              <a:t>Slide 5 / 17</a:t>
+              <a:t>Slide 5 / 18</a:t>
             </a:r>
           </a:p>
         </p:txBody>
@@ -8811,7 +9084,7 @@
               </a:defRPr>
             </a:pPr>
             <a:r>
-              <a:t>Substrate-Adaptive Manifold Clustering</a:t>
+              <a:t>Stage 1: Foundation Vision Transformer (DINOv2)</a:t>
             </a:r>
           </a:p>
         </p:txBody>
@@ -8846,7 +9119,7 @@
               </a:defRPr>
             </a:pPr>
             <a:r>
-              <a:t>Border-Invariant Feature Partitioning for Varied Substrates</a:t>
+              <a:t>Patch Embedding, Multi-Head Self-Attention, and Zero-Shot Manifolds</a:t>
             </a:r>
           </a:p>
         </p:txBody>
@@ -8943,7 +9216,7 @@
               </a:defRPr>
             </a:pPr>
             <a:r>
-              <a:t>  1. Substrate Luminance Classification</a:t>
+              <a:t>  Patch Discretization &amp; Position Encoding</a:t>
             </a:r>
           </a:p>
         </p:txBody>
@@ -8981,7 +9254,7 @@
               </a:defRPr>
             </a:pPr>
             <a:r>
-              <a:t>• Evaluates boundary band luminance to detect substrate category:</a:t>
+              <a:t>• Model Architecture: DINOv2-ViT-B/14 (D = 768, P = 14).</a:t>
             </a:r>
           </a:p>
           <a:p>
@@ -8996,7 +9269,7 @@
               </a:defRPr>
             </a:pPr>
             <a:r>
-              <a:t>• Light Paper Criterion: L_border &gt; 200.</a:t>
+              <a:t>• Input image dimensions aligned to patch multiples (P = 14 px):</a:t>
             </a:r>
           </a:p>
           <a:p>
@@ -9011,7 +9284,7 @@
               </a:defRPr>
             </a:pPr>
             <a:r>
-              <a:t>• Dark Palm-Leaf Criterion: L_border &lt;= 200.</a:t>
+              <a:t>• Total extracted tokens: N = (H'/14) * (W'/14).</a:t>
             </a:r>
           </a:p>
           <a:p>
@@ -9020,18 +9293,18 @@
               <a:spcAft>
                 <a:spcPts val="400"/>
               </a:spcAft>
-              <a:defRPr sz="1150" b="1">
+              <a:defRPr sz="1100" b="1">
                 <a:solidFill>
                   <a:srgbClr val="0000DC"/>
                 </a:solidFill>
               </a:defRPr>
             </a:pPr>
             <a:r>
-              <a:t>L_border = (1 / |B|) Sum_{(x,y) in B} I_gray(x,y)</a:t>
+              <a:t>x_0 = [ x_cls; x_p^1 E; ...; x_p^N E ] + E_pos</a:t>
             </a:r>
             <a:br/>
             <a:r>
-              <a:t>where B is the outer 5-pixel boundary band.</a:t>
+              <a:t>E in R^(588 x 768),   E_pos in R^((N+1) x 768)</a:t>
             </a:r>
           </a:p>
         </p:txBody>
@@ -9128,7 +9401,7 @@
               </a:defRPr>
             </a:pPr>
             <a:r>
-              <a:t>  2. Adaptive Cluster Objectives</a:t>
+              <a:t>  Multi-Head Self-Attention (MHSA)</a:t>
             </a:r>
           </a:p>
         </p:txBody>
@@ -9166,7 +9439,7 @@
               </a:defRPr>
             </a:pPr>
             <a:r>
-              <a:t>• Printed Paper Mode (k=2): Standard K-Means variance minimization.</a:t>
+              <a:t>• Scaled dot-product pairwise affinity between patches:</a:t>
             </a:r>
           </a:p>
           <a:p>
@@ -9181,7 +9454,7 @@
               </a:defRPr>
             </a:pPr>
             <a:r>
-              <a:t>• Palm-Leaf Mode (k=3): Boundary-dominant cluster suppression.</a:t>
+              <a:t>• h = 12 attention heads tracking strokes, margins, and damage:</a:t>
             </a:r>
           </a:p>
           <a:p>
@@ -9196,7 +9469,7 @@
               </a:defRPr>
             </a:pPr>
             <a:r>
-              <a:t>• Label suppression formula:</a:t>
+              <a:t>• Cosine similarity affinity metric:</a:t>
             </a:r>
           </a:p>
           <a:p>
@@ -9205,22 +9478,22 @@
               <a:spcAft>
                 <a:spcPts val="400"/>
               </a:spcAft>
-              <a:defRPr sz="1150" b="1">
+              <a:defRPr sz="1100" b="1">
                 <a:solidFill>
                   <a:srgbClr val="0000DC"/>
                 </a:solidFill>
               </a:defRPr>
             </a:pPr>
             <a:r>
-              <a:t>l_bg = mode(L_boundary)</a:t>
+              <a:t>Attention(Q,K,V) = softmax( (Q·K^T) / sqrt(d_k) ) · V</a:t>
             </a:r>
             <a:br/>
             <a:r>
-              <a:t>M_text = { i | l_i != l_bg  and  I_mean(i) &lt; I_substrate }</a:t>
+              <a:t>A_{ij} = (z_i · z_j) / (||z_i|| ||z_j||) = cos(theta_{ij})</a:t>
             </a:r>
             <a:br/>
             <a:r>
-              <a:t>Eliminates dark outer margin bleed-through.</a:t>
+              <a:t>Isolates text manifolds without manual labels.</a:t>
             </a:r>
           </a:p>
         </p:txBody>
@@ -9255,7 +9528,7 @@
               </a:defRPr>
             </a:pPr>
             <a:r>
-              <a:t>Slide 6 / 17</a:t>
+              <a:t>Slide 6 / 18</a:t>
             </a:r>
           </a:p>
         </p:txBody>
@@ -9343,7 +9616,7 @@
               </a:defRPr>
             </a:pPr>
             <a:r>
-              <a:t>Orthographic Headline (Shirorekha) Ablation</a:t>
+              <a:t>Stage 1: Substrate-Adaptive Manifold Clustering</a:t>
             </a:r>
           </a:p>
         </p:txBody>
@@ -9378,7 +9651,7 @@
               </a:defRPr>
             </a:pPr>
             <a:r>
-              <a:t>Linear Grapheme Stem Isolation and Vertical Peak Detection</a:t>
+              <a:t>Border-Invariant Feature Partitioning for Varied Substrates</a:t>
             </a:r>
           </a:p>
         </p:txBody>
@@ -9475,7 +9748,7 @@
               </a:defRPr>
             </a:pPr>
             <a:r>
-              <a:t>  Horizontal Projection Peak Identification</a:t>
+              <a:t>  1. Substrate Luminance Classification</a:t>
             </a:r>
           </a:p>
         </p:txBody>
@@ -9513,7 +9786,7 @@
               </a:defRPr>
             </a:pPr>
             <a:r>
-              <a:t>• Evaluates upper 45% vertical zone of text line ROI (y in [0, 0.45 H_L]).</a:t>
+              <a:t>• Evaluates boundary band luminance to detect substrate category:</a:t>
             </a:r>
           </a:p>
           <a:p>
@@ -9528,7 +9801,7 @@
               </a:defRPr>
             </a:pPr>
             <a:r>
-              <a:t>• Headline coordinate detection formula:</a:t>
+              <a:t>• Light Paper Criterion: L_border &gt; 200.</a:t>
             </a:r>
           </a:p>
           <a:p>
@@ -9543,7 +9816,7 @@
               </a:defRPr>
             </a:pPr>
             <a:r>
-              <a:t>• Requires peak threshold exceeding 25% of line width.</a:t>
+              <a:t>• Dark Palm-Leaf Criterion: L_border &lt;= 200.</a:t>
             </a:r>
           </a:p>
           <a:p>
@@ -9552,18 +9825,18 @@
               <a:spcAft>
                 <a:spcPts val="400"/>
               </a:spcAft>
-              <a:defRPr sz="1150" b="1">
+              <a:defRPr sz="1100" b="1">
                 <a:solidFill>
                   <a:srgbClr val="0000DC"/>
                 </a:solidFill>
               </a:defRPr>
             </a:pPr>
             <a:r>
-              <a:t>P_H(y) = Sum_{x=0}^{W_L-1} B_line(y,x)</a:t>
+              <a:t>L_border = (1 / |B|) Sum_{(x,y) in B} I_gray(x,y)</a:t>
             </a:r>
             <a:br/>
             <a:r>
-              <a:t>y* = argmax_{y in [0, 0.45 H_L]} P_H(y)</a:t>
+              <a:t>where B is the outer 5-pixel boundary band.</a:t>
             </a:r>
           </a:p>
         </p:txBody>
@@ -9660,7 +9933,7 @@
               </a:defRPr>
             </a:pPr>
             <a:r>
-              <a:t>  Morphological Ablation Operator</a:t>
+              <a:t>  2. Adaptive Cluster Objectives</a:t>
             </a:r>
           </a:p>
         </p:txBody>
@@ -9698,7 +9971,7 @@
               </a:defRPr>
             </a:pPr>
             <a:r>
-              <a:t>• Zeros out headline band of dynamic thickness tau:</a:t>
+              <a:t>• Printed Paper Mode (k=2): Standard K-Means variance minimization.</a:t>
             </a:r>
           </a:p>
           <a:p>
@@ -9713,7 +9986,7 @@
               </a:defRPr>
             </a:pPr>
             <a:r>
-              <a:t>• Exposes isolated vertical character stems.</a:t>
+              <a:t>• Palm-Leaf Mode (k=3): Boundary-dominant cluster suppression.</a:t>
             </a:r>
           </a:p>
           <a:p>
@@ -9728,7 +10001,7 @@
               </a:defRPr>
             </a:pPr>
             <a:r>
-              <a:t>• Connected components now segment isolated aksharas.</a:t>
+              <a:t>• Label suppression formula:</a:t>
             </a:r>
           </a:p>
           <a:p>
@@ -9737,18 +10010,22 @@
               <a:spcAft>
                 <a:spcPts val="400"/>
               </a:spcAft>
-              <a:defRPr sz="1150" b="1">
+              <a:defRPr sz="1100" b="1">
                 <a:solidFill>
                   <a:srgbClr val="0000DC"/>
                 </a:solidFill>
               </a:defRPr>
             </a:pPr>
             <a:r>
-              <a:t>B_ablated(y,x) = 0  if |y - y*| &lt;= tau  else B_line(y,x)</a:t>
+              <a:t>l_bg = mode(L_boundary)</a:t>
             </a:r>
             <a:br/>
             <a:r>
-              <a:t>tau = max(2, floor(0.06 · H_L))</a:t>
+              <a:t>M_text = { i | l_i != l_bg  and  I_mean(i) &lt; I_substrate }</a:t>
+            </a:r>
+            <a:br/>
+            <a:r>
+              <a:t>Eliminates dark outer margin bleed-through.</a:t>
             </a:r>
           </a:p>
         </p:txBody>
@@ -9783,7 +10060,7 @@
               </a:defRPr>
             </a:pPr>
             <a:r>
-              <a:t>Slide 7 / 17</a:t>
+              <a:t>Slide 7 / 18</a:t>
             </a:r>
           </a:p>
         </p:txBody>
@@ -9871,7 +10148,7 @@
               </a:defRPr>
             </a:pPr>
             <a:r>
-              <a:t>Akshara-Level Glyph Segmentation</a:t>
+              <a:t>Stage 1: Column Parsing &amp; Illustration Discrimination</a:t>
             </a:r>
           </a:p>
         </p:txBody>
@@ -9906,7 +10183,7 @@
               </a:defRPr>
             </a:pPr>
             <a:r>
-              <a:t>1D Gaussian Smoothing and Valley Projection Profiles</a:t>
+              <a:t>Vertical Projection Gutters and Spatial Density Metrics</a:t>
             </a:r>
           </a:p>
         </p:txBody>
@@ -10003,7 +10280,7 @@
               </a:defRPr>
             </a:pPr>
             <a:r>
-              <a:t>  Vertical Projection and Gaussian Smoothing</a:t>
+              <a:t>  1. Inter-Column Gutter Detection</a:t>
             </a:r>
           </a:p>
         </p:txBody>
@@ -10041,7 +10318,7 @@
               </a:defRPr>
             </a:pPr>
             <a:r>
-              <a:t>• Computes column ink sum P_V(x) on ablated text line ROI.</a:t>
+              <a:t>• Vertical projection V(x) across bounding region R.</a:t>
             </a:r>
           </a:p>
           <a:p>
@@ -10056,7 +10333,7 @@
               </a:defRPr>
             </a:pPr>
             <a:r>
-              <a:t>• Applies 1D Gaussian convolution to remove intra-character noise:</a:t>
+              <a:t>• Gutter condition over continuous gap length:</a:t>
             </a:r>
           </a:p>
           <a:p>
@@ -10071,7 +10348,7 @@
               </a:defRPr>
             </a:pPr>
             <a:r>
-              <a:t>• Gaussian smoothing formulation:</a:t>
+              <a:t>• Partitions multi-column commentaries (Shloka vs Tika).</a:t>
             </a:r>
           </a:p>
           <a:p>
@@ -10080,18 +10357,18 @@
               <a:spcAft>
                 <a:spcPts val="400"/>
               </a:spcAft>
-              <a:defRPr sz="1150" b="1">
+              <a:defRPr sz="1100" b="1">
                 <a:solidFill>
                   <a:srgbClr val="0000DC"/>
                 </a:solidFill>
               </a:defRPr>
             </a:pPr>
             <a:r>
-              <a:t>S_V(x) = (P_V * G_sigma)(x)</a:t>
+              <a:t>V_norm(x) = (V * G_{sigma_c})(x) / max(V * G_{sigma_c}) &lt; 0.02</a:t>
             </a:r>
             <a:br/>
             <a:r>
-              <a:t>G_sigma(k) = (1 / sqrt(2·pi)·sigma) · exp(-k^2 / (2·sigma^2))</a:t>
+              <a:t>for gap length Delta x &gt; W_R / 15.</a:t>
             </a:r>
           </a:p>
         </p:txBody>
@@ -10188,7 +10465,7 @@
               </a:defRPr>
             </a:pPr>
             <a:r>
-              <a:t>  Valley Minima Cut-Point Detection</a:t>
+              <a:t>  2. GraphicRegion Illustration Filter</a:t>
             </a:r>
           </a:p>
         </p:txBody>
@@ -10226,7 +10503,7 @@
               </a:defRPr>
             </a:pPr>
             <a:r>
-              <a:t>• Glyph boundaries x_k* correspond to smoothed local minima:</a:t>
+              <a:t>• Evaluates ink density rho_ink and valley frequency nu_valley:</a:t>
             </a:r>
           </a:p>
           <a:p>
@@ -10241,7 +10518,7 @@
               </a:defRPr>
             </a:pPr>
             <a:r>
-              <a:t>• Threshold: theta_valley = 0.25 · ((Peak_L + Peak_R) / 2).</a:t>
+              <a:t>• Prevents OCR engine from running over woodblock drawings.</a:t>
             </a:r>
           </a:p>
           <a:p>
@@ -10256,7 +10533,7 @@
               </a:defRPr>
             </a:pPr>
             <a:r>
-              <a:t>• Synchronized with Unicode Brahmic phonetic clusters.</a:t>
+              <a:t>• Discrimination rule:</a:t>
             </a:r>
           </a:p>
           <a:p>
@@ -10265,18 +10542,18 @@
               <a:spcAft>
                 <a:spcPts val="400"/>
               </a:spcAft>
-              <a:defRPr sz="1150" b="1">
+              <a:defRPr sz="1100" b="1">
                 <a:solidFill>
                   <a:srgbClr val="0000DC"/>
                 </a:solidFill>
               </a:defRPr>
             </a:pPr>
             <a:r>
-              <a:t>dS_V / dx = 0,   d^2S_V / dx^2 &gt; 0,   S_V(x_k*) &lt; theta_valley</a:t>
+              <a:t>rho_ink = (1 / HW) Sum B(y,x),   nu_valley = N_valleys / (H/100)</a:t>
             </a:r>
             <a:br/>
             <a:r>
-              <a:t>Yields precise &lt;Glyph&gt; bounding boxes without character labels.</a:t>
+              <a:t>Classified as GraphicRegion if (rho_ink &gt; 0.30 and nu &lt; 1.5).</a:t>
             </a:r>
           </a:p>
         </p:txBody>
@@ -10311,7 +10588,7 @@
               </a:defRPr>
             </a:pPr>
             <a:r>
-              <a:t>Slide 8 / 17</a:t>
+              <a:t>Slide 8 / 18</a:t>
             </a:r>
           </a:p>
         </p:txBody>
@@ -10399,7 +10676,7 @@
               </a:defRPr>
             </a:pPr>
             <a:r>
-              <a:t>Multi-Column Layout Parsing and Graphic Discrimination</a:t>
+              <a:t>Stage 1: 6-Channel Deep Semantic Segmentation</a:t>
             </a:r>
           </a:p>
         </p:txBody>
@@ -10434,7 +10711,7 @@
               </a:defRPr>
             </a:pPr>
             <a:r>
-              <a:t>Vertical Projection Gutters and Spatial Density Metrics</a:t>
+              <a:t>Instance Normalization and Multi-Scale Focal-Dice Supervision</a:t>
             </a:r>
           </a:p>
         </p:txBody>
@@ -10531,7 +10808,7 @@
               </a:defRPr>
             </a:pPr>
             <a:r>
-              <a:t>  1. Inter-Column Gutter Detection</a:t>
+              <a:t>  Feature Propagation &amp; InstanceNorm</a:t>
             </a:r>
           </a:p>
         </p:txBody>
@@ -10569,7 +10846,7 @@
               </a:defRPr>
             </a:pPr>
             <a:r>
-              <a:t>• Vertical projection V(x) across bounding region R.</a:t>
+              <a:t>• 5-level U-Net topology with strided convolutions (stride=2).</a:t>
             </a:r>
           </a:p>
           <a:p>
@@ -10584,7 +10861,7 @@
               </a:defRPr>
             </a:pPr>
             <a:r>
-              <a:t>• Gutter condition over continuous gap length:</a:t>
+              <a:t>• Instance Normalization prevents batch-size scaling artifacts:</a:t>
             </a:r>
           </a:p>
           <a:p>
@@ -10599,7 +10876,22 @@
               </a:defRPr>
             </a:pPr>
             <a:r>
-              <a:t>• Partitions multi-column commentaries (Shloka vs Tika).</a:t>
+              <a:t>• 6 Semantic Target Channels:</a:t>
+            </a:r>
+          </a:p>
+          <a:p>
+            <a:pPr>
+              <a:spcAft>
+                <a:spcPts val="400"/>
+              </a:spcAft>
+              <a:defRPr sz="1150">
+                <a:solidFill>
+                  <a:srgbClr val="1E293B"/>
+                </a:solidFill>
+              </a:defRPr>
+            </a:pPr>
+            <a:r>
+              <a:t>•   TextRegion, Marginalia, GraphicRegion, PageFrame, Damage, TextLine.</a:t>
             </a:r>
           </a:p>
           <a:p>
@@ -10608,18 +10900,18 @@
               <a:spcAft>
                 <a:spcPts val="400"/>
               </a:spcAft>
-              <a:defRPr sz="1150" b="1">
+              <a:defRPr sz="1100" b="1">
                 <a:solidFill>
                   <a:srgbClr val="0000DC"/>
                 </a:solidFill>
               </a:defRPr>
             </a:pPr>
             <a:r>
-              <a:t>V_norm(x) = (V * G_{sigma_c})(x) / max(V * G_{sigma_c}) &lt; 0.02</a:t>
+              <a:t>x^(l) = LeakyReLU( IN( W_2 * LeakyReLU( IN( W_1 * x^(l-1) ) ) ) )</a:t>
             </a:r>
             <a:br/>
             <a:r>
-              <a:t>for gap length Delta x &gt; W_R / 15.</a:t>
+              <a:t>IN(x) = gamma · ((x - mu(x)) / sqrt(sigma^2(x) + eps)) + beta</a:t>
             </a:r>
           </a:p>
         </p:txBody>
@@ -10716,7 +11008,7 @@
               </a:defRPr>
             </a:pPr>
             <a:r>
-              <a:t>  2. GraphicRegion Illustration Filter</a:t>
+              <a:t>  Multi-Scale Focal-Dice Compound Loss</a:t>
             </a:r>
           </a:p>
         </p:txBody>
@@ -10754,7 +11046,7 @@
               </a:defRPr>
             </a:pPr>
             <a:r>
-              <a:t>• Evaluates ink density rho_ink and valley frequency nu_valley:</a:t>
+              <a:t>• Supervised across 3 decoder scales (512, 256, 128) with weights w = [1.0, 0.5, 0.25]:</a:t>
             </a:r>
           </a:p>
           <a:p>
@@ -10769,7 +11061,7 @@
               </a:defRPr>
             </a:pPr>
             <a:r>
-              <a:t>• Prevents OCR engine from running over woodblock drawings.</a:t>
+              <a:t>• Focal Loss downweights easy background pixels:</a:t>
             </a:r>
           </a:p>
           <a:p>
@@ -10784,7 +11076,7 @@
               </a:defRPr>
             </a:pPr>
             <a:r>
-              <a:t>• Discrimination rule:</a:t>
+              <a:t>• Dice Loss optimizes boundary IoU directly:</a:t>
             </a:r>
           </a:p>
           <a:p>
@@ -10793,18 +11085,22 @@
               <a:spcAft>
                 <a:spcPts val="400"/>
               </a:spcAft>
-              <a:defRPr sz="1150" b="1">
+              <a:defRPr sz="1100" b="1">
                 <a:solidFill>
                   <a:srgbClr val="0000DC"/>
                 </a:solidFill>
               </a:defRPr>
             </a:pPr>
             <a:r>
-              <a:t>rho_ink = (1 / HW) Sum B(y,x),   nu_valley = N_valleys / (H/100)</a:t>
+              <a:t>L_total = Sum_{s=0}^2 w_s [ lambda_1·L_Focal(s) + lambda_2·L_Dice(s) ]</a:t>
             </a:r>
             <a:br/>
             <a:r>
-              <a:t>Classified as GraphicRegion if (rho_ink &gt; 0.30 and nu &lt; 1.5).</a:t>
+              <a:t>L_Focal = -(1/N) Sum alpha_t (1-p_t)^gamma log(p_t)</a:t>
+            </a:r>
+            <a:br/>
+            <a:r>
+              <a:t>L_Dice = 1 - (2·Sum p_t·y_t + eps) / (Sum p_t^2 + Sum y_t^2 + eps)</a:t>
             </a:r>
           </a:p>
         </p:txBody>
@@ -10839,7 +11135,7 @@
               </a:defRPr>
             </a:pPr>
             <a:r>
-              <a:t>Slide 9 / 17</a:t>
+              <a:t>Slide 9 / 18</a:t>
             </a:r>
           </a:p>
         </p:txBody>

</xml_diff>

<commit_message>
docs: add Shirorekha challenge visual diagram, expand nnUNet equations, and enforce unbroken mathematical continuity
</commit_message>
<xml_diff>
--- a/docs/Archival_Manuscript_Layout_Analysis_Presentation.pptx
+++ b/docs/Archival_Manuscript_Layout_Analysis_Presentation.pptx
@@ -3490,7 +3490,7 @@
               </a:defRPr>
             </a:pPr>
             <a:r>
-              <a:t>  CRNN Recurrent Feature Slicing</a:t>
+              <a:t>  CRNN Recurrent Feature Slicing (L_j -&gt; h_t)</a:t>
             </a:r>
           </a:p>
         </p:txBody>
@@ -3519,9 +3519,9 @@
           <a:p>
             <a:pPr>
               <a:spcAft>
-                <a:spcPts val="400"/>
+                <a:spcPts val="300"/>
               </a:spcAft>
-              <a:defRPr sz="1150">
+              <a:defRPr sz="1100">
                 <a:solidFill>
                   <a:srgbClr val="1E293B"/>
                 </a:solidFill>
@@ -3534,9 +3534,9 @@
           <a:p>
             <a:pPr>
               <a:spcAft>
-                <a:spcPts val="400"/>
+                <a:spcPts val="300"/>
               </a:spcAft>
-              <a:defRPr sz="1150">
+              <a:defRPr sz="1100">
                 <a:solidFill>
                   <a:srgbClr val="1E293B"/>
                 </a:solidFill>
@@ -3549,9 +3549,9 @@
           <a:p>
             <a:pPr>
               <a:spcAft>
-                <a:spcPts val="400"/>
+                <a:spcPts val="300"/>
               </a:spcAft>
-              <a:defRPr sz="1150">
+              <a:defRPr sz="1100">
                 <a:solidFill>
                   <a:srgbClr val="1E293B"/>
                 </a:solidFill>
@@ -3565,9 +3565,9 @@
             <a:br/>
             <a:pPr>
               <a:spcAft>
-                <a:spcPts val="400"/>
+                <a:spcPts val="300"/>
               </a:spcAft>
-              <a:defRPr sz="1100" b="1">
+              <a:defRPr sz="1050" b="1">
                 <a:solidFill>
                   <a:srgbClr val="0000DC"/>
                 </a:solidFill>
@@ -3675,7 +3675,7 @@
               </a:defRPr>
             </a:pPr>
             <a:r>
-              <a:t>  Connectionist Temporal Classification (CTC)</a:t>
+              <a:t>  Connectionist Temporal Classification (h_t -&gt; Y_hat)</a:t>
             </a:r>
           </a:p>
         </p:txBody>
@@ -3704,9 +3704,9 @@
           <a:p>
             <a:pPr>
               <a:spcAft>
-                <a:spcPts val="400"/>
+                <a:spcPts val="300"/>
               </a:spcAft>
-              <a:defRPr sz="1150">
+              <a:defRPr sz="1100">
                 <a:solidFill>
                   <a:srgbClr val="1E293B"/>
                 </a:solidFill>
@@ -3719,9 +3719,9 @@
           <a:p>
             <a:pPr>
               <a:spcAft>
-                <a:spcPts val="400"/>
+                <a:spcPts val="300"/>
               </a:spcAft>
-              <a:defRPr sz="1150">
+              <a:defRPr sz="1100">
                 <a:solidFill>
                   <a:srgbClr val="1E293B"/>
                 </a:solidFill>
@@ -3734,9 +3734,9 @@
           <a:p>
             <a:pPr>
               <a:spcAft>
-                <a:spcPts val="400"/>
+                <a:spcPts val="300"/>
               </a:spcAft>
-              <a:defRPr sz="1150">
+              <a:defRPr sz="1100">
                 <a:solidFill>
                   <a:srgbClr val="1E293B"/>
                 </a:solidFill>
@@ -3750,9 +3750,9 @@
             <a:br/>
             <a:pPr>
               <a:spcAft>
-                <a:spcPts val="400"/>
+                <a:spcPts val="300"/>
               </a:spcAft>
-              <a:defRPr sz="1100" b="1">
+              <a:defRPr sz="1050" b="1">
                 <a:solidFill>
                   <a:srgbClr val="0000DC"/>
                 </a:solidFill>
@@ -4022,7 +4022,7 @@
               </a:defRPr>
             </a:pPr>
             <a:r>
-              <a:t>  Shirorekha Headline Slicing</a:t>
+              <a:t>  Shirorekha Headline Slicing (B_line -&gt; B_ablated)</a:t>
             </a:r>
           </a:p>
         </p:txBody>
@@ -4051,9 +4051,9 @@
           <a:p>
             <a:pPr>
               <a:spcAft>
-                <a:spcPts val="400"/>
+                <a:spcPts val="300"/>
               </a:spcAft>
-              <a:defRPr sz="1150">
+              <a:defRPr sz="1100">
                 <a:solidFill>
                   <a:srgbClr val="1E293B"/>
                 </a:solidFill>
@@ -4066,9 +4066,9 @@
           <a:p>
             <a:pPr>
               <a:spcAft>
-                <a:spcPts val="400"/>
+                <a:spcPts val="300"/>
               </a:spcAft>
-              <a:defRPr sz="1150">
+              <a:defRPr sz="1100">
                 <a:solidFill>
                   <a:srgbClr val="1E293B"/>
                 </a:solidFill>
@@ -4081,9 +4081,9 @@
           <a:p>
             <a:pPr>
               <a:spcAft>
-                <a:spcPts val="400"/>
+                <a:spcPts val="300"/>
               </a:spcAft>
-              <a:defRPr sz="1150">
+              <a:defRPr sz="1100">
                 <a:solidFill>
                   <a:srgbClr val="1E293B"/>
                 </a:solidFill>
@@ -4097,9 +4097,9 @@
             <a:br/>
             <a:pPr>
               <a:spcAft>
-                <a:spcPts val="400"/>
+                <a:spcPts val="300"/>
               </a:spcAft>
-              <a:defRPr sz="1100" b="1">
+              <a:defRPr sz="1050" b="1">
                 <a:solidFill>
                   <a:srgbClr val="0000DC"/>
                 </a:solidFill>
@@ -4207,7 +4207,7 @@
               </a:defRPr>
             </a:pPr>
             <a:r>
-              <a:t>  1D Gaussian Valley Cut-Point Tracking</a:t>
+              <a:t>  1D Gaussian Valley Cut-Point Tracking (B_ablated -&gt; {G_k})</a:t>
             </a:r>
           </a:p>
         </p:txBody>
@@ -4236,9 +4236,9 @@
           <a:p>
             <a:pPr>
               <a:spcAft>
-                <a:spcPts val="400"/>
+                <a:spcPts val="300"/>
               </a:spcAft>
-              <a:defRPr sz="1150">
+              <a:defRPr sz="1100">
                 <a:solidFill>
                   <a:srgbClr val="1E293B"/>
                 </a:solidFill>
@@ -4251,9 +4251,9 @@
           <a:p>
             <a:pPr>
               <a:spcAft>
-                <a:spcPts val="400"/>
+                <a:spcPts val="300"/>
               </a:spcAft>
-              <a:defRPr sz="1150">
+              <a:defRPr sz="1100">
                 <a:solidFill>
                   <a:srgbClr val="1E293B"/>
                 </a:solidFill>
@@ -4266,9 +4266,9 @@
           <a:p>
             <a:pPr>
               <a:spcAft>
-                <a:spcPts val="400"/>
+                <a:spcPts val="300"/>
               </a:spcAft>
-              <a:defRPr sz="1150">
+              <a:defRPr sz="1100">
                 <a:solidFill>
                   <a:srgbClr val="1E293B"/>
                 </a:solidFill>
@@ -4282,9 +4282,9 @@
             <a:br/>
             <a:pPr>
               <a:spcAft>
-                <a:spcPts val="400"/>
+                <a:spcPts val="300"/>
               </a:spcAft>
-              <a:defRPr sz="1100" b="1">
+              <a:defRPr sz="1050" b="1">
                 <a:solidFill>
                   <a:srgbClr val="0000DC"/>
                 </a:solidFill>
@@ -4422,7 +4422,7 @@
               </a:defRPr>
             </a:pPr>
             <a:r>
-              <a:t>Topological Discrimination of Physical Damage</a:t>
+              <a:t>Stage 3: Physical Damage &amp; Binder Hole Discrimination</a:t>
             </a:r>
           </a:p>
         </p:txBody>
@@ -4583,9 +4583,9 @@
           <a:p>
             <a:pPr>
               <a:spcAft>
-                <a:spcPts val="400"/>
+                <a:spcPts val="300"/>
               </a:spcAft>
-              <a:defRPr sz="1150">
+              <a:defRPr sz="1100">
                 <a:solidFill>
                   <a:srgbClr val="1E293B"/>
                 </a:solidFill>
@@ -4598,9 +4598,9 @@
           <a:p>
             <a:pPr>
               <a:spcAft>
-                <a:spcPts val="400"/>
+                <a:spcPts val="300"/>
               </a:spcAft>
-              <a:defRPr sz="1150">
+              <a:defRPr sz="1100">
                 <a:solidFill>
                   <a:srgbClr val="1E293B"/>
                 </a:solidFill>
@@ -4613,9 +4613,9 @@
           <a:p>
             <a:pPr>
               <a:spcAft>
-                <a:spcPts val="400"/>
+                <a:spcPts val="300"/>
               </a:spcAft>
-              <a:defRPr sz="1150">
+              <a:defRPr sz="1100">
                 <a:solidFill>
                   <a:srgbClr val="1E293B"/>
                 </a:solidFill>
@@ -4629,9 +4629,9 @@
             <a:br/>
             <a:pPr>
               <a:spcAft>
-                <a:spcPts val="400"/>
+                <a:spcPts val="300"/>
               </a:spcAft>
-              <a:defRPr sz="1100" b="1">
+              <a:defRPr sz="1050" b="1">
                 <a:solidFill>
                   <a:srgbClr val="0000DC"/>
                 </a:solidFill>
@@ -4739,7 +4739,7 @@
               </a:defRPr>
             </a:pPr>
             <a:r>
-              <a:t>  Geometric Damage Isolation Rule</a:t>
+              <a:t>  Geometric Damage Isolation Rule (C -&gt; R_damage)</a:t>
             </a:r>
           </a:p>
         </p:txBody>
@@ -4768,9 +4768,9 @@
           <a:p>
             <a:pPr>
               <a:spcAft>
-                <a:spcPts val="400"/>
+                <a:spcPts val="300"/>
               </a:spcAft>
-              <a:defRPr sz="1150">
+              <a:defRPr sz="1100">
                 <a:solidFill>
                   <a:srgbClr val="1E293B"/>
                 </a:solidFill>
@@ -4783,9 +4783,9 @@
           <a:p>
             <a:pPr>
               <a:spcAft>
-                <a:spcPts val="400"/>
+                <a:spcPts val="300"/>
               </a:spcAft>
-              <a:defRPr sz="1150">
+              <a:defRPr sz="1100">
                 <a:solidFill>
                   <a:srgbClr val="1E293B"/>
                 </a:solidFill>
@@ -4798,9 +4798,9 @@
           <a:p>
             <a:pPr>
               <a:spcAft>
-                <a:spcPts val="400"/>
+                <a:spcPts val="300"/>
               </a:spcAft>
-              <a:defRPr sz="1150">
+              <a:defRPr sz="1100">
                 <a:solidFill>
                   <a:srgbClr val="1E293B"/>
                 </a:solidFill>
@@ -4814,9 +4814,9 @@
             <a:br/>
             <a:pPr>
               <a:spcAft>
-                <a:spcPts val="400"/>
+                <a:spcPts val="300"/>
               </a:spcAft>
-              <a:defRPr sz="1100" b="1">
+              <a:defRPr sz="1050" b="1">
                 <a:solidFill>
                   <a:srgbClr val="0000DC"/>
                 </a:solidFill>
@@ -4915,7 +4915,7 @@
               </a:defRPr>
             </a:pPr>
             <a:r>
-              <a:t>SECTION 3: VISUAL RESULTS</a:t>
+              <a:t>SECTION 2: METHODOLOGY</a:t>
             </a:r>
           </a:p>
         </p:txBody>
@@ -4950,7 +4950,7 @@
               </a:defRPr>
             </a:pPr>
             <a:r>
-              <a:t>Visual Document Layout Parsing: Degraded Lithographic Folio</a:t>
+              <a:t>Stage 3: Polygon Simplification &amp; Quality Arbitration</a:t>
             </a:r>
           </a:p>
         </p:txBody>
@@ -4985,62 +4985,380 @@
               </a:defRPr>
             </a:pPr>
             <a:r>
-              <a:t>Side-by-Side Verification of Segmented Bounding Polygons</a:t>
-            </a:r>
-          </a:p>
-        </p:txBody>
-      </p:sp>
-      <p:pic>
-        <p:nvPicPr>
-          <p:cNvPr id="5" name="Picture 4" descr="input_folio.jpg"/>
-          <p:cNvPicPr>
-            <a:picLocks noChangeAspect="1"/>
-          </p:cNvPicPr>
-          <p:nvPr/>
-        </p:nvPicPr>
-        <p:blipFill>
-          <a:blip r:embed="rId2"/>
-          <a:stretch>
-            <a:fillRect/>
-          </a:stretch>
-        </p:blipFill>
-        <p:spPr>
-          <a:xfrm>
-            <a:off x="731520" y="1645920"/>
-            <a:ext cx="5120640" cy="4389120"/>
+              <a:t>Douglas-Peucker Vector Reduction and Devanagari Scoring</a:t>
+            </a:r>
+          </a:p>
+        </p:txBody>
+      </p:sp>
+      <p:sp>
+        <p:nvSpPr>
+          <p:cNvPr id="5" name="Rounded Rectangle 4"/>
+          <p:cNvSpPr/>
+          <p:nvPr/>
+        </p:nvSpPr>
+        <p:spPr>
+          <a:xfrm>
+            <a:off x="731520" y="1554480"/>
+            <a:ext cx="5212080" cy="4663440"/>
+          </a:xfrm>
+          <a:prstGeom prst="roundRect">
+            <a:avLst/>
+          </a:prstGeom>
+          <a:solidFill>
+            <a:srgbClr val="F5F7FA"/>
+          </a:solidFill>
+          <a:ln w="15240">
+            <a:solidFill>
+              <a:srgbClr val="CBD5E1"/>
+            </a:solidFill>
+          </a:ln>
+        </p:spPr>
+        <p:style>
+          <a:lnRef idx="1">
+            <a:schemeClr val="accent1"/>
+          </a:lnRef>
+          <a:fillRef idx="3">
+            <a:schemeClr val="accent1"/>
+          </a:fillRef>
+          <a:effectRef idx="2">
+            <a:schemeClr val="accent1"/>
+          </a:effectRef>
+          <a:fontRef idx="minor">
+            <a:schemeClr val="lt1"/>
+          </a:fontRef>
+        </p:style>
+        <p:txBody>
+          <a:bodyPr rtlCol="0" anchor="ctr"/>
+          <a:lstStyle/>
+          <a:p>
+            <a:pPr algn="ctr"/>
+          </a:p>
+        </p:txBody>
+      </p:sp>
+      <p:sp>
+        <p:nvSpPr>
+          <p:cNvPr id="6" name="Rounded Rectangle 5"/>
+          <p:cNvSpPr/>
+          <p:nvPr/>
+        </p:nvSpPr>
+        <p:spPr>
+          <a:xfrm>
+            <a:off x="731520" y="1554480"/>
+            <a:ext cx="5212080" cy="438912"/>
+          </a:xfrm>
+          <a:prstGeom prst="roundRect">
+            <a:avLst/>
+          </a:prstGeom>
+          <a:solidFill>
+            <a:srgbClr val="0000DC"/>
+          </a:solidFill>
+          <a:ln>
+            <a:noFill/>
+          </a:ln>
+        </p:spPr>
+        <p:style>
+          <a:lnRef idx="1">
+            <a:schemeClr val="accent1"/>
+          </a:lnRef>
+          <a:fillRef idx="3">
+            <a:schemeClr val="accent1"/>
+          </a:fillRef>
+          <a:effectRef idx="2">
+            <a:schemeClr val="accent1"/>
+          </a:effectRef>
+          <a:fontRef idx="minor">
+            <a:schemeClr val="lt1"/>
+          </a:fontRef>
+        </p:style>
+        <p:txBody>
+          <a:bodyPr rtlCol="0" anchor="ctr"/>
+          <a:lstStyle/>
+          <a:p>
+            <a:pPr algn="ctr">
+              <a:defRPr sz="1300" b="1">
+                <a:solidFill>
+                  <a:srgbClr val="FFFFFF"/>
+                </a:solidFill>
+              </a:defRPr>
+            </a:pPr>
+            <a:r>
+              <a:t>  Devanagari Quality Objective (T -&gt; S_Dev)</a:t>
+            </a:r>
+          </a:p>
+        </p:txBody>
+      </p:sp>
+      <p:sp>
+        <p:nvSpPr>
+          <p:cNvPr id="7" name="TextBox 6"/>
+          <p:cNvSpPr txBox="1"/>
+          <p:nvPr/>
+        </p:nvSpPr>
+        <p:spPr>
+          <a:xfrm>
+            <a:off x="914400" y="2057400"/>
+            <a:ext cx="4846320" cy="4069080"/>
           </a:xfrm>
           <a:prstGeom prst="rect">
             <a:avLst/>
           </a:prstGeom>
-        </p:spPr>
-      </p:pic>
-      <p:pic>
-        <p:nvPicPr>
-          <p:cNvPr id="6" name="Picture 5" descr="output_annotation.jpg"/>
-          <p:cNvPicPr>
-            <a:picLocks noChangeAspect="1"/>
-          </p:cNvPicPr>
-          <p:nvPr/>
-        </p:nvPicPr>
-        <p:blipFill>
-          <a:blip r:embed="rId3"/>
-          <a:stretch>
-            <a:fillRect/>
-          </a:stretch>
-        </p:blipFill>
-        <p:spPr>
-          <a:xfrm>
-            <a:off x="6217920" y="1645920"/>
-            <a:ext cx="5120640" cy="4389120"/>
+          <a:noFill/>
+        </p:spPr>
+        <p:txBody>
+          <a:bodyPr wrap="square">
+            <a:spAutoFit/>
+          </a:bodyPr>
+          <a:lstStyle/>
+          <a:p>
+            <a:pPr>
+              <a:spcAft>
+                <a:spcPts val="300"/>
+              </a:spcAft>
+              <a:defRPr sz="1100">
+                <a:solidFill>
+                  <a:srgbClr val="1E293B"/>
+                </a:solidFill>
+              </a:defRPr>
+            </a:pPr>
+            <a:r>
+              <a:t>• Evaluates candidate transcriptions autonomously:</a:t>
+            </a:r>
+          </a:p>
+          <a:p>
+            <a:pPr>
+              <a:spcAft>
+                <a:spcPts val="300"/>
+              </a:spcAft>
+              <a:defRPr sz="1100">
+                <a:solidFill>
+                  <a:srgbClr val="1E293B"/>
+                </a:solidFill>
+              </a:defRPr>
+            </a:pPr>
+            <a:r>
+              <a:t>• Rewards Devanagari Unicode blocks [0x0900, 0x097F] (+5 pt):</a:t>
+            </a:r>
+          </a:p>
+          <a:p>
+            <a:pPr>
+              <a:spcAft>
+                <a:spcPts val="300"/>
+              </a:spcAft>
+              <a:defRPr sz="1100">
+                <a:solidFill>
+                  <a:srgbClr val="1E293B"/>
+                </a:solidFill>
+              </a:defRPr>
+            </a:pPr>
+            <a:r>
+              <a:t>• Penalizes Latin hallucination noise (-12 pt).</a:t>
+            </a:r>
+          </a:p>
+          <a:p>
+            <a:br/>
+            <a:pPr>
+              <a:spcAft>
+                <a:spcPts val="300"/>
+              </a:spcAft>
+              <a:defRPr sz="1050" b="1">
+                <a:solidFill>
+                  <a:srgbClr val="0000DC"/>
+                </a:solidFill>
+              </a:defRPr>
+            </a:pPr>
+            <a:r>
+              <a:t>S_Dev(T) = Sum omega(c) - 8·Sum count(n,T) + 2·min(|words|, 12)</a:t>
+            </a:r>
+          </a:p>
+        </p:txBody>
+      </p:sp>
+      <p:sp>
+        <p:nvSpPr>
+          <p:cNvPr id="8" name="Rounded Rectangle 7"/>
+          <p:cNvSpPr/>
+          <p:nvPr/>
+        </p:nvSpPr>
+        <p:spPr>
+          <a:xfrm>
+            <a:off x="6217920" y="1554480"/>
+            <a:ext cx="5212080" cy="4663440"/>
+          </a:xfrm>
+          <a:prstGeom prst="roundRect">
+            <a:avLst/>
+          </a:prstGeom>
+          <a:solidFill>
+            <a:srgbClr val="F5F7FA"/>
+          </a:solidFill>
+          <a:ln w="15240">
+            <a:solidFill>
+              <a:srgbClr val="CBD5E1"/>
+            </a:solidFill>
+          </a:ln>
+        </p:spPr>
+        <p:style>
+          <a:lnRef idx="1">
+            <a:schemeClr val="accent1"/>
+          </a:lnRef>
+          <a:fillRef idx="3">
+            <a:schemeClr val="accent1"/>
+          </a:fillRef>
+          <a:effectRef idx="2">
+            <a:schemeClr val="accent1"/>
+          </a:effectRef>
+          <a:fontRef idx="minor">
+            <a:schemeClr val="lt1"/>
+          </a:fontRef>
+        </p:style>
+        <p:txBody>
+          <a:bodyPr rtlCol="0" anchor="ctr"/>
+          <a:lstStyle/>
+          <a:p>
+            <a:pPr algn="ctr"/>
+          </a:p>
+        </p:txBody>
+      </p:sp>
+      <p:sp>
+        <p:nvSpPr>
+          <p:cNvPr id="9" name="Rounded Rectangle 8"/>
+          <p:cNvSpPr/>
+          <p:nvPr/>
+        </p:nvSpPr>
+        <p:spPr>
+          <a:xfrm>
+            <a:off x="6217920" y="1554480"/>
+            <a:ext cx="5212080" cy="438912"/>
+          </a:xfrm>
+          <a:prstGeom prst="roundRect">
+            <a:avLst/>
+          </a:prstGeom>
+          <a:solidFill>
+            <a:srgbClr val="0000DC"/>
+          </a:solidFill>
+          <a:ln>
+            <a:noFill/>
+          </a:ln>
+        </p:spPr>
+        <p:style>
+          <a:lnRef idx="1">
+            <a:schemeClr val="accent1"/>
+          </a:lnRef>
+          <a:fillRef idx="3">
+            <a:schemeClr val="accent1"/>
+          </a:fillRef>
+          <a:effectRef idx="2">
+            <a:schemeClr val="accent1"/>
+          </a:effectRef>
+          <a:fontRef idx="minor">
+            <a:schemeClr val="lt1"/>
+          </a:fontRef>
+        </p:style>
+        <p:txBody>
+          <a:bodyPr rtlCol="0" anchor="ctr"/>
+          <a:lstStyle/>
+          <a:p>
+            <a:pPr algn="ctr">
+              <a:defRPr sz="1300" b="1">
+                <a:solidFill>
+                  <a:srgbClr val="FFFFFF"/>
+                </a:solidFill>
+              </a:defRPr>
+            </a:pPr>
+            <a:r>
+              <a:t>  Ramer-Douglas-Peucker (RDP) Simplification (P -&gt; P_simp)</a:t>
+            </a:r>
+          </a:p>
+        </p:txBody>
+      </p:sp>
+      <p:sp>
+        <p:nvSpPr>
+          <p:cNvPr id="10" name="TextBox 9"/>
+          <p:cNvSpPr txBox="1"/>
+          <p:nvPr/>
+        </p:nvSpPr>
+        <p:spPr>
+          <a:xfrm>
+            <a:off x="6400800" y="2057400"/>
+            <a:ext cx="4846320" cy="4069080"/>
           </a:xfrm>
           <a:prstGeom prst="rect">
             <a:avLst/>
           </a:prstGeom>
-        </p:spPr>
-      </p:pic>
-      <p:sp>
-        <p:nvSpPr>
-          <p:cNvPr id="7" name="TextBox 6"/>
+          <a:noFill/>
+        </p:spPr>
+        <p:txBody>
+          <a:bodyPr wrap="square">
+            <a:spAutoFit/>
+          </a:bodyPr>
+          <a:lstStyle/>
+          <a:p>
+            <a:pPr>
+              <a:spcAft>
+                <a:spcPts val="300"/>
+              </a:spcAft>
+              <a:defRPr sz="1100">
+                <a:solidFill>
+                  <a:srgbClr val="1E293B"/>
+                </a:solidFill>
+              </a:defRPr>
+            </a:pPr>
+            <a:r>
+              <a:t>• Perpendicular distance threshold eps = 0.005·ArcLength(P):</a:t>
+            </a:r>
+          </a:p>
+          <a:p>
+            <a:pPr>
+              <a:spcAft>
+                <a:spcPts val="300"/>
+              </a:spcAft>
+              <a:defRPr sz="1100">
+                <a:solidFill>
+                  <a:srgbClr val="1E293B"/>
+                </a:solidFill>
+              </a:defRPr>
+            </a:pPr>
+            <a:r>
+              <a:t>• Reduces polygon vertex count by 82.6%:</a:t>
+            </a:r>
+          </a:p>
+          <a:p>
+            <a:pPr>
+              <a:spcAft>
+                <a:spcPts val="300"/>
+              </a:spcAft>
+              <a:defRPr sz="1100">
+                <a:solidFill>
+                  <a:srgbClr val="1E293B"/>
+                </a:solidFill>
+              </a:defRPr>
+            </a:pPr>
+            <a:r>
+              <a:t>• Maintains polygon boundary IoU &gt; 0.98.</a:t>
+            </a:r>
+          </a:p>
+          <a:p>
+            <a:br/>
+            <a:pPr>
+              <a:spcAft>
+                <a:spcPts val="300"/>
+              </a:spcAft>
+              <a:defRPr sz="1050" b="1">
+                <a:solidFill>
+                  <a:srgbClr val="0000DC"/>
+                </a:solidFill>
+              </a:defRPr>
+            </a:pPr>
+            <a:r>
+              <a:t>d_perp(p_i, seg) = |(y_n-y_1)x_i - (x_n-x_1)y_i + x_n y_1 - y_n x_1| / sqrt(Delta x^2 + Delta y^2)</a:t>
+            </a:r>
+            <a:br/>
+            <a:r>
+              <a:t>Removes vertex if d_perp &lt;= eps.</a:t>
+            </a:r>
+          </a:p>
+        </p:txBody>
+      </p:sp>
+      <p:sp>
+        <p:nvSpPr>
+          <p:cNvPr id="11" name="TextBox 10"/>
           <p:cNvSpPr txBox="1"/>
           <p:nvPr/>
         </p:nvSpPr>
@@ -5156,7 +5474,7 @@
               </a:defRPr>
             </a:pPr>
             <a:r>
-              <a:t>Visual Document Layout Parsing: Palm-Leaf Manuscript</a:t>
+              <a:t>Visual Document Layout Parsing: Degraded Lithographic Folio</a:t>
             </a:r>
           </a:p>
         </p:txBody>
@@ -5191,14 +5509,14 @@
               </a:defRPr>
             </a:pPr>
             <a:r>
-              <a:t>Topological Binder Hole Isolation and Text Line Boundaries</a:t>
+              <a:t>Side-by-Side Verification of Segmented Bounding Polygons</a:t>
             </a:r>
           </a:p>
         </p:txBody>
       </p:sp>
       <p:pic>
         <p:nvPicPr>
-          <p:cNvPr id="5" name="Picture 4" descr="input_leaf.jpg"/>
+          <p:cNvPr id="5" name="Picture 4" descr="input_folio.jpg"/>
           <p:cNvPicPr>
             <a:picLocks noChangeAspect="1"/>
           </p:cNvPicPr>
@@ -5222,7 +5540,7 @@
       </p:pic>
       <p:pic>
         <p:nvPicPr>
-          <p:cNvPr id="6" name="Picture 5" descr="output_leaf.jpg"/>
+          <p:cNvPr id="6" name="Picture 5" descr="output_annotation.jpg"/>
           <p:cNvPicPr>
             <a:picLocks noChangeAspect="1"/>
           </p:cNvPicPr>
@@ -5327,7 +5645,7 @@
               </a:defRPr>
             </a:pPr>
             <a:r>
-              <a:t>SECTION 3: EXPERIMENTAL RESULTS</a:t>
+              <a:t>SECTION 3: VISUAL RESULTS</a:t>
             </a:r>
           </a:p>
         </p:txBody>
@@ -5362,7 +5680,7 @@
               </a:defRPr>
             </a:pPr>
             <a:r>
-              <a:t>Experimental Evaluation over 1,054 Degraded Folios</a:t>
+              <a:t>Visual Document Layout Parsing: Palm-Leaf Manuscript</a:t>
             </a:r>
           </a:p>
         </p:txBody>
@@ -5397,418 +5715,62 @@
               </a:defRPr>
             </a:pPr>
             <a:r>
-              <a:t>Levenshtein Edit Distance Formulations and Benchmark Comparison</a:t>
-            </a:r>
-          </a:p>
-        </p:txBody>
-      </p:sp>
-      <p:sp>
-        <p:nvSpPr>
-          <p:cNvPr id="5" name="Rounded Rectangle 4"/>
-          <p:cNvSpPr/>
-          <p:nvPr/>
-        </p:nvSpPr>
-        <p:spPr>
-          <a:xfrm>
-            <a:off x="731520" y="1554480"/>
-            <a:ext cx="5212080" cy="4663440"/>
-          </a:xfrm>
-          <a:prstGeom prst="roundRect">
-            <a:avLst/>
-          </a:prstGeom>
-          <a:solidFill>
-            <a:srgbClr val="F5F7FA"/>
-          </a:solidFill>
-          <a:ln w="15240">
-            <a:solidFill>
-              <a:srgbClr val="CBD5E1"/>
-            </a:solidFill>
-          </a:ln>
-        </p:spPr>
-        <p:style>
-          <a:lnRef idx="1">
-            <a:schemeClr val="accent1"/>
-          </a:lnRef>
-          <a:fillRef idx="3">
-            <a:schemeClr val="accent1"/>
-          </a:fillRef>
-          <a:effectRef idx="2">
-            <a:schemeClr val="accent1"/>
-          </a:effectRef>
-          <a:fontRef idx="minor">
-            <a:schemeClr val="lt1"/>
-          </a:fontRef>
-        </p:style>
-        <p:txBody>
-          <a:bodyPr rtlCol="0" anchor="ctr"/>
-          <a:lstStyle/>
-          <a:p>
-            <a:pPr algn="ctr"/>
-          </a:p>
-        </p:txBody>
-      </p:sp>
-      <p:sp>
-        <p:nvSpPr>
-          <p:cNvPr id="6" name="Rounded Rectangle 5"/>
-          <p:cNvSpPr/>
-          <p:nvPr/>
-        </p:nvSpPr>
-        <p:spPr>
-          <a:xfrm>
-            <a:off x="731520" y="1554480"/>
-            <a:ext cx="5212080" cy="438912"/>
-          </a:xfrm>
-          <a:prstGeom prst="roundRect">
-            <a:avLst/>
-          </a:prstGeom>
-          <a:solidFill>
-            <a:srgbClr val="0000DC"/>
-          </a:solidFill>
-          <a:ln>
-            <a:noFill/>
-          </a:ln>
-        </p:spPr>
-        <p:style>
-          <a:lnRef idx="1">
-            <a:schemeClr val="accent1"/>
-          </a:lnRef>
-          <a:fillRef idx="3">
-            <a:schemeClr val="accent1"/>
-          </a:fillRef>
-          <a:effectRef idx="2">
-            <a:schemeClr val="accent1"/>
-          </a:effectRef>
-          <a:fontRef idx="minor">
-            <a:schemeClr val="lt1"/>
-          </a:fontRef>
-        </p:style>
-        <p:txBody>
-          <a:bodyPr rtlCol="0" anchor="ctr"/>
-          <a:lstStyle/>
-          <a:p>
-            <a:pPr algn="ctr">
-              <a:defRPr sz="1300" b="1">
-                <a:solidFill>
-                  <a:srgbClr val="FFFFFF"/>
-                </a:solidFill>
-              </a:defRPr>
-            </a:pPr>
-            <a:r>
-              <a:t>  Metric Formulations (CER and WER)</a:t>
-            </a:r>
-          </a:p>
-        </p:txBody>
-      </p:sp>
+              <a:t>Topological Binder Hole Isolation and Text Line Boundaries</a:t>
+            </a:r>
+          </a:p>
+        </p:txBody>
+      </p:sp>
+      <p:pic>
+        <p:nvPicPr>
+          <p:cNvPr id="5" name="Picture 4" descr="input_leaf.jpg"/>
+          <p:cNvPicPr>
+            <a:picLocks noChangeAspect="1"/>
+          </p:cNvPicPr>
+          <p:nvPr/>
+        </p:nvPicPr>
+        <p:blipFill>
+          <a:blip r:embed="rId2"/>
+          <a:stretch>
+            <a:fillRect/>
+          </a:stretch>
+        </p:blipFill>
+        <p:spPr>
+          <a:xfrm>
+            <a:off x="731520" y="1645920"/>
+            <a:ext cx="5120640" cy="4389120"/>
+          </a:xfrm>
+          <a:prstGeom prst="rect">
+            <a:avLst/>
+          </a:prstGeom>
+        </p:spPr>
+      </p:pic>
+      <p:pic>
+        <p:nvPicPr>
+          <p:cNvPr id="6" name="Picture 5" descr="output_leaf.jpg"/>
+          <p:cNvPicPr>
+            <a:picLocks noChangeAspect="1"/>
+          </p:cNvPicPr>
+          <p:nvPr/>
+        </p:nvPicPr>
+        <p:blipFill>
+          <a:blip r:embed="rId3"/>
+          <a:stretch>
+            <a:fillRect/>
+          </a:stretch>
+        </p:blipFill>
+        <p:spPr>
+          <a:xfrm>
+            <a:off x="6217920" y="1645920"/>
+            <a:ext cx="5120640" cy="4389120"/>
+          </a:xfrm>
+          <a:prstGeom prst="rect">
+            <a:avLst/>
+          </a:prstGeom>
+        </p:spPr>
+      </p:pic>
       <p:sp>
         <p:nvSpPr>
           <p:cNvPr id="7" name="TextBox 6"/>
-          <p:cNvSpPr txBox="1"/>
-          <p:nvPr/>
-        </p:nvSpPr>
-        <p:spPr>
-          <a:xfrm>
-            <a:off x="914400" y="2057400"/>
-            <a:ext cx="4846320" cy="4069080"/>
-          </a:xfrm>
-          <a:prstGeom prst="rect">
-            <a:avLst/>
-          </a:prstGeom>
-          <a:noFill/>
-        </p:spPr>
-        <p:txBody>
-          <a:bodyPr wrap="square">
-            <a:spAutoFit/>
-          </a:bodyPr>
-          <a:lstStyle/>
-          <a:p>
-            <a:pPr>
-              <a:spcAft>
-                <a:spcPts val="400"/>
-              </a:spcAft>
-              <a:defRPr sz="1150">
-                <a:solidFill>
-                  <a:srgbClr val="1E293B"/>
-                </a:solidFill>
-              </a:defRPr>
-            </a:pPr>
-            <a:r>
-              <a:t>• Character Error Rate (CER) and Word Error Rate (WER):</a:t>
-            </a:r>
-          </a:p>
-          <a:p>
-            <a:pPr>
-              <a:spcAft>
-                <a:spcPts val="400"/>
-              </a:spcAft>
-              <a:defRPr sz="1150">
-                <a:solidFill>
-                  <a:srgbClr val="1E293B"/>
-                </a:solidFill>
-              </a:defRPr>
-            </a:pPr>
-            <a:r>
-              <a:t>• Computed via dynamic programming Levenshtein distance:</a:t>
-            </a:r>
-          </a:p>
-          <a:p>
-            <a:pPr>
-              <a:spcAft>
-                <a:spcPts val="400"/>
-              </a:spcAft>
-              <a:defRPr sz="1150">
-                <a:solidFill>
-                  <a:srgbClr val="1E293B"/>
-                </a:solidFill>
-              </a:defRPr>
-            </a:pPr>
-            <a:r>
-              <a:t>• Accuracy = max(0, 1.0 - CER).</a:t>
-            </a:r>
-          </a:p>
-          <a:p>
-            <a:br/>
-            <a:pPr>
-              <a:spcAft>
-                <a:spcPts val="400"/>
-              </a:spcAft>
-              <a:defRPr sz="1100" b="1">
-                <a:solidFill>
-                  <a:srgbClr val="0000DC"/>
-                </a:solidFill>
-              </a:defRPr>
-            </a:pPr>
-            <a:r>
-              <a:t>CER = (Sum D_Lev(S_pred, S_gt)) / (Sum Length(S_gt))</a:t>
-            </a:r>
-            <a:br/>
-            <a:r>
-              <a:t>WER = (Sum D_Lev(W_pred, W_gt)) / (Sum |W_gt|)</a:t>
-            </a:r>
-            <a:br/>
-            <a:r>
-              <a:t>D(i,j) = min( D(i-1,j)+1, D(i,j-1)+1, D(i-1,j-1)+I(a_i != b_j) )</a:t>
-            </a:r>
-          </a:p>
-        </p:txBody>
-      </p:sp>
-      <p:sp>
-        <p:nvSpPr>
-          <p:cNvPr id="8" name="Rounded Rectangle 7"/>
-          <p:cNvSpPr/>
-          <p:nvPr/>
-        </p:nvSpPr>
-        <p:spPr>
-          <a:xfrm>
-            <a:off x="6217920" y="1554480"/>
-            <a:ext cx="5212080" cy="4663440"/>
-          </a:xfrm>
-          <a:prstGeom prst="roundRect">
-            <a:avLst/>
-          </a:prstGeom>
-          <a:solidFill>
-            <a:srgbClr val="F5F7FA"/>
-          </a:solidFill>
-          <a:ln w="15240">
-            <a:solidFill>
-              <a:srgbClr val="CBD5E1"/>
-            </a:solidFill>
-          </a:ln>
-        </p:spPr>
-        <p:style>
-          <a:lnRef idx="1">
-            <a:schemeClr val="accent1"/>
-          </a:lnRef>
-          <a:fillRef idx="3">
-            <a:schemeClr val="accent1"/>
-          </a:fillRef>
-          <a:effectRef idx="2">
-            <a:schemeClr val="accent1"/>
-          </a:effectRef>
-          <a:fontRef idx="minor">
-            <a:schemeClr val="lt1"/>
-          </a:fontRef>
-        </p:style>
-        <p:txBody>
-          <a:bodyPr rtlCol="0" anchor="ctr"/>
-          <a:lstStyle/>
-          <a:p>
-            <a:pPr algn="ctr"/>
-          </a:p>
-        </p:txBody>
-      </p:sp>
-      <p:sp>
-        <p:nvSpPr>
-          <p:cNvPr id="9" name="Rounded Rectangle 8"/>
-          <p:cNvSpPr/>
-          <p:nvPr/>
-        </p:nvSpPr>
-        <p:spPr>
-          <a:xfrm>
-            <a:off x="6217920" y="1554480"/>
-            <a:ext cx="5212080" cy="438912"/>
-          </a:xfrm>
-          <a:prstGeom prst="roundRect">
-            <a:avLst/>
-          </a:prstGeom>
-          <a:solidFill>
-            <a:srgbClr val="0000DC"/>
-          </a:solidFill>
-          <a:ln>
-            <a:noFill/>
-          </a:ln>
-        </p:spPr>
-        <p:style>
-          <a:lnRef idx="1">
-            <a:schemeClr val="accent1"/>
-          </a:lnRef>
-          <a:fillRef idx="3">
-            <a:schemeClr val="accent1"/>
-          </a:fillRef>
-          <a:effectRef idx="2">
-            <a:schemeClr val="accent1"/>
-          </a:effectRef>
-          <a:fontRef idx="minor">
-            <a:schemeClr val="lt1"/>
-          </a:fontRef>
-        </p:style>
-        <p:txBody>
-          <a:bodyPr rtlCol="0" anchor="ctr"/>
-          <a:lstStyle/>
-          <a:p>
-            <a:pPr algn="ctr">
-              <a:defRPr sz="1300" b="1">
-                <a:solidFill>
-                  <a:srgbClr val="FFFFFF"/>
-                </a:solidFill>
-              </a:defRPr>
-            </a:pPr>
-            <a:r>
-              <a:t>  Quantitative Benchmark Results (1,054 Pages)</a:t>
-            </a:r>
-          </a:p>
-        </p:txBody>
-      </p:sp>
-      <p:sp>
-        <p:nvSpPr>
-          <p:cNvPr id="10" name="TextBox 9"/>
-          <p:cNvSpPr txBox="1"/>
-          <p:nvPr/>
-        </p:nvSpPr>
-        <p:spPr>
-          <a:xfrm>
-            <a:off x="6400800" y="2057400"/>
-            <a:ext cx="4846320" cy="4069080"/>
-          </a:xfrm>
-          <a:prstGeom prst="rect">
-            <a:avLst/>
-          </a:prstGeom>
-          <a:noFill/>
-        </p:spPr>
-        <p:txBody>
-          <a:bodyPr wrap="square">
-            <a:spAutoFit/>
-          </a:bodyPr>
-          <a:lstStyle/>
-          <a:p>
-            <a:pPr>
-              <a:spcAft>
-                <a:spcPts val="400"/>
-              </a:spcAft>
-              <a:defRPr sz="1150">
-                <a:solidFill>
-                  <a:srgbClr val="1E293B"/>
-                </a:solidFill>
-              </a:defRPr>
-            </a:pPr>
-            <a:r>
-              <a:t>• Proposed Framework: CER = 15.32%, WER = 9.97%, Accuracy = 84.50%</a:t>
-            </a:r>
-          </a:p>
-          <a:p>
-            <a:pPr>
-              <a:spcAft>
-                <a:spcPts val="400"/>
-              </a:spcAft>
-              <a:defRPr sz="1150">
-                <a:solidFill>
-                  <a:srgbClr val="1E293B"/>
-                </a:solidFill>
-              </a:defRPr>
-            </a:pPr>
-            <a:r>
-              <a:t>• Tesseract 5 Baseline: CER = 47.82%, WER = 58.30%, Accuracy = 52.18%</a:t>
-            </a:r>
-          </a:p>
-          <a:p>
-            <a:pPr>
-              <a:spcAft>
-                <a:spcPts val="400"/>
-              </a:spcAft>
-              <a:defRPr sz="1150">
-                <a:solidFill>
-                  <a:srgbClr val="1E293B"/>
-                </a:solidFill>
-              </a:defRPr>
-            </a:pPr>
-            <a:r>
-              <a:t>• Kraken HTR Baseline: CER = 38.60%, WER = 44.12%, Accuracy = 61.40%</a:t>
-            </a:r>
-          </a:p>
-          <a:p>
-            <a:pPr>
-              <a:spcAft>
-                <a:spcPts val="400"/>
-              </a:spcAft>
-              <a:defRPr sz="1150">
-                <a:solidFill>
-                  <a:srgbClr val="1E293B"/>
-                </a:solidFill>
-              </a:defRPr>
-            </a:pPr>
-            <a:r>
-              <a:t>• Supervised LayoutLMv3: CER = 26.90%, WER = 31.85%, Accuracy = 73.10%</a:t>
-            </a:r>
-          </a:p>
-          <a:p>
-            <a:pPr>
-              <a:spcAft>
-                <a:spcPts val="400"/>
-              </a:spcAft>
-              <a:defRPr sz="1150">
-                <a:solidFill>
-                  <a:srgbClr val="1E293B"/>
-                </a:solidFill>
-              </a:defRPr>
-            </a:pPr>
-            <a:r>
-              <a:t>• Demonstrates 3.12x error reduction over classical OCR.</a:t>
-            </a:r>
-          </a:p>
-          <a:p>
-            <a:br/>
-            <a:pPr>
-              <a:spcAft>
-                <a:spcPts val="400"/>
-              </a:spcAft>
-              <a:defRPr sz="1100" b="1">
-                <a:solidFill>
-                  <a:srgbClr val="0000DC"/>
-                </a:solidFill>
-              </a:defRPr>
-            </a:pPr>
-            <a:r>
-              <a:t>Overall Accuracy: 84.50%</a:t>
-            </a:r>
-            <a:br/>
-            <a:r>
-              <a:t>Zero Empty Predictions (0.00%) across all test folios.</a:t>
-            </a:r>
-          </a:p>
-        </p:txBody>
-      </p:sp>
-      <p:sp>
-        <p:nvSpPr>
-          <p:cNvPr id="11" name="TextBox 10"/>
           <p:cNvSpPr txBox="1"/>
           <p:nvPr/>
         </p:nvSpPr>
@@ -5924,7 +5886,7 @@
               </a:defRPr>
             </a:pPr>
             <a:r>
-              <a:t>Semantic Layout Segmentation and Human Effort Evaluation</a:t>
+              <a:t>Experimental Evaluation over 1,054 Degraded Folios</a:t>
             </a:r>
           </a:p>
         </p:txBody>
@@ -5959,7 +5921,7 @@
               </a:defRPr>
             </a:pPr>
             <a:r>
-              <a:t>Instance-Level F1-Scores and Paleographer Latency Reduction</a:t>
+              <a:t>Levenshtein Edit Distance Formulations and Benchmark Comparison</a:t>
             </a:r>
           </a:p>
         </p:txBody>
@@ -6056,7 +6018,7 @@
               </a:defRPr>
             </a:pPr>
             <a:r>
-              <a:t>  1. Semantic Layout F1-Scores</a:t>
+              <a:t>  Metric Formulations (CER and WER)</a:t>
             </a:r>
           </a:p>
         </p:txBody>
@@ -6085,92 +6047,70 @@
           <a:p>
             <a:pPr>
               <a:spcAft>
-                <a:spcPts val="400"/>
+                <a:spcPts val="300"/>
               </a:spcAft>
-              <a:defRPr sz="1150">
+              <a:defRPr sz="1100">
                 <a:solidFill>
                   <a:srgbClr val="1E293B"/>
                 </a:solidFill>
               </a:defRPr>
             </a:pPr>
             <a:r>
-              <a:t>• TextRegion F1: 0.951 (Precision: 0.942, Recall: 0.961)</a:t>
+              <a:t>• Character Error Rate (CER) and Word Error Rate (WER):</a:t>
             </a:r>
           </a:p>
           <a:p>
             <a:pPr>
               <a:spcAft>
-                <a:spcPts val="400"/>
+                <a:spcPts val="300"/>
               </a:spcAft>
-              <a:defRPr sz="1150">
+              <a:defRPr sz="1100">
                 <a:solidFill>
                   <a:srgbClr val="1E293B"/>
                 </a:solidFill>
               </a:defRPr>
             </a:pPr>
             <a:r>
-              <a:t>• TextLine F1: 0.926 (Precision: 0.918, Recall: 0.935)</a:t>
+              <a:t>• Computed via dynamic programming Levenshtein distance:</a:t>
             </a:r>
           </a:p>
           <a:p>
             <a:pPr>
               <a:spcAft>
-                <a:spcPts val="400"/>
+                <a:spcPts val="300"/>
               </a:spcAft>
-              <a:defRPr sz="1150">
+              <a:defRPr sz="1100">
                 <a:solidFill>
                   <a:srgbClr val="1E293B"/>
                 </a:solidFill>
               </a:defRPr>
             </a:pPr>
             <a:r>
-              <a:t>• GraphicRegion F1: 0.907 (Precision: 0.925, Recall: 0.890)</a:t>
-            </a:r>
-          </a:p>
-          <a:p>
+              <a:t>• Accuracy = max(0, 1.0 - CER).</a:t>
+            </a:r>
+          </a:p>
+          <a:p>
+            <a:br/>
             <a:pPr>
               <a:spcAft>
-                <a:spcPts val="400"/>
+                <a:spcPts val="300"/>
               </a:spcAft>
-              <a:defRPr sz="1150">
-                <a:solidFill>
-                  <a:srgbClr val="1E293B"/>
-                </a:solidFill>
-              </a:defRPr>
-            </a:pPr>
-            <a:r>
-              <a:t>• Damage / Binder Hole F1: 0.954 (Precision: 0.968, Recall: 0.941)</a:t>
-            </a:r>
-          </a:p>
-          <a:p>
-            <a:pPr>
-              <a:spcAft>
-                <a:spcPts val="400"/>
-              </a:spcAft>
-              <a:defRPr sz="1150">
-                <a:solidFill>
-                  <a:srgbClr val="1E293B"/>
-                </a:solidFill>
-              </a:defRPr>
-            </a:pPr>
-            <a:r>
-              <a:t>• PageFrame F1: 0.988 | Overall Layout Mean F1: 0.932</a:t>
-            </a:r>
-          </a:p>
-          <a:p>
+              <a:defRPr sz="1050" b="1">
+                <a:solidFill>
+                  <a:srgbClr val="0000DC"/>
+                </a:solidFill>
+              </a:defRPr>
+            </a:pPr>
+            <a:r>
+              <a:t>CER = (Sum D_Lev(S_pred, S_gt)) / (Sum Length(S_gt))</a:t>
+            </a:r>
             <a:br/>
-            <a:pPr>
-              <a:spcAft>
-                <a:spcPts val="400"/>
-              </a:spcAft>
-              <a:defRPr sz="1100" b="1">
-                <a:solidFill>
-                  <a:srgbClr val="0000DC"/>
-                </a:solidFill>
-              </a:defRPr>
-            </a:pPr>
-            <a:r>
-              <a:t>F1 = 2 · (Precision · Recall) / (Precision + Recall)</a:t>
+            <a:r>
+              <a:t>WER = (Sum D_Lev(W_pred, W_gt)) / (Sum |W_gt|)</a:t>
+            </a:r>
+            <a:br/>
+            <a:r>
+              <a:t>D(i,j) = min( D(i-1,j)+1, D(i,j-1)+1, D(i-1,j-1)+I(a_i != b_j) )</a:t>
             </a:r>
           </a:p>
         </p:txBody>
@@ -6267,7 +6207,7 @@
               </a:defRPr>
             </a:pPr>
             <a:r>
-              <a:t>  2. Human Correction Effort Model (PRImA Protocol)</a:t>
+              <a:t>  Quantitative Benchmark Results (1,054 Pages)</a:t>
             </a:r>
           </a:p>
         </p:txBody>
@@ -6296,81 +6236,96 @@
           <a:p>
             <a:pPr>
               <a:spcAft>
-                <a:spcPts val="400"/>
+                <a:spcPts val="300"/>
               </a:spcAft>
-              <a:defRPr sz="1150">
+              <a:defRPr sz="1100">
                 <a:solidFill>
                   <a:srgbClr val="1E293B"/>
                 </a:solidFill>
               </a:defRPr>
             </a:pPr>
             <a:r>
-              <a:t>• Manual Transcription (From Scratch): 22.5 min/page (Effort: 285.0)</a:t>
+              <a:t>• Proposed Framework: CER = 15.32%, WER = 9.97%, Accuracy = 84.50%</a:t>
             </a:r>
           </a:p>
           <a:p>
             <a:pPr>
               <a:spcAft>
-                <a:spcPts val="400"/>
+                <a:spcPts val="300"/>
               </a:spcAft>
-              <a:defRPr sz="1150">
+              <a:defRPr sz="1100">
                 <a:solidFill>
                   <a:srgbClr val="1E293B"/>
                 </a:solidFill>
               </a:defRPr>
             </a:pPr>
             <a:r>
-              <a:t>• Standard Automated Baseline: 11.8 min/page (Effort: 142.6)</a:t>
+              <a:t>• Tesseract 5 Baseline: CER = 47.82%, WER = 58.30%, Accuracy = 52.18%</a:t>
             </a:r>
           </a:p>
           <a:p>
             <a:pPr>
               <a:spcAft>
-                <a:spcPts val="400"/>
+                <a:spcPts val="300"/>
               </a:spcAft>
-              <a:defRPr sz="1150">
+              <a:defRPr sz="1100">
                 <a:solidFill>
                   <a:srgbClr val="1E293B"/>
                 </a:solidFill>
               </a:defRPr>
             </a:pPr>
             <a:r>
-              <a:t>• Proposed Pre-Annotations: 2.9 min/page (Effort: 14.20)</a:t>
+              <a:t>• Kraken HTR Baseline: CER = 38.60%, WER = 44.12%, Accuracy = 61.40%</a:t>
             </a:r>
           </a:p>
           <a:p>
             <a:pPr>
               <a:spcAft>
-                <a:spcPts val="400"/>
+                <a:spcPts val="300"/>
               </a:spcAft>
-              <a:defRPr sz="1150">
+              <a:defRPr sz="1100">
                 <a:solidFill>
                   <a:srgbClr val="1E293B"/>
                 </a:solidFill>
               </a:defRPr>
             </a:pPr>
             <a:r>
-              <a:t>• Achieves 75.4% reduction in manual editing time.</a:t>
+              <a:t>• Supervised LayoutLMv3: CER = 26.90%, WER = 31.85%, Accuracy = 73.10%</a:t>
+            </a:r>
+          </a:p>
+          <a:p>
+            <a:pPr>
+              <a:spcAft>
+                <a:spcPts val="300"/>
+              </a:spcAft>
+              <a:defRPr sz="1100">
+                <a:solidFill>
+                  <a:srgbClr val="1E293B"/>
+                </a:solidFill>
+              </a:defRPr>
+            </a:pPr>
+            <a:r>
+              <a:t>• Demonstrates 3.12x error reduction over classical OCR.</a:t>
             </a:r>
           </a:p>
           <a:p>
             <a:br/>
             <a:pPr>
               <a:spcAft>
-                <a:spcPts val="400"/>
+                <a:spcPts val="300"/>
               </a:spcAft>
-              <a:defRPr sz="1100" b="1">
+              <a:defRPr sz="1050" b="1">
                 <a:solidFill>
                   <a:srgbClr val="0000DC"/>
                 </a:solidFill>
               </a:defRPr>
             </a:pPr>
             <a:r>
-              <a:t>E = 50·|Delta R| + Sum [ (1 - IoU)·100 + 0.5·|Delta V| ]</a:t>
+              <a:t>Overall Accuracy: 84.50%</a:t>
             </a:r>
             <a:br/>
             <a:r>
-              <a:t>Rating in Aletheia: Exceptional.</a:t>
+              <a:t>Zero Empty Predictions (0.00%) across all test folios.</a:t>
             </a:r>
           </a:p>
         </p:txBody>
@@ -6458,7 +6413,7 @@
               </a:defRPr>
             </a:pPr>
             <a:r>
-              <a:t>SECTION 4: CONCLUSION</a:t>
+              <a:t>SECTION 3: EXPERIMENTAL RESULTS</a:t>
             </a:r>
           </a:p>
         </p:txBody>
@@ -6493,7 +6448,7 @@
               </a:defRPr>
             </a:pPr>
             <a:r>
-              <a:t>Standardized Output Formats &amp; Production Scaling</a:t>
+              <a:t>Semantic Layout Segmentation and Human Effort Evaluation</a:t>
             </a:r>
           </a:p>
         </p:txBody>
@@ -6528,7 +6483,7 @@
               </a:defRPr>
             </a:pPr>
             <a:r>
-              <a:t>PRImA PAGE-XML 2013 Schema Conformance and Production Readiness</a:t>
+              <a:t>Instance-Level F1-Scores and Paleographer Latency Reduction</a:t>
             </a:r>
           </a:p>
         </p:txBody>
@@ -6625,7 +6580,7 @@
               </a:defRPr>
             </a:pPr>
             <a:r>
-              <a:t>  PRImA PAGE-XML 2013 Hierarchy</a:t>
+              <a:t>  1. Semantic Layout F1-Scores</a:t>
             </a:r>
           </a:p>
         </p:txBody>
@@ -6654,145 +6609,92 @@
           <a:p>
             <a:pPr>
               <a:spcAft>
-                <a:spcPts val="400"/>
+                <a:spcPts val="300"/>
               </a:spcAft>
-              <a:defRPr sz="1150">
+              <a:defRPr sz="1100">
                 <a:solidFill>
                   <a:srgbClr val="1E293B"/>
                 </a:solidFill>
               </a:defRPr>
             </a:pPr>
             <a:r>
-              <a:t>• PcGts (Root Archive Container)</a:t>
+              <a:t>• TextRegion F1: 0.951 (Precision: 0.942, Recall: 0.961)</a:t>
             </a:r>
           </a:p>
           <a:p>
             <a:pPr>
               <a:spcAft>
-                <a:spcPts val="400"/>
+                <a:spcPts val="300"/>
               </a:spcAft>
-              <a:defRPr sz="1150">
+              <a:defRPr sz="1100">
                 <a:solidFill>
                   <a:srgbClr val="1E293B"/>
                 </a:solidFill>
               </a:defRPr>
             </a:pPr>
             <a:r>
-              <a:t>•   └── Page (Folio image dimensions)</a:t>
+              <a:t>• TextLine F1: 0.926 (Precision: 0.918, Recall: 0.935)</a:t>
             </a:r>
           </a:p>
           <a:p>
             <a:pPr>
               <a:spcAft>
-                <a:spcPts val="400"/>
+                <a:spcPts val="300"/>
               </a:spcAft>
-              <a:defRPr sz="1150">
+              <a:defRPr sz="1100">
                 <a:solidFill>
                   <a:srgbClr val="1E293B"/>
                 </a:solidFill>
               </a:defRPr>
             </a:pPr>
             <a:r>
-              <a:t>•        ├── TextRegion (Paragraph &amp; column bounds)</a:t>
+              <a:t>• GraphicRegion F1: 0.907 (Precision: 0.925, Recall: 0.890)</a:t>
             </a:r>
           </a:p>
           <a:p>
             <a:pPr>
               <a:spcAft>
-                <a:spcPts val="400"/>
+                <a:spcPts val="300"/>
               </a:spcAft>
-              <a:defRPr sz="1150">
+              <a:defRPr sz="1100">
                 <a:solidFill>
                   <a:srgbClr val="1E293B"/>
                 </a:solidFill>
               </a:defRPr>
             </a:pPr>
             <a:r>
-              <a:t>•        │     └── TextLine (Line-level polygon + text)</a:t>
+              <a:t>• Damage / Binder Hole F1: 0.954 (Precision: 0.968, Recall: 0.941)</a:t>
             </a:r>
           </a:p>
           <a:p>
             <a:pPr>
               <a:spcAft>
-                <a:spcPts val="400"/>
+                <a:spcPts val="300"/>
               </a:spcAft>
-              <a:defRPr sz="1150">
+              <a:defRPr sz="1100">
                 <a:solidFill>
                   <a:srgbClr val="1E293B"/>
                 </a:solidFill>
               </a:defRPr>
             </a:pPr>
             <a:r>
-              <a:t>•        │           └── Word (Word bbox + Unicode)</a:t>
-            </a:r>
-          </a:p>
-          <a:p>
+              <a:t>• PageFrame F1: 0.988 | Overall Layout Mean F1: 0.932</a:t>
+            </a:r>
+          </a:p>
+          <a:p>
+            <a:br/>
             <a:pPr>
               <a:spcAft>
-                <a:spcPts val="400"/>
+                <a:spcPts val="300"/>
               </a:spcAft>
-              <a:defRPr sz="1150">
-                <a:solidFill>
-                  <a:srgbClr val="1E293B"/>
-                </a:solidFill>
-              </a:defRPr>
-            </a:pPr>
-            <a:r>
-              <a:t>•        │                 └── Glyph (Akshara bbox)</a:t>
-            </a:r>
-          </a:p>
-          <a:p>
-            <a:pPr>
-              <a:spcAft>
-                <a:spcPts val="400"/>
-              </a:spcAft>
-              <a:defRPr sz="1150">
-                <a:solidFill>
-                  <a:srgbClr val="1E293B"/>
-                </a:solidFill>
-              </a:defRPr>
-            </a:pPr>
-            <a:r>
-              <a:t>•        └── GraphicRegion (Artwork / illustrations)</a:t>
-            </a:r>
-          </a:p>
-          <a:p>
-            <a:pPr>
-              <a:spcAft>
-                <a:spcPts val="400"/>
-              </a:spcAft>
-              <a:defRPr sz="1150">
-                <a:solidFill>
-                  <a:srgbClr val="1E293B"/>
-                </a:solidFill>
-              </a:defRPr>
-            </a:pPr>
-            <a:r>
-              <a:t>• Fully compatible with Aletheia, Transkribus, &amp; eScriptorium.</a:t>
-            </a:r>
-          </a:p>
-          <a:p>
-            <a:br/>
-            <a:pPr>
-              <a:spcAft>
-                <a:spcPts val="400"/>
-              </a:spcAft>
-              <a:defRPr sz="1100" b="1">
+              <a:defRPr sz="1050" b="1">
                 <a:solidFill>
                   <a:srgbClr val="0000DC"/>
                 </a:solidFill>
               </a:defRPr>
             </a:pPr>
             <a:r>
-              <a:t>RDP Polygon Simplification:</a:t>
-            </a:r>
-            <a:br/>
-            <a:r>
-              <a:t>Perpendicular distance threshold eps = 0.005·ArcLength</a:t>
-            </a:r>
-            <a:br/>
-            <a:r>
-              <a:t>Reduces vertex count by 82.6% (IoU &gt; 0.98).</a:t>
+              <a:t>F1 = 2 · (Precision · Recall) / (Precision + Recall)</a:t>
             </a:r>
           </a:p>
         </p:txBody>
@@ -6889,7 +6791,7 @@
               </a:defRPr>
             </a:pPr>
             <a:r>
-              <a:t>  Benchmark Accuracy Highlights</a:t>
+              <a:t>  2. Human Correction Effort Model (PRImA Protocol)</a:t>
             </a:r>
           </a:p>
         </p:txBody>
@@ -6918,92 +6820,81 @@
           <a:p>
             <a:pPr>
               <a:spcAft>
-                <a:spcPts val="400"/>
+                <a:spcPts val="300"/>
               </a:spcAft>
-              <a:defRPr sz="1150">
+              <a:defRPr sz="1100">
                 <a:solidFill>
                   <a:srgbClr val="1E293B"/>
                 </a:solidFill>
               </a:defRPr>
             </a:pPr>
             <a:r>
-              <a:t>• Overall Accuracy: 84.50%</a:t>
+              <a:t>• Manual Transcription (From Scratch): 22.5 min/page (Effort: 285.0)</a:t>
             </a:r>
           </a:p>
           <a:p>
             <a:pPr>
               <a:spcAft>
-                <a:spcPts val="400"/>
+                <a:spcPts val="300"/>
               </a:spcAft>
-              <a:defRPr sz="1150">
+              <a:defRPr sz="1100">
                 <a:solidFill>
                   <a:srgbClr val="1E293B"/>
                 </a:solidFill>
               </a:defRPr>
             </a:pPr>
             <a:r>
-              <a:t>• Character Error Rate (CER): 15.32%</a:t>
+              <a:t>• Standard Automated Baseline: 11.8 min/page (Effort: 142.6)</a:t>
             </a:r>
           </a:p>
           <a:p>
             <a:pPr>
               <a:spcAft>
-                <a:spcPts val="400"/>
+                <a:spcPts val="300"/>
               </a:spcAft>
-              <a:defRPr sz="1150">
+              <a:defRPr sz="1100">
                 <a:solidFill>
                   <a:srgbClr val="1E293B"/>
                 </a:solidFill>
               </a:defRPr>
             </a:pPr>
             <a:r>
-              <a:t>• Word Error Rate (WER): 9.97%</a:t>
+              <a:t>• Proposed Pre-Annotations: 2.9 min/page (Effort: 14.20)</a:t>
             </a:r>
           </a:p>
           <a:p>
             <a:pPr>
               <a:spcAft>
-                <a:spcPts val="400"/>
+                <a:spcPts val="300"/>
               </a:spcAft>
-              <a:defRPr sz="1150">
+              <a:defRPr sz="1100">
                 <a:solidFill>
                   <a:srgbClr val="1E293B"/>
                 </a:solidFill>
               </a:defRPr>
             </a:pPr>
             <a:r>
-              <a:t>• Human Correction Time: 2.9 min/page (75.4% reduction)</a:t>
-            </a:r>
-          </a:p>
-          <a:p>
+              <a:t>• Achieves 75.4% reduction in manual editing time.</a:t>
+            </a:r>
+          </a:p>
+          <a:p>
+            <a:br/>
             <a:pPr>
               <a:spcAft>
-                <a:spcPts val="400"/>
+                <a:spcPts val="300"/>
               </a:spcAft>
-              <a:defRPr sz="1150">
-                <a:solidFill>
-                  <a:srgbClr val="1E293B"/>
-                </a:solidFill>
-              </a:defRPr>
-            </a:pPr>
-            <a:r>
-              <a:t>• Evaluated on 1,054 historical manuscript folios with 0.00% empty predictions.</a:t>
-            </a:r>
-          </a:p>
-          <a:p>
+              <a:defRPr sz="1050" b="1">
+                <a:solidFill>
+                  <a:srgbClr val="0000DC"/>
+                </a:solidFill>
+              </a:defRPr>
+            </a:pPr>
+            <a:r>
+              <a:t>E = 50·|Delta R| + Sum [ (1 - IoU)·100 + 0.5·|Delta V| ]</a:t>
+            </a:r>
             <a:br/>
-            <a:pPr>
-              <a:spcAft>
-                <a:spcPts val="400"/>
-              </a:spcAft>
-              <a:defRPr sz="1100" b="1">
-                <a:solidFill>
-                  <a:srgbClr val="0000DC"/>
-                </a:solidFill>
-              </a:defRPr>
-            </a:pPr>
-            <a:r>
-              <a:t>Scalable Pipeline: Batch processing at 350 ms/page on NVIDIA RTX GPU.</a:t>
+            <a:r>
+              <a:t>Rating in Aletheia: Exceptional.</a:t>
             </a:r>
           </a:p>
         </p:txBody>
@@ -7287,9 +7178,9 @@
           <a:p>
             <a:pPr>
               <a:spcAft>
-                <a:spcPts val="400"/>
+                <a:spcPts val="300"/>
               </a:spcAft>
-              <a:defRPr sz="1150">
+              <a:defRPr sz="1100">
                 <a:solidFill>
                   <a:srgbClr val="1E293B"/>
                 </a:solidFill>
@@ -7302,9 +7193,9 @@
           <a:p>
             <a:pPr>
               <a:spcAft>
-                <a:spcPts val="400"/>
+                <a:spcPts val="300"/>
               </a:spcAft>
-              <a:defRPr sz="1150">
+              <a:defRPr sz="1100">
                 <a:solidFill>
                   <a:srgbClr val="1E293B"/>
                 </a:solidFill>
@@ -7317,9 +7208,9 @@
           <a:p>
             <a:pPr>
               <a:spcAft>
-                <a:spcPts val="400"/>
+                <a:spcPts val="300"/>
               </a:spcAft>
-              <a:defRPr sz="1150">
+              <a:defRPr sz="1100">
                 <a:solidFill>
                   <a:srgbClr val="1E293B"/>
                 </a:solidFill>
@@ -7332,9 +7223,9 @@
           <a:p>
             <a:pPr>
               <a:spcAft>
-                <a:spcPts val="400"/>
+                <a:spcPts val="300"/>
               </a:spcAft>
-              <a:defRPr sz="1150">
+              <a:defRPr sz="1100">
                 <a:solidFill>
                   <a:srgbClr val="1E293B"/>
                 </a:solidFill>
@@ -7347,9 +7238,9 @@
           <a:p>
             <a:pPr>
               <a:spcAft>
-                <a:spcPts val="400"/>
+                <a:spcPts val="300"/>
               </a:spcAft>
-              <a:defRPr sz="1150">
+              <a:defRPr sz="1100">
                 <a:solidFill>
                   <a:srgbClr val="1E293B"/>
                 </a:solidFill>
@@ -7363,9 +7254,9 @@
             <a:br/>
             <a:pPr>
               <a:spcAft>
-                <a:spcPts val="400"/>
+                <a:spcPts val="300"/>
               </a:spcAft>
-              <a:defRPr sz="1100" b="1">
+              <a:defRPr sz="1050" b="1">
                 <a:solidFill>
                   <a:srgbClr val="0000DC"/>
                 </a:solidFill>
@@ -7495,7 +7386,7 @@
               </a:defRPr>
             </a:pPr>
             <a:r>
-              <a:t>Introduction &amp; Problem Statement</a:t>
+              <a:t>Physical and Orthographic Challenges in Indic Manuscripts</a:t>
             </a:r>
           </a:p>
         </p:txBody>
@@ -7530,21 +7421,45 @@
               </a:defRPr>
             </a:pPr>
             <a:r>
-              <a:t>Historical Manuscript Degradation and Manual Annotation Bottlenecks</a:t>
-            </a:r>
-          </a:p>
-        </p:txBody>
-      </p:sp>
-      <p:sp>
-        <p:nvSpPr>
-          <p:cNvPr id="5" name="Rounded Rectangle 4"/>
+              <a:t>Continuous Headlines, Substrate Degradation, and Binder Punch Holes</a:t>
+            </a:r>
+          </a:p>
+        </p:txBody>
+      </p:sp>
+      <p:pic>
+        <p:nvPicPr>
+          <p:cNvPr id="5" name="Picture 4" descr="shirorekha_challenge_demo.png"/>
+          <p:cNvPicPr>
+            <a:picLocks noChangeAspect="1"/>
+          </p:cNvPicPr>
+          <p:nvPr/>
+        </p:nvPicPr>
+        <p:blipFill>
+          <a:blip r:embed="rId2"/>
+          <a:stretch>
+            <a:fillRect/>
+          </a:stretch>
+        </p:blipFill>
+        <p:spPr>
+          <a:xfrm>
+            <a:off x="731520" y="1463040"/>
+            <a:ext cx="10698480" cy="2286000"/>
+          </a:xfrm>
+          <a:prstGeom prst="rect">
+            <a:avLst/>
+          </a:prstGeom>
+        </p:spPr>
+      </p:pic>
+      <p:sp>
+        <p:nvSpPr>
+          <p:cNvPr id="6" name="Rounded Rectangle 5"/>
           <p:cNvSpPr/>
           <p:nvPr/>
         </p:nvSpPr>
         <p:spPr>
           <a:xfrm>
-            <a:off x="731520" y="1554480"/>
-            <a:ext cx="5212080" cy="4663440"/>
+            <a:off x="731520" y="3931920"/>
+            <a:ext cx="5212080" cy="2377440"/>
           </a:xfrm>
           <a:prstGeom prst="roundRect">
             <a:avLst/>
@@ -7582,13 +7497,13 @@
       </p:sp>
       <p:sp>
         <p:nvSpPr>
-          <p:cNvPr id="6" name="Rounded Rectangle 5"/>
+          <p:cNvPr id="7" name="Rounded Rectangle 6"/>
           <p:cNvSpPr/>
           <p:nvPr/>
         </p:nvSpPr>
         <p:spPr>
           <a:xfrm>
-            <a:off x="731520" y="1554480"/>
+            <a:off x="731520" y="3931920"/>
             <a:ext cx="5212080" cy="438912"/>
           </a:xfrm>
           <a:prstGeom prst="roundRect">
@@ -7627,21 +7542,21 @@
               </a:defRPr>
             </a:pPr>
             <a:r>
-              <a:t>  1. Heritage at Risk &amp; OCR Limitations</a:t>
-            </a:r>
-          </a:p>
-        </p:txBody>
-      </p:sp>
-      <p:sp>
-        <p:nvSpPr>
-          <p:cNvPr id="7" name="TextBox 6"/>
+              <a:t>  1. Continuous Headline (Shirorekha)</a:t>
+            </a:r>
+          </a:p>
+        </p:txBody>
+      </p:sp>
+      <p:sp>
+        <p:nvSpPr>
+          <p:cNvPr id="8" name="TextBox 7"/>
           <p:cNvSpPr txBox="1"/>
           <p:nvPr/>
         </p:nvSpPr>
         <p:spPr>
           <a:xfrm>
-            <a:off x="914400" y="2057400"/>
-            <a:ext cx="4846320" cy="4069080"/>
+            <a:off x="914400" y="4434840"/>
+            <a:ext cx="4846320" cy="1783080"/>
           </a:xfrm>
           <a:prstGeom prst="rect">
             <a:avLst/>
@@ -7656,84 +7571,65 @@
           <a:p>
             <a:pPr>
               <a:spcAft>
-                <a:spcPts val="400"/>
+                <a:spcPts val="300"/>
               </a:spcAft>
-              <a:defRPr sz="1150">
+              <a:defRPr sz="1100">
                 <a:solidFill>
                   <a:srgbClr val="1E293B"/>
                 </a:solidFill>
               </a:defRPr>
             </a:pPr>
             <a:r>
-              <a:t>• Thousands of Indic manuscripts (Ramcharitmanas, palm-leaf folios) suffer severe decay from humidity, insects, and ink corrosion.</a:t>
+              <a:t>• Devanagari characters are bound along the upper boundary by a horizontal stroke.</a:t>
             </a:r>
           </a:p>
           <a:p>
             <a:pPr>
               <a:spcAft>
-                <a:spcPts val="400"/>
+                <a:spcPts val="300"/>
               </a:spcAft>
-              <a:defRPr sz="1150">
+              <a:defRPr sz="1100">
                 <a:solidFill>
                   <a:srgbClr val="1E293B"/>
                 </a:solidFill>
               </a:defRPr>
             </a:pPr>
             <a:r>
-              <a:t>• Standard OCR (Tesseract, Google Vision) fails on complex Devanagari with conjuncts, matras, and non-standard layouts.</a:t>
-            </a:r>
-          </a:p>
-          <a:p>
+              <a:t>• Connected components group entire lines as single entities without segmentation.</a:t>
+            </a:r>
+          </a:p>
+          <a:p>
+            <a:br/>
             <a:pPr>
               <a:spcAft>
-                <a:spcPts val="400"/>
+                <a:spcPts val="300"/>
               </a:spcAft>
-              <a:defRPr sz="1150">
-                <a:solidFill>
-                  <a:srgbClr val="1E293B"/>
-                </a:solidFill>
-              </a:defRPr>
-            </a:pPr>
-            <a:r>
-              <a:t>• Optical image formation equation:</a:t>
-            </a:r>
-          </a:p>
-          <a:p>
+              <a:defRPr sz="1050" b="1">
+                <a:solidFill>
+                  <a:srgbClr val="0000DC"/>
+                </a:solidFill>
+              </a:defRPr>
+            </a:pPr>
+            <a:r>
+              <a:t>S_word = Union_{i=1}^M G_i  UNION  H_shirorekha</a:t>
+            </a:r>
             <a:br/>
-            <a:pPr>
-              <a:spcAft>
-                <a:spcPts val="400"/>
-              </a:spcAft>
-              <a:defRPr sz="1100" b="1">
-                <a:solidFill>
-                  <a:srgbClr val="0000DC"/>
-                </a:solidFill>
-              </a:defRPr>
-            </a:pPr>
-            <a:r>
-              <a:t>I(x,y) = R(x,y) · L(x,y) + eta(x,y)</a:t>
-            </a:r>
-            <a:br/>
-            <a:r>
-              <a:t>where R(x,y) is true reflectance, L(x,y) is illumination,</a:t>
-            </a:r>
-            <a:br/>
-            <a:r>
-              <a:t>and eta(x,y) is additive substrate decay noise.</a:t>
-            </a:r>
-          </a:p>
-        </p:txBody>
-      </p:sp>
-      <p:sp>
-        <p:nvSpPr>
-          <p:cNvPr id="8" name="Rounded Rectangle 7"/>
+            <a:r>
+              <a:t>where G_i denotes individual glyph components.</a:t>
+            </a:r>
+          </a:p>
+        </p:txBody>
+      </p:sp>
+      <p:sp>
+        <p:nvSpPr>
+          <p:cNvPr id="9" name="Rounded Rectangle 8"/>
           <p:cNvSpPr/>
           <p:nvPr/>
         </p:nvSpPr>
         <p:spPr>
           <a:xfrm>
-            <a:off x="6217920" y="1554480"/>
-            <a:ext cx="5212080" cy="4663440"/>
+            <a:off x="6217920" y="3931920"/>
+            <a:ext cx="5212080" cy="2377440"/>
           </a:xfrm>
           <a:prstGeom prst="roundRect">
             <a:avLst/>
@@ -7771,13 +7667,13 @@
       </p:sp>
       <p:sp>
         <p:nvSpPr>
-          <p:cNvPr id="9" name="Rounded Rectangle 8"/>
+          <p:cNvPr id="10" name="Rounded Rectangle 9"/>
           <p:cNvSpPr/>
           <p:nvPr/>
         </p:nvSpPr>
         <p:spPr>
           <a:xfrm>
-            <a:off x="6217920" y="1554480"/>
+            <a:off x="6217920" y="3931920"/>
             <a:ext cx="5212080" cy="438912"/>
           </a:xfrm>
           <a:prstGeom prst="roundRect">
@@ -7816,21 +7712,21 @@
               </a:defRPr>
             </a:pPr>
             <a:r>
-              <a:t>  2. Manual Annotation Bottleneck (3,000+ Pages)</a:t>
-            </a:r>
-          </a:p>
-        </p:txBody>
-      </p:sp>
-      <p:sp>
-        <p:nvSpPr>
-          <p:cNvPr id="10" name="TextBox 9"/>
+              <a:t>  2. Substrate Degradation &amp; Illumination</a:t>
+            </a:r>
+          </a:p>
+        </p:txBody>
+      </p:sp>
+      <p:sp>
+        <p:nvSpPr>
+          <p:cNvPr id="11" name="TextBox 10"/>
           <p:cNvSpPr txBox="1"/>
           <p:nvPr/>
         </p:nvSpPr>
         <p:spPr>
           <a:xfrm>
-            <a:off x="6400800" y="2057400"/>
-            <a:ext cx="4846320" cy="4069080"/>
+            <a:off x="6400800" y="4434840"/>
+            <a:ext cx="4846320" cy="1783080"/>
           </a:xfrm>
           <a:prstGeom prst="rect">
             <a:avLst/>
@@ -7845,77 +7741,58 @@
           <a:p>
             <a:pPr>
               <a:spcAft>
-                <a:spcPts val="400"/>
+                <a:spcPts val="300"/>
               </a:spcAft>
-              <a:defRPr sz="1150">
+              <a:defRPr sz="1100">
                 <a:solidFill>
                   <a:srgbClr val="1E293B"/>
                 </a:solidFill>
               </a:defRPr>
             </a:pPr>
             <a:r>
-              <a:t>• Expert paleographers spend 30 to 60 minutes per page manually drawing bounding boxes for regions, lines, words, and aksharas.</a:t>
+              <a:t>• Palm-leaf and handmade papers exhibit non-uniform decay and punch holes.</a:t>
             </a:r>
           </a:p>
           <a:p>
             <a:pPr>
               <a:spcAft>
-                <a:spcPts val="400"/>
+                <a:spcPts val="300"/>
               </a:spcAft>
-              <a:defRPr sz="1150">
+              <a:defRPr sz="1100">
                 <a:solidFill>
                   <a:srgbClr val="1E293B"/>
                 </a:solidFill>
               </a:defRPr>
             </a:pPr>
             <a:r>
-              <a:t>• At 3,000+ historical pages, manual annotation requires over 2,000 human-hours.</a:t>
-            </a:r>
-          </a:p>
-          <a:p>
+              <a:t>• Causes frequent false character hallucinations (e.g. 'Tha').</a:t>
+            </a:r>
+          </a:p>
+          <a:p>
+            <a:br/>
             <a:pPr>
               <a:spcAft>
-                <a:spcPts val="400"/>
+                <a:spcPts val="300"/>
               </a:spcAft>
-              <a:defRPr sz="1150">
-                <a:solidFill>
-                  <a:srgbClr val="1E293B"/>
-                </a:solidFill>
-              </a:defRPr>
-            </a:pPr>
-            <a:r>
-              <a:t>• Continuous headline modeling:</a:t>
-            </a:r>
-          </a:p>
-          <a:p>
+              <a:defRPr sz="1050" b="1">
+                <a:solidFill>
+                  <a:srgbClr val="0000DC"/>
+                </a:solidFill>
+              </a:defRPr>
+            </a:pPr>
+            <a:r>
+              <a:t>I(x,y) = R(x,y) · L(x,y) + eta(x,y),   Psi &gt; 0.85</a:t>
+            </a:r>
             <a:br/>
-            <a:pPr>
-              <a:spcAft>
-                <a:spcPts val="400"/>
-              </a:spcAft>
-              <a:defRPr sz="1100" b="1">
-                <a:solidFill>
-                  <a:srgbClr val="0000DC"/>
-                </a:solidFill>
-              </a:defRPr>
-            </a:pPr>
-            <a:r>
-              <a:t>S_word = Union_{i=1}^M G_i  UNION  H_shirorekha</a:t>
-            </a:r>
-            <a:br/>
-            <a:r>
-              <a:t>Connected components group entire lines into single blobs,</a:t>
-            </a:r>
-            <a:br/>
-            <a:r>
-              <a:t>preventing classical character segmentation.</a:t>
-            </a:r>
-          </a:p>
-        </p:txBody>
-      </p:sp>
-      <p:sp>
-        <p:nvSpPr>
-          <p:cNvPr id="11" name="TextBox 10"/>
+            <a:r>
+              <a:t>where eta(x,y) is additive substrate noise.</a:t>
+            </a:r>
+          </a:p>
+        </p:txBody>
+      </p:sp>
+      <p:sp>
+        <p:nvSpPr>
+          <p:cNvPr id="12" name="TextBox 11"/>
           <p:cNvSpPr txBox="1"/>
           <p:nvPr/>
         </p:nvSpPr>
@@ -8192,9 +8069,9 @@
           <a:p>
             <a:pPr>
               <a:spcAft>
-                <a:spcPts val="400"/>
+                <a:spcPts val="300"/>
               </a:spcAft>
-              <a:defRPr sz="1150">
+              <a:defRPr sz="1100">
                 <a:solidFill>
                   <a:srgbClr val="1E293B"/>
                 </a:solidFill>
@@ -8207,9 +8084,9 @@
           <a:p>
             <a:pPr>
               <a:spcAft>
-                <a:spcPts val="400"/>
+                <a:spcPts val="300"/>
               </a:spcAft>
-              <a:defRPr sz="1150">
+              <a:defRPr sz="1100">
                 <a:solidFill>
                   <a:srgbClr val="1E293B"/>
                 </a:solidFill>
@@ -8222,9 +8099,9 @@
           <a:p>
             <a:pPr>
               <a:spcAft>
-                <a:spcPts val="400"/>
+                <a:spcPts val="300"/>
               </a:spcAft>
-              <a:defRPr sz="1150">
+              <a:defRPr sz="1100">
                 <a:solidFill>
                   <a:srgbClr val="1E293B"/>
                 </a:solidFill>
@@ -8235,12 +8112,27 @@
             </a:r>
           </a:p>
           <a:p>
+            <a:pPr>
+              <a:spcAft>
+                <a:spcPts val="300"/>
+              </a:spcAft>
+              <a:defRPr sz="1100">
+                <a:solidFill>
+                  <a:srgbClr val="1E293B"/>
+                </a:solidFill>
+              </a:defRPr>
+            </a:pPr>
+            <a:r>
+              <a:t>• Mathematical Continuity: Every stage output directly feeds the subsequent stage's input.</a:t>
+            </a:r>
+          </a:p>
+          <a:p>
             <a:br/>
             <a:pPr>
               <a:spcAft>
-                <a:spcPts val="400"/>
+                <a:spcPts val="300"/>
               </a:spcAft>
-              <a:defRPr sz="1100" b="1">
+              <a:defRPr sz="1050" b="1">
                 <a:solidFill>
                   <a:srgbClr val="0000DC"/>
                 </a:solidFill>
@@ -8688,7 +8580,7 @@
               </a:defRPr>
             </a:pPr>
             <a:r>
-              <a:t>  Adaptive Gaussian Thresholding</a:t>
+              <a:t>  Adaptive Gaussian Thresholding (I -&gt; B)</a:t>
             </a:r>
           </a:p>
         </p:txBody>
@@ -8717,9 +8609,9 @@
           <a:p>
             <a:pPr>
               <a:spcAft>
-                <a:spcPts val="400"/>
+                <a:spcPts val="300"/>
               </a:spcAft>
-              <a:defRPr sz="1150">
+              <a:defRPr sz="1100">
                 <a:solidFill>
                   <a:srgbClr val="1E293B"/>
                 </a:solidFill>
@@ -8732,9 +8624,9 @@
           <a:p>
             <a:pPr>
               <a:spcAft>
-                <a:spcPts val="400"/>
+                <a:spcPts val="300"/>
               </a:spcAft>
-              <a:defRPr sz="1150">
+              <a:defRPr sz="1100">
                 <a:solidFill>
                   <a:srgbClr val="1E293B"/>
                 </a:solidFill>
@@ -8747,9 +8639,9 @@
           <a:p>
             <a:pPr>
               <a:spcAft>
-                <a:spcPts val="400"/>
+                <a:spcPts val="300"/>
               </a:spcAft>
-              <a:defRPr sz="1150">
+              <a:defRPr sz="1100">
                 <a:solidFill>
                   <a:srgbClr val="1E293B"/>
                 </a:solidFill>
@@ -8763,9 +8655,9 @@
             <a:br/>
             <a:pPr>
               <a:spcAft>
-                <a:spcPts val="400"/>
+                <a:spcPts val="300"/>
               </a:spcAft>
-              <a:defRPr sz="1100" b="1">
+              <a:defRPr sz="1050" b="1">
                 <a:solidFill>
                   <a:srgbClr val="0000DC"/>
                 </a:solidFill>
@@ -8873,7 +8765,7 @@
               </a:defRPr>
             </a:pPr>
             <a:r>
-              <a:t>  Morphological Opening Noise Suppression</a:t>
+              <a:t>  Morphological Opening Noise Suppression (B -&gt; B_clean)</a:t>
             </a:r>
           </a:p>
         </p:txBody>
@@ -8902,9 +8794,9 @@
           <a:p>
             <a:pPr>
               <a:spcAft>
-                <a:spcPts val="400"/>
+                <a:spcPts val="300"/>
               </a:spcAft>
-              <a:defRPr sz="1150">
+              <a:defRPr sz="1100">
                 <a:solidFill>
                   <a:srgbClr val="1E293B"/>
                 </a:solidFill>
@@ -8917,9 +8809,9 @@
           <a:p>
             <a:pPr>
               <a:spcAft>
-                <a:spcPts val="400"/>
+                <a:spcPts val="300"/>
               </a:spcAft>
-              <a:defRPr sz="1150">
+              <a:defRPr sz="1100">
                 <a:solidFill>
                   <a:srgbClr val="1E293B"/>
                 </a:solidFill>
@@ -8932,9 +8824,9 @@
           <a:p>
             <a:pPr>
               <a:spcAft>
-                <a:spcPts val="400"/>
+                <a:spcPts val="300"/>
               </a:spcAft>
-              <a:defRPr sz="1150">
+              <a:defRPr sz="1100">
                 <a:solidFill>
                   <a:srgbClr val="1E293B"/>
                 </a:solidFill>
@@ -8948,9 +8840,9 @@
             <a:br/>
             <a:pPr>
               <a:spcAft>
-                <a:spcPts val="400"/>
+                <a:spcPts val="300"/>
               </a:spcAft>
-              <a:defRPr sz="1100" b="1">
+              <a:defRPr sz="1050" b="1">
                 <a:solidFill>
                   <a:srgbClr val="0000DC"/>
                 </a:solidFill>
@@ -9216,7 +9108,7 @@
               </a:defRPr>
             </a:pPr>
             <a:r>
-              <a:t>  Patch Discretization &amp; Position Encoding</a:t>
+              <a:t>  Patch Discretization &amp; Position Encoding (I -&gt; x_0)</a:t>
             </a:r>
           </a:p>
         </p:txBody>
@@ -9245,9 +9137,9 @@
           <a:p>
             <a:pPr>
               <a:spcAft>
-                <a:spcPts val="400"/>
+                <a:spcPts val="300"/>
               </a:spcAft>
-              <a:defRPr sz="1150">
+              <a:defRPr sz="1100">
                 <a:solidFill>
                   <a:srgbClr val="1E293B"/>
                 </a:solidFill>
@@ -9260,9 +9152,9 @@
           <a:p>
             <a:pPr>
               <a:spcAft>
-                <a:spcPts val="400"/>
+                <a:spcPts val="300"/>
               </a:spcAft>
-              <a:defRPr sz="1150">
+              <a:defRPr sz="1100">
                 <a:solidFill>
                   <a:srgbClr val="1E293B"/>
                 </a:solidFill>
@@ -9275,9 +9167,9 @@
           <a:p>
             <a:pPr>
               <a:spcAft>
-                <a:spcPts val="400"/>
+                <a:spcPts val="300"/>
               </a:spcAft>
-              <a:defRPr sz="1150">
+              <a:defRPr sz="1100">
                 <a:solidFill>
                   <a:srgbClr val="1E293B"/>
                 </a:solidFill>
@@ -9291,9 +9183,9 @@
             <a:br/>
             <a:pPr>
               <a:spcAft>
-                <a:spcPts val="400"/>
+                <a:spcPts val="300"/>
               </a:spcAft>
-              <a:defRPr sz="1100" b="1">
+              <a:defRPr sz="1050" b="1">
                 <a:solidFill>
                   <a:srgbClr val="0000DC"/>
                 </a:solidFill>
@@ -9401,7 +9293,7 @@
               </a:defRPr>
             </a:pPr>
             <a:r>
-              <a:t>  Multi-Head Self-Attention (MHSA)</a:t>
+              <a:t>  Multi-Head Self-Attention Matrix (x_0 -&gt; Z)</a:t>
             </a:r>
           </a:p>
         </p:txBody>
@@ -9430,9 +9322,9 @@
           <a:p>
             <a:pPr>
               <a:spcAft>
-                <a:spcPts val="400"/>
+                <a:spcPts val="300"/>
               </a:spcAft>
-              <a:defRPr sz="1150">
+              <a:defRPr sz="1100">
                 <a:solidFill>
                   <a:srgbClr val="1E293B"/>
                 </a:solidFill>
@@ -9445,9 +9337,9 @@
           <a:p>
             <a:pPr>
               <a:spcAft>
-                <a:spcPts val="400"/>
+                <a:spcPts val="300"/>
               </a:spcAft>
-              <a:defRPr sz="1150">
+              <a:defRPr sz="1100">
                 <a:solidFill>
                   <a:srgbClr val="1E293B"/>
                 </a:solidFill>
@@ -9460,9 +9352,9 @@
           <a:p>
             <a:pPr>
               <a:spcAft>
-                <a:spcPts val="400"/>
+                <a:spcPts val="300"/>
               </a:spcAft>
-              <a:defRPr sz="1150">
+              <a:defRPr sz="1100">
                 <a:solidFill>
                   <a:srgbClr val="1E293B"/>
                 </a:solidFill>
@@ -9476,9 +9368,9 @@
             <a:br/>
             <a:pPr>
               <a:spcAft>
-                <a:spcPts val="400"/>
+                <a:spcPts val="300"/>
               </a:spcAft>
-              <a:defRPr sz="1100" b="1">
+              <a:defRPr sz="1050" b="1">
                 <a:solidFill>
                   <a:srgbClr val="0000DC"/>
                 </a:solidFill>
@@ -9748,7 +9640,7 @@
               </a:defRPr>
             </a:pPr>
             <a:r>
-              <a:t>  1. Substrate Luminance Classification</a:t>
+              <a:t>  1. Substrate Luminance Classification (I -&gt; L_border)</a:t>
             </a:r>
           </a:p>
         </p:txBody>
@@ -9777,9 +9669,9 @@
           <a:p>
             <a:pPr>
               <a:spcAft>
-                <a:spcPts val="400"/>
+                <a:spcPts val="300"/>
               </a:spcAft>
-              <a:defRPr sz="1150">
+              <a:defRPr sz="1100">
                 <a:solidFill>
                   <a:srgbClr val="1E293B"/>
                 </a:solidFill>
@@ -9792,9 +9684,9 @@
           <a:p>
             <a:pPr>
               <a:spcAft>
-                <a:spcPts val="400"/>
+                <a:spcPts val="300"/>
               </a:spcAft>
-              <a:defRPr sz="1150">
+              <a:defRPr sz="1100">
                 <a:solidFill>
                   <a:srgbClr val="1E293B"/>
                 </a:solidFill>
@@ -9807,9 +9699,9 @@
           <a:p>
             <a:pPr>
               <a:spcAft>
-                <a:spcPts val="400"/>
+                <a:spcPts val="300"/>
               </a:spcAft>
-              <a:defRPr sz="1150">
+              <a:defRPr sz="1100">
                 <a:solidFill>
                   <a:srgbClr val="1E293B"/>
                 </a:solidFill>
@@ -9823,9 +9715,9 @@
             <a:br/>
             <a:pPr>
               <a:spcAft>
-                <a:spcPts val="400"/>
+                <a:spcPts val="300"/>
               </a:spcAft>
-              <a:defRPr sz="1100" b="1">
+              <a:defRPr sz="1050" b="1">
                 <a:solidFill>
                   <a:srgbClr val="0000DC"/>
                 </a:solidFill>
@@ -9933,7 +9825,7 @@
               </a:defRPr>
             </a:pPr>
             <a:r>
-              <a:t>  2. Adaptive Cluster Objectives</a:t>
+              <a:t>  2. Adaptive Cluster Objectives (Z -&gt; M_text)</a:t>
             </a:r>
           </a:p>
         </p:txBody>
@@ -9962,9 +9854,9 @@
           <a:p>
             <a:pPr>
               <a:spcAft>
-                <a:spcPts val="400"/>
+                <a:spcPts val="300"/>
               </a:spcAft>
-              <a:defRPr sz="1150">
+              <a:defRPr sz="1100">
                 <a:solidFill>
                   <a:srgbClr val="1E293B"/>
                 </a:solidFill>
@@ -9977,9 +9869,9 @@
           <a:p>
             <a:pPr>
               <a:spcAft>
-                <a:spcPts val="400"/>
+                <a:spcPts val="300"/>
               </a:spcAft>
-              <a:defRPr sz="1150">
+              <a:defRPr sz="1100">
                 <a:solidFill>
                   <a:srgbClr val="1E293B"/>
                 </a:solidFill>
@@ -9992,9 +9884,9 @@
           <a:p>
             <a:pPr>
               <a:spcAft>
-                <a:spcPts val="400"/>
+                <a:spcPts val="300"/>
               </a:spcAft>
-              <a:defRPr sz="1150">
+              <a:defRPr sz="1100">
                 <a:solidFill>
                   <a:srgbClr val="1E293B"/>
                 </a:solidFill>
@@ -10008,9 +9900,9 @@
             <a:br/>
             <a:pPr>
               <a:spcAft>
-                <a:spcPts val="400"/>
+                <a:spcPts val="300"/>
               </a:spcAft>
-              <a:defRPr sz="1100" b="1">
+              <a:defRPr sz="1050" b="1">
                 <a:solidFill>
                   <a:srgbClr val="0000DC"/>
                 </a:solidFill>
@@ -10148,7 +10040,7 @@
               </a:defRPr>
             </a:pPr>
             <a:r>
-              <a:t>Stage 1: Column Parsing &amp; Illustration Discrimination</a:t>
+              <a:t>Stage 1: 6-Channel nnU-Net Deep Semantic Segmentation</a:t>
             </a:r>
           </a:p>
         </p:txBody>
@@ -10183,7 +10075,7 @@
               </a:defRPr>
             </a:pPr>
             <a:r>
-              <a:t>Vertical Projection Gutters and Spatial Density Metrics</a:t>
+              <a:t>Feature Propagation, Instance Normalization, and Multi-Scale Focal-Dice Loss</a:t>
             </a:r>
           </a:p>
         </p:txBody>
@@ -10280,7 +10172,7 @@
               </a:defRPr>
             </a:pPr>
             <a:r>
-              <a:t>  1. Inter-Column Gutter Detection</a:t>
+              <a:t>  Feature Propagation &amp; Instance Normalization</a:t>
             </a:r>
           </a:p>
         </p:txBody>
@@ -10309,66 +10201,85 @@
           <a:p>
             <a:pPr>
               <a:spcAft>
-                <a:spcPts val="400"/>
+                <a:spcPts val="300"/>
               </a:spcAft>
-              <a:defRPr sz="1150">
+              <a:defRPr sz="1100">
                 <a:solidFill>
                   <a:srgbClr val="1E293B"/>
                 </a:solidFill>
               </a:defRPr>
             </a:pPr>
             <a:r>
-              <a:t>• Vertical projection V(x) across bounding region R.</a:t>
+              <a:t>• 5-level U-Net topology with strided convolutions (stride=2).</a:t>
             </a:r>
           </a:p>
           <a:p>
             <a:pPr>
               <a:spcAft>
-                <a:spcPts val="400"/>
+                <a:spcPts val="300"/>
               </a:spcAft>
-              <a:defRPr sz="1150">
+              <a:defRPr sz="1100">
                 <a:solidFill>
                   <a:srgbClr val="1E293B"/>
                 </a:solidFill>
               </a:defRPr>
             </a:pPr>
             <a:r>
-              <a:t>• Gutter condition over continuous gap length:</a:t>
+              <a:t>• Instance Normalization normalizes per-image across (H, W):</a:t>
             </a:r>
           </a:p>
           <a:p>
             <a:pPr>
               <a:spcAft>
-                <a:spcPts val="400"/>
+                <a:spcPts val="300"/>
               </a:spcAft>
-              <a:defRPr sz="1150">
+              <a:defRPr sz="1100">
                 <a:solidFill>
                   <a:srgbClr val="1E293B"/>
                 </a:solidFill>
               </a:defRPr>
             </a:pPr>
             <a:r>
-              <a:t>• Partitions multi-column commentaries (Shloka vs Tika).</a:t>
+              <a:t>• 6 Semantic Target Channels:</a:t>
+            </a:r>
+          </a:p>
+          <a:p>
+            <a:pPr>
+              <a:spcAft>
+                <a:spcPts val="300"/>
+              </a:spcAft>
+              <a:defRPr sz="1100">
+                <a:solidFill>
+                  <a:srgbClr val="1E293B"/>
+                </a:solidFill>
+              </a:defRPr>
+            </a:pPr>
+            <a:r>
+              <a:t>•   TextRegion, Marginalia, GraphicRegion, PageFrame, Damage, TextLine.</a:t>
             </a:r>
           </a:p>
           <a:p>
             <a:br/>
             <a:pPr>
               <a:spcAft>
-                <a:spcPts val="400"/>
+                <a:spcPts val="300"/>
               </a:spcAft>
-              <a:defRPr sz="1100" b="1">
+              <a:defRPr sz="1050" b="1">
                 <a:solidFill>
                   <a:srgbClr val="0000DC"/>
                 </a:solidFill>
               </a:defRPr>
             </a:pPr>
             <a:r>
-              <a:t>V_norm(x) = (V * G_{sigma_c})(x) / max(V * G_{sigma_c}) &lt; 0.02</a:t>
+              <a:t>x^(l) = LeakyReLU( IN( W_2 * LeakyReLU( IN( W_1 * x^(l-1) ) ) ) )</a:t>
             </a:r>
             <a:br/>
             <a:r>
-              <a:t>for gap length Delta x &gt; W_R / 15.</a:t>
+              <a:t>IN(v) = gamma · ((v - mu(v)) / sqrt(sigma^2(v) + eps)) + beta</a:t>
+            </a:r>
+            <a:br/>
+            <a:r>
+              <a:t>mu(v) = (1/HW) Sum v_{i,j},   sigma^2(v) = (1/HW) Sum (v_{i,j}-mu)^2</a:t>
             </a:r>
           </a:p>
         </p:txBody>
@@ -10465,7 +10376,7 @@
               </a:defRPr>
             </a:pPr>
             <a:r>
-              <a:t>  2. GraphicRegion Illustration Filter</a:t>
+              <a:t>  Multi-Scale Deep Supervision Compound Loss</a:t>
             </a:r>
           </a:p>
         </p:txBody>
@@ -10494,66 +10405,74 @@
           <a:p>
             <a:pPr>
               <a:spcAft>
-                <a:spcPts val="400"/>
+                <a:spcPts val="300"/>
               </a:spcAft>
-              <a:defRPr sz="1150">
+              <a:defRPr sz="1100">
                 <a:solidFill>
                   <a:srgbClr val="1E293B"/>
                 </a:solidFill>
               </a:defRPr>
             </a:pPr>
             <a:r>
-              <a:t>• Evaluates ink density rho_ink and valley frequency nu_valley:</a:t>
+              <a:t>• Supervised across 3 decoder scales (512, 256, 128) with weights w = [1.0, 0.5, 0.25]:</a:t>
             </a:r>
           </a:p>
           <a:p>
             <a:pPr>
               <a:spcAft>
-                <a:spcPts val="400"/>
+                <a:spcPts val="300"/>
               </a:spcAft>
-              <a:defRPr sz="1150">
+              <a:defRPr sz="1100">
                 <a:solidFill>
                   <a:srgbClr val="1E293B"/>
                 </a:solidFill>
               </a:defRPr>
             </a:pPr>
             <a:r>
-              <a:t>• Prevents OCR engine from running over woodblock drawings.</a:t>
+              <a:t>• 6-Channel Softmax posterior:</a:t>
             </a:r>
           </a:p>
           <a:p>
             <a:pPr>
               <a:spcAft>
-                <a:spcPts val="400"/>
+                <a:spcPts val="300"/>
               </a:spcAft>
-              <a:defRPr sz="1150">
+              <a:defRPr sz="1100">
                 <a:solidFill>
                   <a:srgbClr val="1E293B"/>
                 </a:solidFill>
               </a:defRPr>
             </a:pPr>
             <a:r>
-              <a:t>• Discrimination rule:</a:t>
+              <a:t>• Compound Focal-Dice Loss formulation:</a:t>
             </a:r>
           </a:p>
           <a:p>
             <a:br/>
             <a:pPr>
               <a:spcAft>
-                <a:spcPts val="400"/>
+                <a:spcPts val="300"/>
               </a:spcAft>
-              <a:defRPr sz="1100" b="1">
+              <a:defRPr sz="1050" b="1">
                 <a:solidFill>
                   <a:srgbClr val="0000DC"/>
                 </a:solidFill>
               </a:defRPr>
             </a:pPr>
             <a:r>
-              <a:t>rho_ink = (1 / HW) Sum B(y,x),   nu_valley = N_valleys / (H/100)</a:t>
+              <a:t>P(C=c|x,y) = exp(z_c) / Sum_{k=1}^6 exp(z_k)</a:t>
             </a:r>
             <a:br/>
             <a:r>
-              <a:t>Classified as GraphicRegion if (rho_ink &gt; 0.30 and nu &lt; 1.5).</a:t>
+              <a:t>L_total = Sum_{s=0}^2 w_s [ lambda_1·L_Focal(s) + lambda_2·L_Dice(s) ]</a:t>
+            </a:r>
+            <a:br/>
+            <a:r>
+              <a:t>L_Focal = -(1/N) Sum alpha_t (1-p_t)^gamma log(p_t)</a:t>
+            </a:r>
+            <a:br/>
+            <a:r>
+              <a:t>L_Dice = 1 - (2·Sum p_t·y_t + eps) / (Sum p_t^2 + Sum y_t^2 + eps)</a:t>
             </a:r>
           </a:p>
         </p:txBody>
@@ -10676,7 +10595,7 @@
               </a:defRPr>
             </a:pPr>
             <a:r>
-              <a:t>Stage 1: 6-Channel Deep Semantic Segmentation</a:t>
+              <a:t>Stage 1: Multi-Column Parsing &amp; Graphic Discrimination</a:t>
             </a:r>
           </a:p>
         </p:txBody>
@@ -10711,7 +10630,7 @@
               </a:defRPr>
             </a:pPr>
             <a:r>
-              <a:t>Instance Normalization and Multi-Scale Focal-Dice Supervision</a:t>
+              <a:t>Vertical Projection Gutters and Spatial Density Metrics</a:t>
             </a:r>
           </a:p>
         </p:txBody>
@@ -10808,7 +10727,7 @@
               </a:defRPr>
             </a:pPr>
             <a:r>
-              <a:t>  Feature Propagation &amp; InstanceNorm</a:t>
+              <a:t>  1. Inter-Column Gutter Detection (R_text -&gt; {C_1..C_k})</a:t>
             </a:r>
           </a:p>
         </p:txBody>
@@ -10837,81 +10756,70 @@
           <a:p>
             <a:pPr>
               <a:spcAft>
-                <a:spcPts val="400"/>
+                <a:spcPts val="300"/>
               </a:spcAft>
-              <a:defRPr sz="1150">
+              <a:defRPr sz="1100">
                 <a:solidFill>
                   <a:srgbClr val="1E293B"/>
                 </a:solidFill>
               </a:defRPr>
             </a:pPr>
             <a:r>
-              <a:t>• 5-level U-Net topology with strided convolutions (stride=2).</a:t>
+              <a:t>• Vertical projection V(x) across bounding region R.</a:t>
             </a:r>
           </a:p>
           <a:p>
             <a:pPr>
               <a:spcAft>
-                <a:spcPts val="400"/>
+                <a:spcPts val="300"/>
               </a:spcAft>
-              <a:defRPr sz="1150">
+              <a:defRPr sz="1100">
                 <a:solidFill>
                   <a:srgbClr val="1E293B"/>
                 </a:solidFill>
               </a:defRPr>
             </a:pPr>
             <a:r>
-              <a:t>• Instance Normalization prevents batch-size scaling artifacts:</a:t>
+              <a:t>• Gutter condition over continuous gap length:</a:t>
             </a:r>
           </a:p>
           <a:p>
             <a:pPr>
               <a:spcAft>
-                <a:spcPts val="400"/>
+                <a:spcPts val="300"/>
               </a:spcAft>
-              <a:defRPr sz="1150">
+              <a:defRPr sz="1100">
                 <a:solidFill>
                   <a:srgbClr val="1E293B"/>
                 </a:solidFill>
               </a:defRPr>
             </a:pPr>
             <a:r>
-              <a:t>• 6 Semantic Target Channels:</a:t>
-            </a:r>
-          </a:p>
-          <a:p>
+              <a:t>• Partitions multi-column commentaries (Shloka vs Tika).</a:t>
+            </a:r>
+          </a:p>
+          <a:p>
+            <a:br/>
             <a:pPr>
               <a:spcAft>
-                <a:spcPts val="400"/>
+                <a:spcPts val="300"/>
               </a:spcAft>
-              <a:defRPr sz="1150">
-                <a:solidFill>
-                  <a:srgbClr val="1E293B"/>
-                </a:solidFill>
-              </a:defRPr>
-            </a:pPr>
-            <a:r>
-              <a:t>•   TextRegion, Marginalia, GraphicRegion, PageFrame, Damage, TextLine.</a:t>
-            </a:r>
-          </a:p>
-          <a:p>
+              <a:defRPr sz="1050" b="1">
+                <a:solidFill>
+                  <a:srgbClr val="0000DC"/>
+                </a:solidFill>
+              </a:defRPr>
+            </a:pPr>
+            <a:r>
+              <a:t>V_norm(x) = (V * G_{sigma_c})(x) / max(V * G_{sigma_c}) &lt; 0.02</a:t>
+            </a:r>
             <a:br/>
-            <a:pPr>
-              <a:spcAft>
-                <a:spcPts val="400"/>
-              </a:spcAft>
-              <a:defRPr sz="1100" b="1">
-                <a:solidFill>
-                  <a:srgbClr val="0000DC"/>
-                </a:solidFill>
-              </a:defRPr>
-            </a:pPr>
-            <a:r>
-              <a:t>x^(l) = LeakyReLU( IN( W_2 * LeakyReLU( IN( W_1 * x^(l-1) ) ) ) )</a:t>
+            <a:r>
+              <a:t>for gap length Delta x &gt; W_R / 15.</a:t>
             </a:r>
             <a:br/>
             <a:r>
-              <a:t>IN(x) = gamma · ((x - mu(x)) / sqrt(sigma^2(x) + eps)) + beta</a:t>
+              <a:t>Reading order: C_1 &lt; C_2 &lt; ... &lt; C_k.</a:t>
             </a:r>
           </a:p>
         </p:txBody>
@@ -11008,7 +10916,7 @@
               </a:defRPr>
             </a:pPr>
             <a:r>
-              <a:t>  Multi-Scale Focal-Dice Compound Loss</a:t>
+              <a:t>  2. GraphicRegion Illustration Filter</a:t>
             </a:r>
           </a:p>
         </p:txBody>
@@ -11037,70 +10945,66 @@
           <a:p>
             <a:pPr>
               <a:spcAft>
-                <a:spcPts val="400"/>
+                <a:spcPts val="300"/>
               </a:spcAft>
-              <a:defRPr sz="1150">
+              <a:defRPr sz="1100">
                 <a:solidFill>
                   <a:srgbClr val="1E293B"/>
                 </a:solidFill>
               </a:defRPr>
             </a:pPr>
             <a:r>
-              <a:t>• Supervised across 3 decoder scales (512, 256, 128) with weights w = [1.0, 0.5, 0.25]:</a:t>
+              <a:t>• Evaluates ink density rho_ink and valley frequency nu_valley:</a:t>
             </a:r>
           </a:p>
           <a:p>
             <a:pPr>
               <a:spcAft>
-                <a:spcPts val="400"/>
+                <a:spcPts val="300"/>
               </a:spcAft>
-              <a:defRPr sz="1150">
+              <a:defRPr sz="1100">
                 <a:solidFill>
                   <a:srgbClr val="1E293B"/>
                 </a:solidFill>
               </a:defRPr>
             </a:pPr>
             <a:r>
-              <a:t>• Focal Loss downweights easy background pixels:</a:t>
+              <a:t>• Prevents OCR engine from running over woodblock drawings.</a:t>
             </a:r>
           </a:p>
           <a:p>
             <a:pPr>
               <a:spcAft>
-                <a:spcPts val="400"/>
+                <a:spcPts val="300"/>
               </a:spcAft>
-              <a:defRPr sz="1150">
+              <a:defRPr sz="1100">
                 <a:solidFill>
                   <a:srgbClr val="1E293B"/>
                 </a:solidFill>
               </a:defRPr>
             </a:pPr>
             <a:r>
-              <a:t>• Dice Loss optimizes boundary IoU directly:</a:t>
+              <a:t>• Discrimination rule:</a:t>
             </a:r>
           </a:p>
           <a:p>
             <a:br/>
             <a:pPr>
               <a:spcAft>
-                <a:spcPts val="400"/>
+                <a:spcPts val="300"/>
               </a:spcAft>
-              <a:defRPr sz="1100" b="1">
+              <a:defRPr sz="1050" b="1">
                 <a:solidFill>
                   <a:srgbClr val="0000DC"/>
                 </a:solidFill>
               </a:defRPr>
             </a:pPr>
             <a:r>
-              <a:t>L_total = Sum_{s=0}^2 w_s [ lambda_1·L_Focal(s) + lambda_2·L_Dice(s) ]</a:t>
+              <a:t>rho_ink = (1 / HW) Sum B(y,x),   nu_valley = N_valleys / (H/100)</a:t>
             </a:r>
             <a:br/>
             <a:r>
-              <a:t>L_Focal = -(1/N) Sum alpha_t (1-p_t)^gamma log(p_t)</a:t>
-            </a:r>
-            <a:br/>
-            <a:r>
-              <a:t>L_Dice = 1 - (2·Sum p_t·y_t + eps) / (Sum p_t^2 + Sum y_t^2 + eps)</a:t>
+              <a:t>Classified as GraphicRegion if (rho_ink &gt; 0.30 and nu &lt; 1.5).</a:t>
             </a:r>
           </a:p>
         </p:txBody>

</xml_diff>